<commit_message>
v0.1.3 Working on `Thermal Management` docs.
</commit_message>
<xml_diff>
--- a/.assets/diagrams.pptx
+++ b/.assets/diagrams.pptx
@@ -201,7 +201,7 @@
           <a:p>
             <a:fld id="{3709B85E-FD1D-4C87-B36A-F5C287A24482}" type="datetimeFigureOut">
               <a:rPr lang="en-US" smtClean="0"/>
-              <a:t>7/24/2025</a:t>
+              <a:t>7/25/2025</a:t>
             </a:fld>
             <a:endParaRPr lang="en-US"/>
           </a:p>
@@ -699,7 +699,7 @@
           <a:p>
             <a:fld id="{67C30635-7F4C-458C-AB0B-9951B311FD29}" type="datetimeFigureOut">
               <a:rPr lang="en-US" smtClean="0"/>
-              <a:t>7/24/2025</a:t>
+              <a:t>7/25/2025</a:t>
             </a:fld>
             <a:endParaRPr lang="en-US"/>
           </a:p>
@@ -897,7 +897,7 @@
           <a:p>
             <a:fld id="{67C30635-7F4C-458C-AB0B-9951B311FD29}" type="datetimeFigureOut">
               <a:rPr lang="en-US" smtClean="0"/>
-              <a:t>7/24/2025</a:t>
+              <a:t>7/25/2025</a:t>
             </a:fld>
             <a:endParaRPr lang="en-US"/>
           </a:p>
@@ -1105,7 +1105,7 @@
           <a:p>
             <a:fld id="{67C30635-7F4C-458C-AB0B-9951B311FD29}" type="datetimeFigureOut">
               <a:rPr lang="en-US" smtClean="0"/>
-              <a:t>7/24/2025</a:t>
+              <a:t>7/25/2025</a:t>
             </a:fld>
             <a:endParaRPr lang="en-US"/>
           </a:p>
@@ -1303,7 +1303,7 @@
           <a:p>
             <a:fld id="{67C30635-7F4C-458C-AB0B-9951B311FD29}" type="datetimeFigureOut">
               <a:rPr lang="en-US" smtClean="0"/>
-              <a:t>7/24/2025</a:t>
+              <a:t>7/25/2025</a:t>
             </a:fld>
             <a:endParaRPr lang="en-US"/>
           </a:p>
@@ -1578,7 +1578,7 @@
           <a:p>
             <a:fld id="{67C30635-7F4C-458C-AB0B-9951B311FD29}" type="datetimeFigureOut">
               <a:rPr lang="en-US" smtClean="0"/>
-              <a:t>7/24/2025</a:t>
+              <a:t>7/25/2025</a:t>
             </a:fld>
             <a:endParaRPr lang="en-US"/>
           </a:p>
@@ -1843,7 +1843,7 @@
           <a:p>
             <a:fld id="{67C30635-7F4C-458C-AB0B-9951B311FD29}" type="datetimeFigureOut">
               <a:rPr lang="en-US" smtClean="0"/>
-              <a:t>7/24/2025</a:t>
+              <a:t>7/25/2025</a:t>
             </a:fld>
             <a:endParaRPr lang="en-US"/>
           </a:p>
@@ -2255,7 +2255,7 @@
           <a:p>
             <a:fld id="{67C30635-7F4C-458C-AB0B-9951B311FD29}" type="datetimeFigureOut">
               <a:rPr lang="en-US" smtClean="0"/>
-              <a:t>7/24/2025</a:t>
+              <a:t>7/25/2025</a:t>
             </a:fld>
             <a:endParaRPr lang="en-US"/>
           </a:p>
@@ -2396,7 +2396,7 @@
           <a:p>
             <a:fld id="{67C30635-7F4C-458C-AB0B-9951B311FD29}" type="datetimeFigureOut">
               <a:rPr lang="en-US" smtClean="0"/>
-              <a:t>7/24/2025</a:t>
+              <a:t>7/25/2025</a:t>
             </a:fld>
             <a:endParaRPr lang="en-US"/>
           </a:p>
@@ -2509,7 +2509,7 @@
           <a:p>
             <a:fld id="{67C30635-7F4C-458C-AB0B-9951B311FD29}" type="datetimeFigureOut">
               <a:rPr lang="en-US" smtClean="0"/>
-              <a:t>7/24/2025</a:t>
+              <a:t>7/25/2025</a:t>
             </a:fld>
             <a:endParaRPr lang="en-US"/>
           </a:p>
@@ -2820,7 +2820,7 @@
           <a:p>
             <a:fld id="{67C30635-7F4C-458C-AB0B-9951B311FD29}" type="datetimeFigureOut">
               <a:rPr lang="en-US" smtClean="0"/>
-              <a:t>7/24/2025</a:t>
+              <a:t>7/25/2025</a:t>
             </a:fld>
             <a:endParaRPr lang="en-US"/>
           </a:p>
@@ -3108,7 +3108,7 @@
           <a:p>
             <a:fld id="{67C30635-7F4C-458C-AB0B-9951B311FD29}" type="datetimeFigureOut">
               <a:rPr lang="en-US" smtClean="0"/>
-              <a:t>7/24/2025</a:t>
+              <a:t>7/25/2025</a:t>
             </a:fld>
             <a:endParaRPr lang="en-US"/>
           </a:p>
@@ -3352,7 +3352,7 @@
           <a:p>
             <a:fld id="{67C30635-7F4C-458C-AB0B-9951B311FD29}" type="datetimeFigureOut">
               <a:rPr lang="en-US" smtClean="0"/>
-              <a:t>7/24/2025</a:t>
+              <a:t>7/25/2025</a:t>
             </a:fld>
             <a:endParaRPr lang="en-US"/>
           </a:p>
@@ -4950,12 +4950,73 @@
           <a:chExt cx="0" cy="0"/>
         </a:xfrm>
       </p:grpSpPr>
+      <p:sp>
+        <p:nvSpPr>
+          <p:cNvPr id="8" name="Rectangle 7">
+            <a:extLst>
+              <a:ext uri="{FF2B5EF4-FFF2-40B4-BE49-F238E27FC236}">
+                <a16:creationId xmlns:a16="http://schemas.microsoft.com/office/drawing/2014/main" id="{EDC66077-2095-BE17-64BB-49727395C2C3}"/>
+              </a:ext>
+            </a:extLst>
+          </p:cNvPr>
+          <p:cNvSpPr/>
+          <p:nvPr/>
+        </p:nvSpPr>
+        <p:spPr>
+          <a:xfrm>
+            <a:off x="1235460" y="152636"/>
+            <a:ext cx="5868652" cy="6120680"/>
+          </a:xfrm>
+          <a:prstGeom prst="rect">
+            <a:avLst/>
+          </a:prstGeom>
+          <a:solidFill>
+            <a:srgbClr val="F5F4EF"/>
+          </a:solidFill>
+          <a:ln w="19050">
+            <a:solidFill>
+              <a:srgbClr val="840000"/>
+            </a:solidFill>
+          </a:ln>
+        </p:spPr>
+        <p:style>
+          <a:lnRef idx="2">
+            <a:schemeClr val="accent1">
+              <a:shade val="15000"/>
+            </a:schemeClr>
+          </a:lnRef>
+          <a:fillRef idx="1">
+            <a:schemeClr val="accent1"/>
+          </a:fillRef>
+          <a:effectRef idx="0">
+            <a:schemeClr val="accent1"/>
+          </a:effectRef>
+          <a:fontRef idx="minor">
+            <a:schemeClr val="lt1"/>
+          </a:fontRef>
+        </p:style>
+        <p:txBody>
+          <a:bodyPr rtlCol="0" anchor="ctr"/>
+          <a:lstStyle/>
+          <a:p>
+            <a:pPr algn="ctr"/>
+            <a:endParaRPr lang="en-US">
+              <a:solidFill>
+                <a:schemeClr val="tx1">
+                  <a:lumMod val="75000"/>
+                  <a:lumOff val="25000"/>
+                </a:schemeClr>
+              </a:solidFill>
+            </a:endParaRPr>
+          </a:p>
+        </p:txBody>
+      </p:sp>
       <p:pic>
         <p:nvPicPr>
-          <p:cNvPr id="4" name="Picture 3">
-            <a:extLst>
-              <a:ext uri="{FF2B5EF4-FFF2-40B4-BE49-F238E27FC236}">
-                <a16:creationId xmlns:a16="http://schemas.microsoft.com/office/drawing/2014/main" id="{27256785-FED5-E973-7337-B68FC03405BE}"/>
+          <p:cNvPr id="7" name="Picture 6">
+            <a:extLst>
+              <a:ext uri="{FF2B5EF4-FFF2-40B4-BE49-F238E27FC236}">
+                <a16:creationId xmlns:a16="http://schemas.microsoft.com/office/drawing/2014/main" id="{8CBD6B5A-4076-E3F8-964D-4AACE8EAD835}"/>
               </a:ext>
             </a:extLst>
           </p:cNvPr>
@@ -4965,17 +5026,15 @@
           <p:nvPr/>
         </p:nvPicPr>
         <p:blipFill>
-          <a:blip r:embed="rId2">
-            <a:grayscl/>
-          </a:blip>
+          <a:blip r:embed="rId2"/>
           <a:stretch>
             <a:fillRect/>
           </a:stretch>
         </p:blipFill>
         <p:spPr>
           <a:xfrm>
-            <a:off x="1711746" y="404664"/>
-            <a:ext cx="4961564" cy="4968552"/>
+            <a:off x="1713729" y="404664"/>
+            <a:ext cx="5024144" cy="4968552"/>
           </a:xfrm>
           <a:prstGeom prst="rect">
             <a:avLst/>
@@ -5091,7 +5150,7 @@
           </a:custGeom>
           <a:solidFill>
             <a:srgbClr val="B1B100">
-              <a:alpha val="85098"/>
+              <a:alpha val="89804"/>
             </a:srgbClr>
           </a:solidFill>
           <a:ln w="19050">
@@ -5154,7 +5213,7 @@
           </a:prstGeom>
           <a:solidFill>
             <a:srgbClr val="A20000">
-              <a:alpha val="74902"/>
+              <a:alpha val="89804"/>
             </a:srgbClr>
           </a:solidFill>
           <a:ln w="19050">
@@ -5309,7 +5368,7 @@
           </a:prstGeom>
           <a:solidFill>
             <a:srgbClr val="215F9A">
-              <a:alpha val="74902"/>
+              <a:alpha val="89804"/>
             </a:srgbClr>
           </a:solidFill>
           <a:ln w="19050">
@@ -5424,7 +5483,7 @@
           </a:prstGeom>
           <a:solidFill>
             <a:srgbClr val="CC00CC">
-              <a:alpha val="74902"/>
+              <a:alpha val="89804"/>
             </a:srgbClr>
           </a:solidFill>
           <a:ln w="19050">
@@ -5537,10 +5596,9 @@
             <a:avLst/>
           </a:prstGeom>
           <a:solidFill>
-            <a:schemeClr val="accent2">
-              <a:lumMod val="75000"/>
-              <a:alpha val="74902"/>
-            </a:schemeClr>
+            <a:srgbClr val="C04F15">
+              <a:alpha val="89804"/>
+            </a:srgbClr>
           </a:solidFill>
           <a:ln w="19050">
             <a:solidFill>
@@ -5652,10 +5710,9 @@
             <a:avLst/>
           </a:prstGeom>
           <a:solidFill>
-            <a:schemeClr val="accent6">
-              <a:lumMod val="75000"/>
-              <a:alpha val="74902"/>
-            </a:schemeClr>
+            <a:srgbClr val="3B7D23">
+              <a:alpha val="89804"/>
+            </a:srgbClr>
           </a:solidFill>
           <a:ln w="19050">
             <a:solidFill>
@@ -5770,7 +5827,7 @@
           </a:prstGeom>
           <a:solidFill>
             <a:srgbClr val="11838F">
-              <a:alpha val="74902"/>
+              <a:alpha val="89804"/>
             </a:srgbClr>
           </a:solidFill>
           <a:ln w="19050">
@@ -5882,7 +5939,7 @@
           </a:prstGeom>
           <a:solidFill>
             <a:srgbClr val="D1D1D1">
-              <a:alpha val="76078"/>
+              <a:alpha val="89804"/>
             </a:srgbClr>
           </a:solidFill>
           <a:ln w="19050">
@@ -6068,12 +6125,73 @@
           <a:chExt cx="0" cy="0"/>
         </a:xfrm>
       </p:grpSpPr>
+      <p:sp>
+        <p:nvSpPr>
+          <p:cNvPr id="6" name="Rectangle 5">
+            <a:extLst>
+              <a:ext uri="{FF2B5EF4-FFF2-40B4-BE49-F238E27FC236}">
+                <a16:creationId xmlns:a16="http://schemas.microsoft.com/office/drawing/2014/main" id="{153F6315-E101-F542-ADAD-AF2A8B2A60B5}"/>
+              </a:ext>
+            </a:extLst>
+          </p:cNvPr>
+          <p:cNvSpPr/>
+          <p:nvPr/>
+        </p:nvSpPr>
+        <p:spPr>
+          <a:xfrm>
+            <a:off x="1235460" y="152636"/>
+            <a:ext cx="5868652" cy="6120680"/>
+          </a:xfrm>
+          <a:prstGeom prst="rect">
+            <a:avLst/>
+          </a:prstGeom>
+          <a:solidFill>
+            <a:srgbClr val="F5F4EF"/>
+          </a:solidFill>
+          <a:ln w="19050">
+            <a:solidFill>
+              <a:srgbClr val="840000"/>
+            </a:solidFill>
+          </a:ln>
+        </p:spPr>
+        <p:style>
+          <a:lnRef idx="2">
+            <a:schemeClr val="accent1">
+              <a:shade val="15000"/>
+            </a:schemeClr>
+          </a:lnRef>
+          <a:fillRef idx="1">
+            <a:schemeClr val="accent1"/>
+          </a:fillRef>
+          <a:effectRef idx="0">
+            <a:schemeClr val="accent1"/>
+          </a:effectRef>
+          <a:fontRef idx="minor">
+            <a:schemeClr val="lt1"/>
+          </a:fontRef>
+        </p:style>
+        <p:txBody>
+          <a:bodyPr rtlCol="0" anchor="ctr"/>
+          <a:lstStyle/>
+          <a:p>
+            <a:pPr algn="ctr"/>
+            <a:endParaRPr lang="en-US">
+              <a:solidFill>
+                <a:schemeClr val="tx1">
+                  <a:lumMod val="75000"/>
+                  <a:lumOff val="25000"/>
+                </a:schemeClr>
+              </a:solidFill>
+            </a:endParaRPr>
+          </a:p>
+        </p:txBody>
+      </p:sp>
       <p:pic>
         <p:nvPicPr>
-          <p:cNvPr id="4" name="Picture 3">
-            <a:extLst>
-              <a:ext uri="{FF2B5EF4-FFF2-40B4-BE49-F238E27FC236}">
-                <a16:creationId xmlns:a16="http://schemas.microsoft.com/office/drawing/2014/main" id="{AEB95030-B34C-DEC7-C4E7-D0A51F6BDF0B}"/>
+          <p:cNvPr id="5" name="Picture 4">
+            <a:extLst>
+              <a:ext uri="{FF2B5EF4-FFF2-40B4-BE49-F238E27FC236}">
+                <a16:creationId xmlns:a16="http://schemas.microsoft.com/office/drawing/2014/main" id="{C6600E61-157A-019D-0181-26A8445C4D06}"/>
               </a:ext>
             </a:extLst>
           </p:cNvPr>
@@ -6083,17 +6201,15 @@
           <p:nvPr/>
         </p:nvPicPr>
         <p:blipFill>
-          <a:blip r:embed="rId2">
-            <a:grayscl/>
-          </a:blip>
+          <a:blip r:embed="rId2"/>
           <a:stretch>
             <a:fillRect/>
           </a:stretch>
         </p:blipFill>
         <p:spPr>
           <a:xfrm>
-            <a:off x="1711746" y="404664"/>
-            <a:ext cx="4961564" cy="4968552"/>
+            <a:off x="1713729" y="404664"/>
+            <a:ext cx="5024144" cy="4968552"/>
           </a:xfrm>
           <a:prstGeom prst="rect">
             <a:avLst/>
@@ -6165,7 +6281,7 @@
           </a:prstGeom>
           <a:solidFill>
             <a:srgbClr val="A20000">
-              <a:alpha val="74902"/>
+              <a:alpha val="89804"/>
             </a:srgbClr>
           </a:solidFill>
           <a:ln w="19050">
@@ -6275,7 +6391,7 @@
           </a:prstGeom>
           <a:solidFill>
             <a:srgbClr val="11838F">
-              <a:alpha val="74902"/>
+              <a:alpha val="89804"/>
             </a:srgbClr>
           </a:solidFill>
           <a:ln w="19050">
@@ -6337,8 +6453,8 @@
             <a:avLst/>
           </a:prstGeom>
           <a:solidFill>
-            <a:srgbClr val="CC00CC">
-              <a:alpha val="76078"/>
+            <a:srgbClr val="D1D1D1">
+              <a:alpha val="89804"/>
             </a:srgbClr>
           </a:solidFill>
           <a:ln w="19050">
@@ -6414,14 +6530,18 @@
             <a:r>
               <a:rPr lang="en-US" sz="900" b="1">
                 <a:solidFill>
-                  <a:schemeClr val="bg1"/>
+                  <a:schemeClr val="bg2">
+                    <a:lumMod val="25000"/>
+                  </a:schemeClr>
                 </a:solidFill>
               </a:rPr>
               <a:t>DIGITAL Domain</a:t>
             </a:r>
             <a:endParaRPr lang="en-US" sz="900">
               <a:solidFill>
-                <a:schemeClr val="bg1"/>
+                <a:schemeClr val="bg2">
+                  <a:lumMod val="25000"/>
+                </a:schemeClr>
               </a:solidFill>
             </a:endParaRPr>
           </a:p>
@@ -6498,53 +6618,71 @@
       </p:grpSpPr>
       <p:sp>
         <p:nvSpPr>
-          <p:cNvPr id="2" name="Title 1">
-            <a:extLst>
-              <a:ext uri="{FF2B5EF4-FFF2-40B4-BE49-F238E27FC236}">
-                <a16:creationId xmlns:a16="http://schemas.microsoft.com/office/drawing/2014/main" id="{4FAD87BF-7D66-DDCA-CA69-52E1091BFA31}"/>
-              </a:ext>
-            </a:extLst>
-          </p:cNvPr>
-          <p:cNvSpPr>
-            <a:spLocks noGrp="1"/>
-          </p:cNvSpPr>
-          <p:nvPr>
-            <p:ph type="title"/>
-          </p:nvPr>
-        </p:nvSpPr>
-        <p:spPr>
-          <a:xfrm>
-            <a:off x="1343472" y="5553236"/>
-            <a:ext cx="3025552" cy="720080"/>
-          </a:xfrm>
-        </p:spPr>
-        <p:txBody>
-          <a:bodyPr vert="horz" lIns="91440" tIns="45720" rIns="91440" bIns="45720" rtlCol="0" anchor="ctr">
-            <a:normAutofit/>
-          </a:bodyPr>
-          <a:lstStyle/>
-          <a:p>
-            <a:r>
-              <a:rPr lang="en-US" sz="1800" i="1">
-                <a:solidFill>
-                  <a:schemeClr val="tx1">
-                    <a:lumMod val="65000"/>
-                    <a:lumOff val="35000"/>
-                  </a:schemeClr>
-                </a:solidFill>
-                <a:latin typeface="Eras Demi ITC" panose="020B0805030504020804" pitchFamily="34" charset="0"/>
-              </a:rPr>
-              <a:t>MDD400 Ground Planes</a:t>
-            </a:r>
+          <p:cNvPr id="4" name="Rectangle 3">
+            <a:extLst>
+              <a:ext uri="{FF2B5EF4-FFF2-40B4-BE49-F238E27FC236}">
+                <a16:creationId xmlns:a16="http://schemas.microsoft.com/office/drawing/2014/main" id="{1982F5D8-22F6-9A24-75B7-9C3A510FBCF9}"/>
+              </a:ext>
+            </a:extLst>
+          </p:cNvPr>
+          <p:cNvSpPr/>
+          <p:nvPr/>
+        </p:nvSpPr>
+        <p:spPr>
+          <a:xfrm>
+            <a:off x="1235460" y="152636"/>
+            <a:ext cx="5868652" cy="6120680"/>
+          </a:xfrm>
+          <a:prstGeom prst="rect">
+            <a:avLst/>
+          </a:prstGeom>
+          <a:solidFill>
+            <a:srgbClr val="F5F4EF"/>
+          </a:solidFill>
+          <a:ln w="19050">
+            <a:solidFill>
+              <a:srgbClr val="840000"/>
+            </a:solidFill>
+          </a:ln>
+        </p:spPr>
+        <p:style>
+          <a:lnRef idx="2">
+            <a:schemeClr val="accent1">
+              <a:shade val="15000"/>
+            </a:schemeClr>
+          </a:lnRef>
+          <a:fillRef idx="1">
+            <a:schemeClr val="accent1"/>
+          </a:fillRef>
+          <a:effectRef idx="0">
+            <a:schemeClr val="accent1"/>
+          </a:effectRef>
+          <a:fontRef idx="minor">
+            <a:schemeClr val="lt1"/>
+          </a:fontRef>
+        </p:style>
+        <p:txBody>
+          <a:bodyPr rtlCol="0" anchor="ctr"/>
+          <a:lstStyle/>
+          <a:p>
+            <a:pPr algn="ctr"/>
+            <a:endParaRPr lang="en-US">
+              <a:solidFill>
+                <a:schemeClr val="tx1">
+                  <a:lumMod val="75000"/>
+                  <a:lumOff val="25000"/>
+                </a:schemeClr>
+              </a:solidFill>
+            </a:endParaRPr>
           </a:p>
         </p:txBody>
       </p:sp>
       <p:pic>
         <p:nvPicPr>
-          <p:cNvPr id="8" name="Picture 7">
-            <a:extLst>
-              <a:ext uri="{FF2B5EF4-FFF2-40B4-BE49-F238E27FC236}">
-                <a16:creationId xmlns:a16="http://schemas.microsoft.com/office/drawing/2014/main" id="{F7E38451-BB7C-2294-2C9F-01EF5DC5F7B3}"/>
+          <p:cNvPr id="3" name="Picture 2">
+            <a:extLst>
+              <a:ext uri="{FF2B5EF4-FFF2-40B4-BE49-F238E27FC236}">
+                <a16:creationId xmlns:a16="http://schemas.microsoft.com/office/drawing/2014/main" id="{5D85245F-A629-F658-71CA-260A14D752D5}"/>
               </a:ext>
             </a:extLst>
           </p:cNvPr>
@@ -6561,14 +6699,57 @@
         </p:blipFill>
         <p:spPr>
           <a:xfrm>
-            <a:off x="1711746" y="406200"/>
-            <a:ext cx="4961564" cy="5001664"/>
+            <a:off x="1713729" y="404664"/>
+            <a:ext cx="5024144" cy="4968552"/>
           </a:xfrm>
           <a:prstGeom prst="rect">
             <a:avLst/>
           </a:prstGeom>
         </p:spPr>
       </p:pic>
+      <p:sp>
+        <p:nvSpPr>
+          <p:cNvPr id="2" name="Title 1">
+            <a:extLst>
+              <a:ext uri="{FF2B5EF4-FFF2-40B4-BE49-F238E27FC236}">
+                <a16:creationId xmlns:a16="http://schemas.microsoft.com/office/drawing/2014/main" id="{4FAD87BF-7D66-DDCA-CA69-52E1091BFA31}"/>
+              </a:ext>
+            </a:extLst>
+          </p:cNvPr>
+          <p:cNvSpPr>
+            <a:spLocks noGrp="1"/>
+          </p:cNvSpPr>
+          <p:nvPr>
+            <p:ph type="title"/>
+          </p:nvPr>
+        </p:nvSpPr>
+        <p:spPr>
+          <a:xfrm>
+            <a:off x="1343472" y="5553236"/>
+            <a:ext cx="3025552" cy="720080"/>
+          </a:xfrm>
+        </p:spPr>
+        <p:txBody>
+          <a:bodyPr vert="horz" lIns="91440" tIns="45720" rIns="91440" bIns="45720" rtlCol="0" anchor="ctr">
+            <a:normAutofit/>
+          </a:bodyPr>
+          <a:lstStyle/>
+          <a:p>
+            <a:r>
+              <a:rPr lang="en-US" sz="1800" i="1">
+                <a:solidFill>
+                  <a:schemeClr val="tx1">
+                    <a:lumMod val="65000"/>
+                    <a:lumOff val="35000"/>
+                  </a:schemeClr>
+                </a:solidFill>
+                <a:latin typeface="Eras Demi ITC" panose="020B0805030504020804" pitchFamily="34" charset="0"/>
+              </a:rPr>
+              <a:t>MDD400 Ground Planes</a:t>
+            </a:r>
+          </a:p>
+        </p:txBody>
+      </p:sp>
       <p:sp>
         <p:nvSpPr>
           <p:cNvPr id="9" name="Rectangle 8">
@@ -6591,7 +6772,7 @@
           </a:prstGeom>
           <a:solidFill>
             <a:srgbClr val="215F9A">
-              <a:alpha val="74902"/>
+              <a:alpha val="89804"/>
             </a:srgbClr>
           </a:solidFill>
           <a:ln w="19050">
@@ -6855,7 +7036,7 @@
           </a:custGeom>
           <a:solidFill>
             <a:srgbClr val="CC00CC">
-              <a:alpha val="74902"/>
+              <a:alpha val="89804"/>
             </a:srgbClr>
           </a:solidFill>
           <a:ln w="19050">
@@ -7052,7 +7233,7 @@
           </a:custGeom>
           <a:solidFill>
             <a:srgbClr val="A20000">
-              <a:alpha val="74902"/>
+              <a:alpha val="89804"/>
             </a:srgbClr>
           </a:solidFill>
           <a:ln w="19050">
@@ -7166,7 +7347,7 @@
           </a:prstGeom>
           <a:solidFill>
             <a:srgbClr val="D1D1D1">
-              <a:alpha val="76078"/>
+              <a:alpha val="89804"/>
             </a:srgbClr>
           </a:solidFill>
           <a:ln w="19050">
@@ -7287,7 +7468,7 @@
           </a:prstGeom>
           <a:solidFill>
             <a:srgbClr val="11838F">
-              <a:alpha val="74902"/>
+              <a:alpha val="89804"/>
             </a:srgbClr>
           </a:solidFill>
           <a:ln w="19050">
@@ -7413,12 +7594,73 @@
           <a:chExt cx="0" cy="0"/>
         </a:xfrm>
       </p:grpSpPr>
+      <p:sp>
+        <p:nvSpPr>
+          <p:cNvPr id="9" name="Rectangle 8">
+            <a:extLst>
+              <a:ext uri="{FF2B5EF4-FFF2-40B4-BE49-F238E27FC236}">
+                <a16:creationId xmlns:a16="http://schemas.microsoft.com/office/drawing/2014/main" id="{BB0E54D8-B5EE-8FBC-1209-EA13E0DF5893}"/>
+              </a:ext>
+            </a:extLst>
+          </p:cNvPr>
+          <p:cNvSpPr/>
+          <p:nvPr/>
+        </p:nvSpPr>
+        <p:spPr>
+          <a:xfrm>
+            <a:off x="1235460" y="152636"/>
+            <a:ext cx="5868652" cy="6120680"/>
+          </a:xfrm>
+          <a:prstGeom prst="rect">
+            <a:avLst/>
+          </a:prstGeom>
+          <a:solidFill>
+            <a:srgbClr val="F5F4EF"/>
+          </a:solidFill>
+          <a:ln w="19050">
+            <a:solidFill>
+              <a:srgbClr val="840000"/>
+            </a:solidFill>
+          </a:ln>
+        </p:spPr>
+        <p:style>
+          <a:lnRef idx="2">
+            <a:schemeClr val="accent1">
+              <a:shade val="15000"/>
+            </a:schemeClr>
+          </a:lnRef>
+          <a:fillRef idx="1">
+            <a:schemeClr val="accent1"/>
+          </a:fillRef>
+          <a:effectRef idx="0">
+            <a:schemeClr val="accent1"/>
+          </a:effectRef>
+          <a:fontRef idx="minor">
+            <a:schemeClr val="lt1"/>
+          </a:fontRef>
+        </p:style>
+        <p:txBody>
+          <a:bodyPr rtlCol="0" anchor="ctr"/>
+          <a:lstStyle/>
+          <a:p>
+            <a:pPr algn="ctr"/>
+            <a:endParaRPr lang="en-US">
+              <a:solidFill>
+                <a:schemeClr val="tx1">
+                  <a:lumMod val="75000"/>
+                  <a:lumOff val="25000"/>
+                </a:schemeClr>
+              </a:solidFill>
+            </a:endParaRPr>
+          </a:p>
+        </p:txBody>
+      </p:sp>
       <p:pic>
         <p:nvPicPr>
-          <p:cNvPr id="4" name="Picture 3">
-            <a:extLst>
-              <a:ext uri="{FF2B5EF4-FFF2-40B4-BE49-F238E27FC236}">
-                <a16:creationId xmlns:a16="http://schemas.microsoft.com/office/drawing/2014/main" id="{6F4E78B8-888D-4FE7-8F81-39F9495D18B6}"/>
+          <p:cNvPr id="8" name="Picture 7">
+            <a:extLst>
+              <a:ext uri="{FF2B5EF4-FFF2-40B4-BE49-F238E27FC236}">
+                <a16:creationId xmlns:a16="http://schemas.microsoft.com/office/drawing/2014/main" id="{AD864FAA-C5C7-BFF4-C546-2903D586695F}"/>
               </a:ext>
             </a:extLst>
           </p:cNvPr>
@@ -7428,17 +7670,15 @@
           <p:nvPr/>
         </p:nvPicPr>
         <p:blipFill>
-          <a:blip r:embed="rId3">
-            <a:grayscl/>
-          </a:blip>
+          <a:blip r:embed="rId3"/>
           <a:stretch>
             <a:fillRect/>
           </a:stretch>
         </p:blipFill>
         <p:spPr>
           <a:xfrm>
-            <a:off x="1711746" y="412549"/>
-            <a:ext cx="4988289" cy="4995315"/>
+            <a:off x="1708137" y="412549"/>
+            <a:ext cx="4967408" cy="4995315"/>
           </a:xfrm>
           <a:prstGeom prst="rect">
             <a:avLst/>
@@ -7510,7 +7750,7 @@
           </a:prstGeom>
           <a:solidFill>
             <a:srgbClr val="CC00CC">
-              <a:alpha val="74902"/>
+              <a:alpha val="89804"/>
             </a:srgbClr>
           </a:solidFill>
           <a:ln w="19050">
@@ -7631,7 +7871,7 @@
           </a:prstGeom>
           <a:solidFill>
             <a:srgbClr val="11838F">
-              <a:alpha val="74902"/>
+              <a:alpha val="89804"/>
             </a:srgbClr>
           </a:solidFill>
           <a:ln w="19050">
@@ -7739,7 +7979,7 @@
           </a:prstGeom>
           <a:solidFill>
             <a:srgbClr val="A20000">
-              <a:alpha val="74902"/>
+              <a:alpha val="89804"/>
             </a:srgbClr>
           </a:solidFill>
           <a:ln w="19050">
@@ -7839,15 +8079,15 @@
         </p:nvSpPr>
         <p:spPr>
           <a:xfrm>
-            <a:off x="3205446" y="691222"/>
-            <a:ext cx="561712" cy="610495"/>
+            <a:off x="3206104" y="692697"/>
+            <a:ext cx="561712" cy="666074"/>
           </a:xfrm>
           <a:prstGeom prst="rect">
             <a:avLst/>
           </a:prstGeom>
           <a:solidFill>
             <a:srgbClr val="009600">
-              <a:alpha val="74902"/>
+              <a:alpha val="89804"/>
             </a:srgbClr>
           </a:solidFill>
           <a:ln w="19050">

</xml_diff>

<commit_message>
v0.1.4 New SMPS design sections.
</commit_message>
<xml_diff>
--- a/.assets/diagrams.pptx
+++ b/.assets/diagrams.pptx
@@ -5,14 +5,15 @@
     <p:sldMasterId id="2147483648" r:id="rId1"/>
   </p:sldMasterIdLst>
   <p:notesMasterIdLst>
-    <p:notesMasterId r:id="rId7"/>
+    <p:notesMasterId r:id="rId8"/>
   </p:notesMasterIdLst>
   <p:sldIdLst>
     <p:sldId id="256" r:id="rId2"/>
     <p:sldId id="257" r:id="rId3"/>
     <p:sldId id="260" r:id="rId4"/>
     <p:sldId id="258" r:id="rId5"/>
-    <p:sldId id="259" r:id="rId6"/>
+    <p:sldId id="261" r:id="rId6"/>
+    <p:sldId id="259" r:id="rId7"/>
   </p:sldIdLst>
   <p:sldSz cx="12192000" cy="6858000"/>
   <p:notesSz cx="6858000" cy="9144000"/>
@@ -201,7 +202,7 @@
           <a:p>
             <a:fld id="{3709B85E-FD1D-4C87-B36A-F5C287A24482}" type="datetimeFigureOut">
               <a:rPr lang="en-US" smtClean="0"/>
-              <a:t>7/25/2025</a:t>
+              <a:t>7/28/2025</a:t>
             </a:fld>
             <a:endParaRPr lang="en-US"/>
           </a:p>
@@ -533,7 +534,7 @@
           <a:p>
             <a:fld id="{9CD017A1-7FA2-4FB5-A9B9-704691091C1D}" type="slidenum">
               <a:rPr lang="en-US" smtClean="0"/>
-              <a:t>5</a:t>
+              <a:t>6</a:t>
             </a:fld>
             <a:endParaRPr lang="en-US"/>
           </a:p>
@@ -699,7 +700,7 @@
           <a:p>
             <a:fld id="{67C30635-7F4C-458C-AB0B-9951B311FD29}" type="datetimeFigureOut">
               <a:rPr lang="en-US" smtClean="0"/>
-              <a:t>7/25/2025</a:t>
+              <a:t>7/28/2025</a:t>
             </a:fld>
             <a:endParaRPr lang="en-US"/>
           </a:p>
@@ -897,7 +898,7 @@
           <a:p>
             <a:fld id="{67C30635-7F4C-458C-AB0B-9951B311FD29}" type="datetimeFigureOut">
               <a:rPr lang="en-US" smtClean="0"/>
-              <a:t>7/25/2025</a:t>
+              <a:t>7/28/2025</a:t>
             </a:fld>
             <a:endParaRPr lang="en-US"/>
           </a:p>
@@ -1105,7 +1106,7 @@
           <a:p>
             <a:fld id="{67C30635-7F4C-458C-AB0B-9951B311FD29}" type="datetimeFigureOut">
               <a:rPr lang="en-US" smtClean="0"/>
-              <a:t>7/25/2025</a:t>
+              <a:t>7/28/2025</a:t>
             </a:fld>
             <a:endParaRPr lang="en-US"/>
           </a:p>
@@ -1303,7 +1304,7 @@
           <a:p>
             <a:fld id="{67C30635-7F4C-458C-AB0B-9951B311FD29}" type="datetimeFigureOut">
               <a:rPr lang="en-US" smtClean="0"/>
-              <a:t>7/25/2025</a:t>
+              <a:t>7/28/2025</a:t>
             </a:fld>
             <a:endParaRPr lang="en-US"/>
           </a:p>
@@ -1578,7 +1579,7 @@
           <a:p>
             <a:fld id="{67C30635-7F4C-458C-AB0B-9951B311FD29}" type="datetimeFigureOut">
               <a:rPr lang="en-US" smtClean="0"/>
-              <a:t>7/25/2025</a:t>
+              <a:t>7/28/2025</a:t>
             </a:fld>
             <a:endParaRPr lang="en-US"/>
           </a:p>
@@ -1843,7 +1844,7 @@
           <a:p>
             <a:fld id="{67C30635-7F4C-458C-AB0B-9951B311FD29}" type="datetimeFigureOut">
               <a:rPr lang="en-US" smtClean="0"/>
-              <a:t>7/25/2025</a:t>
+              <a:t>7/28/2025</a:t>
             </a:fld>
             <a:endParaRPr lang="en-US"/>
           </a:p>
@@ -2255,7 +2256,7 @@
           <a:p>
             <a:fld id="{67C30635-7F4C-458C-AB0B-9951B311FD29}" type="datetimeFigureOut">
               <a:rPr lang="en-US" smtClean="0"/>
-              <a:t>7/25/2025</a:t>
+              <a:t>7/28/2025</a:t>
             </a:fld>
             <a:endParaRPr lang="en-US"/>
           </a:p>
@@ -2396,7 +2397,7 @@
           <a:p>
             <a:fld id="{67C30635-7F4C-458C-AB0B-9951B311FD29}" type="datetimeFigureOut">
               <a:rPr lang="en-US" smtClean="0"/>
-              <a:t>7/25/2025</a:t>
+              <a:t>7/28/2025</a:t>
             </a:fld>
             <a:endParaRPr lang="en-US"/>
           </a:p>
@@ -2509,7 +2510,7 @@
           <a:p>
             <a:fld id="{67C30635-7F4C-458C-AB0B-9951B311FD29}" type="datetimeFigureOut">
               <a:rPr lang="en-US" smtClean="0"/>
-              <a:t>7/25/2025</a:t>
+              <a:t>7/28/2025</a:t>
             </a:fld>
             <a:endParaRPr lang="en-US"/>
           </a:p>
@@ -2820,7 +2821,7 @@
           <a:p>
             <a:fld id="{67C30635-7F4C-458C-AB0B-9951B311FD29}" type="datetimeFigureOut">
               <a:rPr lang="en-US" smtClean="0"/>
-              <a:t>7/25/2025</a:t>
+              <a:t>7/28/2025</a:t>
             </a:fld>
             <a:endParaRPr lang="en-US"/>
           </a:p>
@@ -3108,7 +3109,7 @@
           <a:p>
             <a:fld id="{67C30635-7F4C-458C-AB0B-9951B311FD29}" type="datetimeFigureOut">
               <a:rPr lang="en-US" smtClean="0"/>
-              <a:t>7/25/2025</a:t>
+              <a:t>7/28/2025</a:t>
             </a:fld>
             <a:endParaRPr lang="en-US"/>
           </a:p>
@@ -3352,7 +3353,7 @@
           <a:p>
             <a:fld id="{67C30635-7F4C-458C-AB0B-9951B311FD29}" type="datetimeFigureOut">
               <a:rPr lang="en-US" smtClean="0"/>
-              <a:t>7/25/2025</a:t>
+              <a:t>7/28/2025</a:t>
             </a:fld>
             <a:endParaRPr lang="en-US"/>
           </a:p>
@@ -6602,6 +6603,14 @@
 <file path=ppt/slides/slide4.xml><?xml version="1.0" encoding="utf-8"?>
 <p:sld xmlns:a="http://schemas.openxmlformats.org/drawingml/2006/main" xmlns:r="http://schemas.openxmlformats.org/officeDocument/2006/relationships" xmlns:p="http://schemas.openxmlformats.org/presentationml/2006/main">
   <p:cSld>
+    <p:bg>
+      <p:bgPr>
+        <a:solidFill>
+          <a:srgbClr val="F5F4EF"/>
+        </a:solidFill>
+        <a:effectLst/>
+      </p:bgPr>
+    </p:bg>
     <p:spTree>
       <p:nvGrpSpPr>
         <p:cNvPr id="1" name=""/>
@@ -6679,10 +6688,10 @@
       </p:sp>
       <p:pic>
         <p:nvPicPr>
-          <p:cNvPr id="3" name="Picture 2">
-            <a:extLst>
-              <a:ext uri="{FF2B5EF4-FFF2-40B4-BE49-F238E27FC236}">
-                <a16:creationId xmlns:a16="http://schemas.microsoft.com/office/drawing/2014/main" id="{5D85245F-A629-F658-71CA-260A14D752D5}"/>
+          <p:cNvPr id="6" name="Picture 5">
+            <a:extLst>
+              <a:ext uri="{FF2B5EF4-FFF2-40B4-BE49-F238E27FC236}">
+                <a16:creationId xmlns:a16="http://schemas.microsoft.com/office/drawing/2014/main" id="{D4236495-055B-E7D5-DBF1-0253F6EC31A7}"/>
               </a:ext>
             </a:extLst>
           </p:cNvPr>
@@ -6699,8 +6708,8 @@
         </p:blipFill>
         <p:spPr>
           <a:xfrm>
-            <a:off x="1713729" y="404664"/>
-            <a:ext cx="5024144" cy="4968552"/>
+            <a:off x="1713729" y="415274"/>
+            <a:ext cx="4978943" cy="4947331"/>
           </a:xfrm>
           <a:prstGeom prst="rect">
             <a:avLst/>
@@ -6709,53 +6718,10 @@
       </p:pic>
       <p:sp>
         <p:nvSpPr>
-          <p:cNvPr id="2" name="Title 1">
-            <a:extLst>
-              <a:ext uri="{FF2B5EF4-FFF2-40B4-BE49-F238E27FC236}">
-                <a16:creationId xmlns:a16="http://schemas.microsoft.com/office/drawing/2014/main" id="{4FAD87BF-7D66-DDCA-CA69-52E1091BFA31}"/>
-              </a:ext>
-            </a:extLst>
-          </p:cNvPr>
-          <p:cNvSpPr>
-            <a:spLocks noGrp="1"/>
-          </p:cNvSpPr>
-          <p:nvPr>
-            <p:ph type="title"/>
-          </p:nvPr>
-        </p:nvSpPr>
-        <p:spPr>
-          <a:xfrm>
-            <a:off x="1343472" y="5553236"/>
-            <a:ext cx="3025552" cy="720080"/>
-          </a:xfrm>
-        </p:spPr>
-        <p:txBody>
-          <a:bodyPr vert="horz" lIns="91440" tIns="45720" rIns="91440" bIns="45720" rtlCol="0" anchor="ctr">
-            <a:normAutofit/>
-          </a:bodyPr>
-          <a:lstStyle/>
-          <a:p>
-            <a:r>
-              <a:rPr lang="en-US" sz="1800" i="1">
-                <a:solidFill>
-                  <a:schemeClr val="tx1">
-                    <a:lumMod val="65000"/>
-                    <a:lumOff val="35000"/>
-                  </a:schemeClr>
-                </a:solidFill>
-                <a:latin typeface="Eras Demi ITC" panose="020B0805030504020804" pitchFamily="34" charset="0"/>
-              </a:rPr>
-              <a:t>MDD400 Ground Planes</a:t>
-            </a:r>
-          </a:p>
-        </p:txBody>
-      </p:sp>
-      <p:sp>
-        <p:nvSpPr>
-          <p:cNvPr id="9" name="Rectangle 8">
-            <a:extLst>
-              <a:ext uri="{FF2B5EF4-FFF2-40B4-BE49-F238E27FC236}">
-                <a16:creationId xmlns:a16="http://schemas.microsoft.com/office/drawing/2014/main" id="{DD1DA1DF-1E5A-4765-6BD6-86C0A65F65A8}"/>
+          <p:cNvPr id="8" name="Rectangle 7">
+            <a:extLst>
+              <a:ext uri="{FF2B5EF4-FFF2-40B4-BE49-F238E27FC236}">
+                <a16:creationId xmlns:a16="http://schemas.microsoft.com/office/drawing/2014/main" id="{C7F3416E-B13F-002D-AD8F-4F3F29CABB22}"/>
               </a:ext>
             </a:extLst>
           </p:cNvPr>
@@ -6764,22 +6730,21 @@
         </p:nvSpPr>
         <p:spPr>
           <a:xfrm>
-            <a:off x="1811524" y="548680"/>
-            <a:ext cx="1296144" cy="1296144"/>
+            <a:off x="1883532" y="1664804"/>
+            <a:ext cx="1702405" cy="716921"/>
           </a:xfrm>
           <a:prstGeom prst="rect">
             <a:avLst/>
           </a:prstGeom>
           <a:solidFill>
-            <a:srgbClr val="215F9A">
+            <a:srgbClr val="CC00CC">
               <a:alpha val="89804"/>
             </a:srgbClr>
           </a:solidFill>
           <a:ln w="19050">
             <a:solidFill>
-              <a:schemeClr val="tx2">
-                <a:lumMod val="90000"/>
-                <a:lumOff val="10000"/>
+              <a:schemeClr val="accent5">
+                <a:lumMod val="75000"/>
               </a:schemeClr>
             </a:solidFill>
           </a:ln>
@@ -6818,59 +6783,73 @@
       </p:sp>
       <p:sp>
         <p:nvSpPr>
-          <p:cNvPr id="10" name="TextBox 9">
-            <a:extLst>
-              <a:ext uri="{FF2B5EF4-FFF2-40B4-BE49-F238E27FC236}">
-                <a16:creationId xmlns:a16="http://schemas.microsoft.com/office/drawing/2014/main" id="{EEE6DECA-8DB3-5B4B-B0A3-070A8923A565}"/>
-              </a:ext>
-            </a:extLst>
-          </p:cNvPr>
-          <p:cNvSpPr txBox="1"/>
+          <p:cNvPr id="19" name="Rectangle 18">
+            <a:extLst>
+              <a:ext uri="{FF2B5EF4-FFF2-40B4-BE49-F238E27FC236}">
+                <a16:creationId xmlns:a16="http://schemas.microsoft.com/office/drawing/2014/main" id="{E6FA95E4-96FB-9DE6-56E2-535328F856F3}"/>
+              </a:ext>
+            </a:extLst>
+          </p:cNvPr>
+          <p:cNvSpPr/>
           <p:nvPr/>
         </p:nvSpPr>
         <p:spPr>
           <a:xfrm>
-            <a:off x="1811524" y="584684"/>
-            <a:ext cx="1296144" cy="276999"/>
+            <a:off x="1883531" y="2572356"/>
+            <a:ext cx="1695853" cy="2637819"/>
           </a:xfrm>
           <a:prstGeom prst="rect">
             <a:avLst/>
           </a:prstGeom>
-          <a:noFill/>
-        </p:spPr>
-        <p:txBody>
-          <a:bodyPr wrap="square" rtlCol="0">
-            <a:spAutoFit/>
-          </a:bodyPr>
-          <a:lstStyle/>
-          <a:p>
-            <a:r>
-              <a:rPr lang="en-US" sz="600" b="1">
-                <a:solidFill>
-                  <a:schemeClr val="bg1"/>
-                </a:solidFill>
-              </a:rPr>
-              <a:t>GNDSMPS</a:t>
-            </a:r>
-          </a:p>
-          <a:p>
-            <a:r>
-              <a:rPr lang="en-US" sz="600">
-                <a:solidFill>
-                  <a:schemeClr val="bg1"/>
-                </a:solidFill>
-              </a:rPr>
-              <a:t>DC-DC Converter Ground</a:t>
-            </a:r>
-          </a:p>
-        </p:txBody>
-      </p:sp>
-      <p:sp>
-        <p:nvSpPr>
-          <p:cNvPr id="11" name="Freeform: Shape 10">
-            <a:extLst>
-              <a:ext uri="{FF2B5EF4-FFF2-40B4-BE49-F238E27FC236}">
-                <a16:creationId xmlns:a16="http://schemas.microsoft.com/office/drawing/2014/main" id="{74BD22A0-E621-03D4-9E6D-0F892FC6C1AB}"/>
+          <a:solidFill>
+            <a:srgbClr val="A20000">
+              <a:alpha val="89804"/>
+            </a:srgbClr>
+          </a:solidFill>
+          <a:ln w="19050">
+            <a:solidFill>
+              <a:srgbClr val="840000"/>
+            </a:solidFill>
+          </a:ln>
+        </p:spPr>
+        <p:style>
+          <a:lnRef idx="2">
+            <a:schemeClr val="accent1">
+              <a:shade val="15000"/>
+            </a:schemeClr>
+          </a:lnRef>
+          <a:fillRef idx="1">
+            <a:schemeClr val="accent1"/>
+          </a:fillRef>
+          <a:effectRef idx="0">
+            <a:schemeClr val="accent1"/>
+          </a:effectRef>
+          <a:fontRef idx="minor">
+            <a:schemeClr val="lt1"/>
+          </a:fontRef>
+        </p:style>
+        <p:txBody>
+          <a:bodyPr rtlCol="0" anchor="ctr"/>
+          <a:lstStyle/>
+          <a:p>
+            <a:pPr algn="ctr"/>
+            <a:endParaRPr lang="en-US">
+              <a:solidFill>
+                <a:schemeClr val="tx1">
+                  <a:lumMod val="75000"/>
+                  <a:lumOff val="25000"/>
+                </a:schemeClr>
+              </a:solidFill>
+            </a:endParaRPr>
+          </a:p>
+        </p:txBody>
+      </p:sp>
+      <p:sp>
+        <p:nvSpPr>
+          <p:cNvPr id="7" name="Freeform: Shape 6">
+            <a:extLst>
+              <a:ext uri="{FF2B5EF4-FFF2-40B4-BE49-F238E27FC236}">
+                <a16:creationId xmlns:a16="http://schemas.microsoft.com/office/drawing/2014/main" id="{7A8E8709-4FD4-A715-F9E9-110B2B820029}"/>
               </a:ext>
             </a:extLst>
           </p:cNvPr>
@@ -6879,64 +6858,114 @@
         </p:nvSpPr>
         <p:spPr>
           <a:xfrm>
-            <a:off x="1866900" y="550616"/>
-            <a:ext cx="1685925" cy="3602283"/>
+            <a:off x="3867150" y="566738"/>
+            <a:ext cx="2652713" cy="4643437"/>
           </a:xfrm>
           <a:custGeom>
             <a:avLst/>
             <a:gdLst>
-              <a:gd name="connsiteX0" fmla="*/ 1276350 w 1685925"/>
-              <a:gd name="connsiteY0" fmla="*/ 0 h 3600450"/>
-              <a:gd name="connsiteX1" fmla="*/ 1271588 w 1685925"/>
-              <a:gd name="connsiteY1" fmla="*/ 1385888 h 3600450"/>
-              <a:gd name="connsiteX2" fmla="*/ 4763 w 1685925"/>
-              <a:gd name="connsiteY2" fmla="*/ 1371600 h 3600450"/>
-              <a:gd name="connsiteX3" fmla="*/ 0 w 1685925"/>
-              <a:gd name="connsiteY3" fmla="*/ 3600450 h 3600450"/>
-              <a:gd name="connsiteX4" fmla="*/ 600075 w 1685925"/>
-              <a:gd name="connsiteY4" fmla="*/ 3586163 h 3600450"/>
-              <a:gd name="connsiteX5" fmla="*/ 619125 w 1685925"/>
-              <a:gd name="connsiteY5" fmla="*/ 2905125 h 3600450"/>
-              <a:gd name="connsiteX6" fmla="*/ 442913 w 1685925"/>
-              <a:gd name="connsiteY6" fmla="*/ 2900363 h 3600450"/>
-              <a:gd name="connsiteX7" fmla="*/ 442913 w 1685925"/>
-              <a:gd name="connsiteY7" fmla="*/ 2505075 h 3600450"/>
-              <a:gd name="connsiteX8" fmla="*/ 1171575 w 1685925"/>
-              <a:gd name="connsiteY8" fmla="*/ 2509838 h 3600450"/>
-              <a:gd name="connsiteX9" fmla="*/ 1181100 w 1685925"/>
-              <a:gd name="connsiteY9" fmla="*/ 1619250 h 3600450"/>
-              <a:gd name="connsiteX10" fmla="*/ 1681163 w 1685925"/>
-              <a:gd name="connsiteY10" fmla="*/ 1614488 h 3600450"/>
-              <a:gd name="connsiteX11" fmla="*/ 1685925 w 1685925"/>
-              <a:gd name="connsiteY11" fmla="*/ 19050 h 3600450"/>
-              <a:gd name="connsiteX12" fmla="*/ 1276350 w 1685925"/>
-              <a:gd name="connsiteY12" fmla="*/ 0 h 3600450"/>
-              <a:gd name="connsiteX0" fmla="*/ 1276350 w 1685925"/>
-              <a:gd name="connsiteY0" fmla="*/ 1833 h 3602283"/>
-              <a:gd name="connsiteX1" fmla="*/ 1271588 w 1685925"/>
-              <a:gd name="connsiteY1" fmla="*/ 1387721 h 3602283"/>
-              <a:gd name="connsiteX2" fmla="*/ 4763 w 1685925"/>
-              <a:gd name="connsiteY2" fmla="*/ 1373433 h 3602283"/>
-              <a:gd name="connsiteX3" fmla="*/ 0 w 1685925"/>
-              <a:gd name="connsiteY3" fmla="*/ 3602283 h 3602283"/>
-              <a:gd name="connsiteX4" fmla="*/ 600075 w 1685925"/>
-              <a:gd name="connsiteY4" fmla="*/ 3587996 h 3602283"/>
-              <a:gd name="connsiteX5" fmla="*/ 619125 w 1685925"/>
-              <a:gd name="connsiteY5" fmla="*/ 2906958 h 3602283"/>
-              <a:gd name="connsiteX6" fmla="*/ 442913 w 1685925"/>
-              <a:gd name="connsiteY6" fmla="*/ 2902196 h 3602283"/>
-              <a:gd name="connsiteX7" fmla="*/ 442913 w 1685925"/>
-              <a:gd name="connsiteY7" fmla="*/ 2506908 h 3602283"/>
-              <a:gd name="connsiteX8" fmla="*/ 1171575 w 1685925"/>
-              <a:gd name="connsiteY8" fmla="*/ 2511671 h 3602283"/>
-              <a:gd name="connsiteX9" fmla="*/ 1181100 w 1685925"/>
-              <a:gd name="connsiteY9" fmla="*/ 1621083 h 3602283"/>
-              <a:gd name="connsiteX10" fmla="*/ 1681163 w 1685925"/>
-              <a:gd name="connsiteY10" fmla="*/ 1616321 h 3602283"/>
-              <a:gd name="connsiteX11" fmla="*/ 1685925 w 1685925"/>
-              <a:gd name="connsiteY11" fmla="*/ 1833 h 3602283"/>
-              <a:gd name="connsiteX12" fmla="*/ 1276350 w 1685925"/>
-              <a:gd name="connsiteY12" fmla="*/ 1833 h 3602283"/>
+              <a:gd name="connsiteX0" fmla="*/ 0 w 2652713"/>
+              <a:gd name="connsiteY0" fmla="*/ 4762 h 4643437"/>
+              <a:gd name="connsiteX1" fmla="*/ 0 w 2652713"/>
+              <a:gd name="connsiteY1" fmla="*/ 4643437 h 4643437"/>
+              <a:gd name="connsiteX2" fmla="*/ 1514475 w 2652713"/>
+              <a:gd name="connsiteY2" fmla="*/ 4633912 h 4643437"/>
+              <a:gd name="connsiteX3" fmla="*/ 1509713 w 2652713"/>
+              <a:gd name="connsiteY3" fmla="*/ 2657475 h 4643437"/>
+              <a:gd name="connsiteX4" fmla="*/ 171450 w 2652713"/>
+              <a:gd name="connsiteY4" fmla="*/ 2652712 h 4643437"/>
+              <a:gd name="connsiteX5" fmla="*/ 176213 w 2652713"/>
+              <a:gd name="connsiteY5" fmla="*/ 2019300 h 4643437"/>
+              <a:gd name="connsiteX6" fmla="*/ 1519238 w 2652713"/>
+              <a:gd name="connsiteY6" fmla="*/ 2033587 h 4643437"/>
+              <a:gd name="connsiteX7" fmla="*/ 1509713 w 2652713"/>
+              <a:gd name="connsiteY7" fmla="*/ 1928812 h 4643437"/>
+              <a:gd name="connsiteX8" fmla="*/ 1624013 w 2652713"/>
+              <a:gd name="connsiteY8" fmla="*/ 1928812 h 4643437"/>
+              <a:gd name="connsiteX9" fmla="*/ 1628775 w 2652713"/>
+              <a:gd name="connsiteY9" fmla="*/ 1819275 h 4643437"/>
+              <a:gd name="connsiteX10" fmla="*/ 2652713 w 2652713"/>
+              <a:gd name="connsiteY10" fmla="*/ 1824037 h 4643437"/>
+              <a:gd name="connsiteX11" fmla="*/ 2652713 w 2652713"/>
+              <a:gd name="connsiteY11" fmla="*/ 1347787 h 4643437"/>
+              <a:gd name="connsiteX12" fmla="*/ 2433638 w 2652713"/>
+              <a:gd name="connsiteY12" fmla="*/ 1347787 h 4643437"/>
+              <a:gd name="connsiteX13" fmla="*/ 2443163 w 2652713"/>
+              <a:gd name="connsiteY13" fmla="*/ 371475 h 4643437"/>
+              <a:gd name="connsiteX14" fmla="*/ 2652713 w 2652713"/>
+              <a:gd name="connsiteY14" fmla="*/ 366712 h 4643437"/>
+              <a:gd name="connsiteX15" fmla="*/ 2652713 w 2652713"/>
+              <a:gd name="connsiteY15" fmla="*/ 0 h 4643437"/>
+              <a:gd name="connsiteX16" fmla="*/ 0 w 2652713"/>
+              <a:gd name="connsiteY16" fmla="*/ 4762 h 4643437"/>
+              <a:gd name="connsiteX0" fmla="*/ 0 w 2652713"/>
+              <a:gd name="connsiteY0" fmla="*/ 4762 h 4643437"/>
+              <a:gd name="connsiteX1" fmla="*/ 0 w 2652713"/>
+              <a:gd name="connsiteY1" fmla="*/ 4643437 h 4643437"/>
+              <a:gd name="connsiteX2" fmla="*/ 1514475 w 2652713"/>
+              <a:gd name="connsiteY2" fmla="*/ 4633912 h 4643437"/>
+              <a:gd name="connsiteX3" fmla="*/ 1509713 w 2652713"/>
+              <a:gd name="connsiteY3" fmla="*/ 2657475 h 4643437"/>
+              <a:gd name="connsiteX4" fmla="*/ 171450 w 2652713"/>
+              <a:gd name="connsiteY4" fmla="*/ 2652712 h 4643437"/>
+              <a:gd name="connsiteX5" fmla="*/ 176213 w 2652713"/>
+              <a:gd name="connsiteY5" fmla="*/ 2019300 h 4643437"/>
+              <a:gd name="connsiteX6" fmla="*/ 1519238 w 2652713"/>
+              <a:gd name="connsiteY6" fmla="*/ 2033587 h 4643437"/>
+              <a:gd name="connsiteX7" fmla="*/ 1522413 w 2652713"/>
+              <a:gd name="connsiteY7" fmla="*/ 1925637 h 4643437"/>
+              <a:gd name="connsiteX8" fmla="*/ 1624013 w 2652713"/>
+              <a:gd name="connsiteY8" fmla="*/ 1928812 h 4643437"/>
+              <a:gd name="connsiteX9" fmla="*/ 1628775 w 2652713"/>
+              <a:gd name="connsiteY9" fmla="*/ 1819275 h 4643437"/>
+              <a:gd name="connsiteX10" fmla="*/ 2652713 w 2652713"/>
+              <a:gd name="connsiteY10" fmla="*/ 1824037 h 4643437"/>
+              <a:gd name="connsiteX11" fmla="*/ 2652713 w 2652713"/>
+              <a:gd name="connsiteY11" fmla="*/ 1347787 h 4643437"/>
+              <a:gd name="connsiteX12" fmla="*/ 2433638 w 2652713"/>
+              <a:gd name="connsiteY12" fmla="*/ 1347787 h 4643437"/>
+              <a:gd name="connsiteX13" fmla="*/ 2443163 w 2652713"/>
+              <a:gd name="connsiteY13" fmla="*/ 371475 h 4643437"/>
+              <a:gd name="connsiteX14" fmla="*/ 2652713 w 2652713"/>
+              <a:gd name="connsiteY14" fmla="*/ 366712 h 4643437"/>
+              <a:gd name="connsiteX15" fmla="*/ 2652713 w 2652713"/>
+              <a:gd name="connsiteY15" fmla="*/ 0 h 4643437"/>
+              <a:gd name="connsiteX16" fmla="*/ 0 w 2652713"/>
+              <a:gd name="connsiteY16" fmla="*/ 4762 h 4643437"/>
+              <a:gd name="connsiteX0" fmla="*/ 0 w 2652713"/>
+              <a:gd name="connsiteY0" fmla="*/ 4762 h 4643437"/>
+              <a:gd name="connsiteX1" fmla="*/ 0 w 2652713"/>
+              <a:gd name="connsiteY1" fmla="*/ 4643437 h 4643437"/>
+              <a:gd name="connsiteX2" fmla="*/ 1514475 w 2652713"/>
+              <a:gd name="connsiteY2" fmla="*/ 4633912 h 4643437"/>
+              <a:gd name="connsiteX3" fmla="*/ 1509713 w 2652713"/>
+              <a:gd name="connsiteY3" fmla="*/ 2657475 h 4643437"/>
+              <a:gd name="connsiteX4" fmla="*/ 171450 w 2652713"/>
+              <a:gd name="connsiteY4" fmla="*/ 2652712 h 4643437"/>
+              <a:gd name="connsiteX5" fmla="*/ 176213 w 2652713"/>
+              <a:gd name="connsiteY5" fmla="*/ 2019300 h 4643437"/>
+              <a:gd name="connsiteX6" fmla="*/ 1519238 w 2652713"/>
+              <a:gd name="connsiteY6" fmla="*/ 2033587 h 4643437"/>
+              <a:gd name="connsiteX7" fmla="*/ 1522413 w 2652713"/>
+              <a:gd name="connsiteY7" fmla="*/ 1925637 h 4643437"/>
+              <a:gd name="connsiteX8" fmla="*/ 1624013 w 2652713"/>
+              <a:gd name="connsiteY8" fmla="*/ 1928812 h 4643437"/>
+              <a:gd name="connsiteX9" fmla="*/ 1619250 w 2652713"/>
+              <a:gd name="connsiteY9" fmla="*/ 1816100 h 4643437"/>
+              <a:gd name="connsiteX10" fmla="*/ 2652713 w 2652713"/>
+              <a:gd name="connsiteY10" fmla="*/ 1824037 h 4643437"/>
+              <a:gd name="connsiteX11" fmla="*/ 2652713 w 2652713"/>
+              <a:gd name="connsiteY11" fmla="*/ 1347787 h 4643437"/>
+              <a:gd name="connsiteX12" fmla="*/ 2433638 w 2652713"/>
+              <a:gd name="connsiteY12" fmla="*/ 1347787 h 4643437"/>
+              <a:gd name="connsiteX13" fmla="*/ 2443163 w 2652713"/>
+              <a:gd name="connsiteY13" fmla="*/ 371475 h 4643437"/>
+              <a:gd name="connsiteX14" fmla="*/ 2652713 w 2652713"/>
+              <a:gd name="connsiteY14" fmla="*/ 366712 h 4643437"/>
+              <a:gd name="connsiteX15" fmla="*/ 2652713 w 2652713"/>
+              <a:gd name="connsiteY15" fmla="*/ 0 h 4643437"/>
+              <a:gd name="connsiteX16" fmla="*/ 0 w 2652713"/>
+              <a:gd name="connsiteY16" fmla="*/ 4762 h 4643437"/>
             </a:gdLst>
             <a:ahLst/>
             <a:cxnLst>
@@ -6979,372 +7008,83 @@
               <a:cxn ang="0">
                 <a:pos x="connsiteX12" y="connsiteY12"/>
               </a:cxn>
-            </a:cxnLst>
-            <a:rect l="l" t="t" r="r" b="b"/>
-            <a:pathLst>
-              <a:path w="1685925" h="3602283">
-                <a:moveTo>
-                  <a:pt x="1276350" y="1833"/>
-                </a:moveTo>
-                <a:cubicBezTo>
-                  <a:pt x="1274763" y="463796"/>
-                  <a:pt x="1273175" y="925758"/>
-                  <a:pt x="1271588" y="1387721"/>
-                </a:cubicBezTo>
-                <a:lnTo>
-                  <a:pt x="4763" y="1373433"/>
-                </a:lnTo>
-                <a:cubicBezTo>
-                  <a:pt x="3175" y="2116383"/>
-                  <a:pt x="1588" y="2859333"/>
-                  <a:pt x="0" y="3602283"/>
-                </a:cubicBezTo>
-                <a:lnTo>
-                  <a:pt x="600075" y="3587996"/>
-                </a:lnTo>
-                <a:lnTo>
-                  <a:pt x="619125" y="2906958"/>
-                </a:lnTo>
-                <a:lnTo>
-                  <a:pt x="442913" y="2902196"/>
-                </a:lnTo>
-                <a:lnTo>
-                  <a:pt x="442913" y="2506908"/>
-                </a:lnTo>
-                <a:lnTo>
-                  <a:pt x="1171575" y="2511671"/>
-                </a:lnTo>
-                <a:lnTo>
-                  <a:pt x="1181100" y="1621083"/>
-                </a:lnTo>
-                <a:lnTo>
-                  <a:pt x="1681163" y="1616321"/>
-                </a:lnTo>
-                <a:cubicBezTo>
-                  <a:pt x="1682750" y="1084508"/>
-                  <a:pt x="1684338" y="533646"/>
-                  <a:pt x="1685925" y="1833"/>
-                </a:cubicBezTo>
-                <a:cubicBezTo>
-                  <a:pt x="1549400" y="-4517"/>
-                  <a:pt x="1412875" y="8183"/>
-                  <a:pt x="1276350" y="1833"/>
-                </a:cubicBezTo>
-                <a:close/>
-              </a:path>
-            </a:pathLst>
-          </a:custGeom>
-          <a:solidFill>
-            <a:srgbClr val="CC00CC">
-              <a:alpha val="89804"/>
-            </a:srgbClr>
-          </a:solidFill>
-          <a:ln w="19050">
-            <a:solidFill>
-              <a:schemeClr val="accent5">
-                <a:lumMod val="75000"/>
-              </a:schemeClr>
-            </a:solidFill>
-          </a:ln>
-        </p:spPr>
-        <p:style>
-          <a:lnRef idx="2">
-            <a:schemeClr val="accent1">
-              <a:shade val="15000"/>
-            </a:schemeClr>
-          </a:lnRef>
-          <a:fillRef idx="1">
-            <a:schemeClr val="accent1"/>
-          </a:fillRef>
-          <a:effectRef idx="0">
-            <a:schemeClr val="accent1"/>
-          </a:effectRef>
-          <a:fontRef idx="minor">
-            <a:schemeClr val="lt1"/>
-          </a:fontRef>
-        </p:style>
-        <p:txBody>
-          <a:bodyPr rtlCol="0" anchor="ctr"/>
-          <a:lstStyle/>
-          <a:p>
-            <a:pPr algn="ctr"/>
-            <a:endParaRPr lang="en-US">
-              <a:solidFill>
-                <a:schemeClr val="tx1">
-                  <a:lumMod val="75000"/>
-                  <a:lumOff val="25000"/>
-                </a:schemeClr>
-              </a:solidFill>
-            </a:endParaRPr>
-          </a:p>
-        </p:txBody>
-      </p:sp>
-      <p:sp>
-        <p:nvSpPr>
-          <p:cNvPr id="12" name="TextBox 11">
-            <a:extLst>
-              <a:ext uri="{FF2B5EF4-FFF2-40B4-BE49-F238E27FC236}">
-                <a16:creationId xmlns:a16="http://schemas.microsoft.com/office/drawing/2014/main" id="{94E444D3-78E4-9085-BB6D-F919381FB8B8}"/>
-              </a:ext>
-            </a:extLst>
-          </p:cNvPr>
-          <p:cNvSpPr txBox="1"/>
-          <p:nvPr/>
-        </p:nvSpPr>
-        <p:spPr>
-          <a:xfrm>
-            <a:off x="1811524" y="1920896"/>
-            <a:ext cx="1296144" cy="276999"/>
-          </a:xfrm>
-          <a:prstGeom prst="rect">
-            <a:avLst/>
-          </a:prstGeom>
-          <a:noFill/>
-        </p:spPr>
-        <p:txBody>
-          <a:bodyPr wrap="square" rtlCol="0">
-            <a:spAutoFit/>
-          </a:bodyPr>
-          <a:lstStyle/>
-          <a:p>
-            <a:r>
-              <a:rPr lang="en-US" sz="600" b="1">
-                <a:solidFill>
-                  <a:schemeClr val="bg1"/>
-                </a:solidFill>
-              </a:rPr>
-              <a:t>GNDC</a:t>
-            </a:r>
-          </a:p>
-          <a:p>
-            <a:r>
-              <a:rPr lang="en-US" sz="600">
-                <a:solidFill>
-                  <a:schemeClr val="bg1"/>
-                </a:solidFill>
-              </a:rPr>
-              <a:t>Filtered CAN Ground Plane</a:t>
-            </a:r>
-          </a:p>
-        </p:txBody>
-      </p:sp>
-      <p:sp>
-        <p:nvSpPr>
-          <p:cNvPr id="13" name="Freeform: Shape 12">
-            <a:extLst>
-              <a:ext uri="{FF2B5EF4-FFF2-40B4-BE49-F238E27FC236}">
-                <a16:creationId xmlns:a16="http://schemas.microsoft.com/office/drawing/2014/main" id="{BEE3C5D8-287F-D642-706A-0DE9BE6A2D6D}"/>
-              </a:ext>
-            </a:extLst>
-          </p:cNvPr>
-          <p:cNvSpPr/>
-          <p:nvPr/>
-        </p:nvSpPr>
-        <p:spPr>
-          <a:xfrm>
-            <a:off x="2324100" y="2190750"/>
-            <a:ext cx="1233488" cy="1943100"/>
-          </a:xfrm>
-          <a:custGeom>
-            <a:avLst/>
-            <a:gdLst>
-              <a:gd name="connsiteX0" fmla="*/ 1233488 w 1233488"/>
-              <a:gd name="connsiteY0" fmla="*/ 0 h 1943100"/>
-              <a:gd name="connsiteX1" fmla="*/ 738188 w 1233488"/>
-              <a:gd name="connsiteY1" fmla="*/ 9525 h 1943100"/>
-              <a:gd name="connsiteX2" fmla="*/ 723900 w 1233488"/>
-              <a:gd name="connsiteY2" fmla="*/ 895350 h 1943100"/>
-              <a:gd name="connsiteX3" fmla="*/ 0 w 1233488"/>
-              <a:gd name="connsiteY3" fmla="*/ 900113 h 1943100"/>
-              <a:gd name="connsiteX4" fmla="*/ 0 w 1233488"/>
-              <a:gd name="connsiteY4" fmla="*/ 1252538 h 1943100"/>
-              <a:gd name="connsiteX5" fmla="*/ 171450 w 1233488"/>
-              <a:gd name="connsiteY5" fmla="*/ 1262063 h 1943100"/>
-              <a:gd name="connsiteX6" fmla="*/ 161925 w 1233488"/>
-              <a:gd name="connsiteY6" fmla="*/ 1943100 h 1943100"/>
-              <a:gd name="connsiteX7" fmla="*/ 1223963 w 1233488"/>
-              <a:gd name="connsiteY7" fmla="*/ 1943100 h 1943100"/>
-              <a:gd name="connsiteX8" fmla="*/ 1233488 w 1233488"/>
-              <a:gd name="connsiteY8" fmla="*/ 0 h 1943100"/>
-            </a:gdLst>
-            <a:ahLst/>
-            <a:cxnLst>
               <a:cxn ang="0">
-                <a:pos x="connsiteX0" y="connsiteY0"/>
+                <a:pos x="connsiteX13" y="connsiteY13"/>
               </a:cxn>
               <a:cxn ang="0">
-                <a:pos x="connsiteX1" y="connsiteY1"/>
+                <a:pos x="connsiteX14" y="connsiteY14"/>
               </a:cxn>
               <a:cxn ang="0">
-                <a:pos x="connsiteX2" y="connsiteY2"/>
+                <a:pos x="connsiteX15" y="connsiteY15"/>
               </a:cxn>
               <a:cxn ang="0">
-                <a:pos x="connsiteX3" y="connsiteY3"/>
-              </a:cxn>
-              <a:cxn ang="0">
-                <a:pos x="connsiteX4" y="connsiteY4"/>
-              </a:cxn>
-              <a:cxn ang="0">
-                <a:pos x="connsiteX5" y="connsiteY5"/>
-              </a:cxn>
-              <a:cxn ang="0">
-                <a:pos x="connsiteX6" y="connsiteY6"/>
-              </a:cxn>
-              <a:cxn ang="0">
-                <a:pos x="connsiteX7" y="connsiteY7"/>
-              </a:cxn>
-              <a:cxn ang="0">
-                <a:pos x="connsiteX8" y="connsiteY8"/>
+                <a:pos x="connsiteX16" y="connsiteY16"/>
               </a:cxn>
             </a:cxnLst>
             <a:rect l="l" t="t" r="r" b="b"/>
             <a:pathLst>
-              <a:path w="1233488" h="1943100">
+              <a:path w="2652713" h="4643437">
                 <a:moveTo>
-                  <a:pt x="1233488" y="0"/>
+                  <a:pt x="0" y="4762"/>
                 </a:moveTo>
                 <a:lnTo>
-                  <a:pt x="738188" y="9525"/>
+                  <a:pt x="0" y="4643437"/>
                 </a:lnTo>
                 <a:lnTo>
-                  <a:pt x="723900" y="895350"/>
+                  <a:pt x="1514475" y="4633912"/>
+                </a:lnTo>
+                <a:cubicBezTo>
+                  <a:pt x="1512888" y="3975100"/>
+                  <a:pt x="1511300" y="3316287"/>
+                  <a:pt x="1509713" y="2657475"/>
+                </a:cubicBezTo>
+                <a:lnTo>
+                  <a:pt x="171450" y="2652712"/>
+                </a:lnTo>
+                <a:cubicBezTo>
+                  <a:pt x="173038" y="2441575"/>
+                  <a:pt x="174625" y="2230437"/>
+                  <a:pt x="176213" y="2019300"/>
+                </a:cubicBezTo>
+                <a:lnTo>
+                  <a:pt x="1519238" y="2033587"/>
+                </a:lnTo>
+                <a:cubicBezTo>
+                  <a:pt x="1520296" y="1997604"/>
+                  <a:pt x="1521355" y="1961620"/>
+                  <a:pt x="1522413" y="1925637"/>
+                </a:cubicBezTo>
+                <a:lnTo>
+                  <a:pt x="1624013" y="1928812"/>
                 </a:lnTo>
                 <a:lnTo>
-                  <a:pt x="0" y="900113"/>
+                  <a:pt x="1619250" y="1816100"/>
                 </a:lnTo>
                 <a:lnTo>
-                  <a:pt x="0" y="1252538"/>
+                  <a:pt x="2652713" y="1824037"/>
                 </a:lnTo>
                 <a:lnTo>
-                  <a:pt x="171450" y="1262063"/>
+                  <a:pt x="2652713" y="1347787"/>
                 </a:lnTo>
                 <a:lnTo>
-                  <a:pt x="161925" y="1943100"/>
+                  <a:pt x="2433638" y="1347787"/>
                 </a:lnTo>
                 <a:lnTo>
-                  <a:pt x="1223963" y="1943100"/>
+                  <a:pt x="2443163" y="371475"/>
                 </a:lnTo>
                 <a:lnTo>
-                  <a:pt x="1233488" y="0"/>
+                  <a:pt x="2652713" y="366712"/>
+                </a:lnTo>
+                <a:lnTo>
+                  <a:pt x="2652713" y="0"/>
+                </a:lnTo>
+                <a:lnTo>
+                  <a:pt x="0" y="4762"/>
                 </a:lnTo>
                 <a:close/>
               </a:path>
             </a:pathLst>
           </a:custGeom>
-          <a:solidFill>
-            <a:srgbClr val="A20000">
-              <a:alpha val="89804"/>
-            </a:srgbClr>
-          </a:solidFill>
-          <a:ln w="19050">
-            <a:solidFill>
-              <a:srgbClr val="840000"/>
-            </a:solidFill>
-          </a:ln>
-        </p:spPr>
-        <p:style>
-          <a:lnRef idx="2">
-            <a:schemeClr val="accent1">
-              <a:shade val="15000"/>
-            </a:schemeClr>
-          </a:lnRef>
-          <a:fillRef idx="1">
-            <a:schemeClr val="accent1"/>
-          </a:fillRef>
-          <a:effectRef idx="0">
-            <a:schemeClr val="accent1"/>
-          </a:effectRef>
-          <a:fontRef idx="minor">
-            <a:schemeClr val="lt1"/>
-          </a:fontRef>
-        </p:style>
-        <p:txBody>
-          <a:bodyPr rtlCol="0" anchor="ctr"/>
-          <a:lstStyle/>
-          <a:p>
-            <a:pPr algn="ctr"/>
-            <a:endParaRPr lang="en-US">
-              <a:solidFill>
-                <a:schemeClr val="tx1">
-                  <a:lumMod val="75000"/>
-                  <a:lumOff val="25000"/>
-                </a:schemeClr>
-              </a:solidFill>
-            </a:endParaRPr>
-          </a:p>
-        </p:txBody>
-      </p:sp>
-      <p:sp>
-        <p:nvSpPr>
-          <p:cNvPr id="14" name="TextBox 13">
-            <a:extLst>
-              <a:ext uri="{FF2B5EF4-FFF2-40B4-BE49-F238E27FC236}">
-                <a16:creationId xmlns:a16="http://schemas.microsoft.com/office/drawing/2014/main" id="{7F7C5643-2E96-E19A-332D-C0DEEAE84FA6}"/>
-              </a:ext>
-            </a:extLst>
-          </p:cNvPr>
-          <p:cNvSpPr txBox="1"/>
-          <p:nvPr/>
-        </p:nvSpPr>
-        <p:spPr>
-          <a:xfrm>
-            <a:off x="2459595" y="3862369"/>
-            <a:ext cx="1148605" cy="276999"/>
-          </a:xfrm>
-          <a:prstGeom prst="rect">
-            <a:avLst/>
-          </a:prstGeom>
-          <a:noFill/>
-        </p:spPr>
-        <p:txBody>
-          <a:bodyPr wrap="square" rtlCol="0">
-            <a:spAutoFit/>
-          </a:bodyPr>
-          <a:lstStyle/>
-          <a:p>
-            <a:pPr algn="r"/>
-            <a:r>
-              <a:rPr lang="en-US" sz="600" b="1">
-                <a:solidFill>
-                  <a:schemeClr val="bg1"/>
-                </a:solidFill>
-              </a:rPr>
-              <a:t>NET-C</a:t>
-            </a:r>
-          </a:p>
-          <a:p>
-            <a:pPr algn="r"/>
-            <a:r>
-              <a:rPr lang="en-US" sz="600">
-                <a:solidFill>
-                  <a:schemeClr val="bg1"/>
-                </a:solidFill>
-              </a:rPr>
-              <a:t>NMEA 2000 Ground</a:t>
-            </a:r>
-          </a:p>
-        </p:txBody>
-      </p:sp>
-      <p:sp>
-        <p:nvSpPr>
-          <p:cNvPr id="15" name="Rectangle 14">
-            <a:extLst>
-              <a:ext uri="{FF2B5EF4-FFF2-40B4-BE49-F238E27FC236}">
-                <a16:creationId xmlns:a16="http://schemas.microsoft.com/office/drawing/2014/main" id="{9FB9D72E-6C32-13B4-9E33-4971CDA6301B}"/>
-              </a:ext>
-            </a:extLst>
-          </p:cNvPr>
-          <p:cNvSpPr/>
-          <p:nvPr/>
-        </p:nvSpPr>
-        <p:spPr>
-          <a:xfrm>
-            <a:off x="3828964" y="548680"/>
-            <a:ext cx="2699084" cy="2052228"/>
-          </a:xfrm>
-          <a:prstGeom prst="rect">
-            <a:avLst/>
-          </a:prstGeom>
           <a:solidFill>
             <a:srgbClr val="D1D1D1">
               <a:alpha val="89804"/>
@@ -7393,10 +7133,119 @@
       </p:sp>
       <p:sp>
         <p:nvSpPr>
-          <p:cNvPr id="16" name="TextBox 15">
-            <a:extLst>
-              <a:ext uri="{FF2B5EF4-FFF2-40B4-BE49-F238E27FC236}">
-                <a16:creationId xmlns:a16="http://schemas.microsoft.com/office/drawing/2014/main" id="{3076611E-9414-A7D1-466D-DAE4BC7FC5CF}"/>
+          <p:cNvPr id="2" name="Title 1">
+            <a:extLst>
+              <a:ext uri="{FF2B5EF4-FFF2-40B4-BE49-F238E27FC236}">
+                <a16:creationId xmlns:a16="http://schemas.microsoft.com/office/drawing/2014/main" id="{4FAD87BF-7D66-DDCA-CA69-52E1091BFA31}"/>
+              </a:ext>
+            </a:extLst>
+          </p:cNvPr>
+          <p:cNvSpPr>
+            <a:spLocks noGrp="1"/>
+          </p:cNvSpPr>
+          <p:nvPr>
+            <p:ph type="title"/>
+          </p:nvPr>
+        </p:nvSpPr>
+        <p:spPr>
+          <a:xfrm>
+            <a:off x="1343472" y="5553236"/>
+            <a:ext cx="3025552" cy="720080"/>
+          </a:xfrm>
+        </p:spPr>
+        <p:txBody>
+          <a:bodyPr vert="horz" lIns="91440" tIns="45720" rIns="91440" bIns="45720" rtlCol="0" anchor="ctr">
+            <a:normAutofit/>
+          </a:bodyPr>
+          <a:lstStyle/>
+          <a:p>
+            <a:r>
+              <a:rPr lang="en-US" sz="1800" i="1">
+                <a:solidFill>
+                  <a:schemeClr val="tx1">
+                    <a:lumMod val="65000"/>
+                    <a:lumOff val="35000"/>
+                  </a:schemeClr>
+                </a:solidFill>
+                <a:latin typeface="Eras Demi ITC" panose="020B0805030504020804" pitchFamily="34" charset="0"/>
+              </a:rPr>
+              <a:t>MDD400 Ground Planes</a:t>
+            </a:r>
+          </a:p>
+        </p:txBody>
+      </p:sp>
+      <p:sp>
+        <p:nvSpPr>
+          <p:cNvPr id="9" name="Rectangle 8">
+            <a:extLst>
+              <a:ext uri="{FF2B5EF4-FFF2-40B4-BE49-F238E27FC236}">
+                <a16:creationId xmlns:a16="http://schemas.microsoft.com/office/drawing/2014/main" id="{DD1DA1DF-1E5A-4765-6BD6-86C0A65F65A8}"/>
+              </a:ext>
+            </a:extLst>
+          </p:cNvPr>
+          <p:cNvSpPr/>
+          <p:nvPr/>
+        </p:nvSpPr>
+        <p:spPr>
+          <a:xfrm>
+            <a:off x="1883532" y="548680"/>
+            <a:ext cx="1767860" cy="828092"/>
+          </a:xfrm>
+          <a:prstGeom prst="rect">
+            <a:avLst/>
+          </a:prstGeom>
+          <a:solidFill>
+            <a:srgbClr val="215F9A">
+              <a:alpha val="89804"/>
+            </a:srgbClr>
+          </a:solidFill>
+          <a:ln w="19050">
+            <a:solidFill>
+              <a:schemeClr val="tx2">
+                <a:lumMod val="90000"/>
+                <a:lumOff val="10000"/>
+              </a:schemeClr>
+            </a:solidFill>
+          </a:ln>
+        </p:spPr>
+        <p:style>
+          <a:lnRef idx="2">
+            <a:schemeClr val="accent1">
+              <a:shade val="15000"/>
+            </a:schemeClr>
+          </a:lnRef>
+          <a:fillRef idx="1">
+            <a:schemeClr val="accent1"/>
+          </a:fillRef>
+          <a:effectRef idx="0">
+            <a:schemeClr val="accent1"/>
+          </a:effectRef>
+          <a:fontRef idx="minor">
+            <a:schemeClr val="lt1"/>
+          </a:fontRef>
+        </p:style>
+        <p:txBody>
+          <a:bodyPr rtlCol="0" anchor="ctr"/>
+          <a:lstStyle/>
+          <a:p>
+            <a:pPr algn="ctr"/>
+            <a:endParaRPr lang="en-US">
+              <a:solidFill>
+                <a:schemeClr val="tx1">
+                  <a:lumMod val="75000"/>
+                  <a:lumOff val="25000"/>
+                </a:schemeClr>
+              </a:solidFill>
+            </a:endParaRPr>
+          </a:p>
+        </p:txBody>
+      </p:sp>
+      <p:sp>
+        <p:nvSpPr>
+          <p:cNvPr id="10" name="TextBox 9">
+            <a:extLst>
+              <a:ext uri="{FF2B5EF4-FFF2-40B4-BE49-F238E27FC236}">
+                <a16:creationId xmlns:a16="http://schemas.microsoft.com/office/drawing/2014/main" id="{EEE6DECA-8DB3-5B4B-B0A3-070A8923A565}"/>
               </a:ext>
             </a:extLst>
           </p:cNvPr>
@@ -7405,8 +7254,157 @@
         </p:nvSpPr>
         <p:spPr>
           <a:xfrm>
+            <a:off x="1811524" y="584684"/>
+            <a:ext cx="1767860" cy="276999"/>
+          </a:xfrm>
+          <a:prstGeom prst="rect">
+            <a:avLst/>
+          </a:prstGeom>
+          <a:noFill/>
+        </p:spPr>
+        <p:txBody>
+          <a:bodyPr wrap="square" rtlCol="0">
+            <a:spAutoFit/>
+          </a:bodyPr>
+          <a:lstStyle/>
+          <a:p>
+            <a:r>
+              <a:rPr lang="en-US" sz="600" b="1">
+                <a:solidFill>
+                  <a:schemeClr val="bg1"/>
+                </a:solidFill>
+              </a:rPr>
+              <a:t>GNDSMPS</a:t>
+            </a:r>
+          </a:p>
+          <a:p>
+            <a:r>
+              <a:rPr lang="en-US" sz="600">
+                <a:solidFill>
+                  <a:schemeClr val="bg1"/>
+                </a:solidFill>
+              </a:rPr>
+              <a:t>DC-DC converter ground refrerence</a:t>
+            </a:r>
+          </a:p>
+        </p:txBody>
+      </p:sp>
+      <p:sp>
+        <p:nvSpPr>
+          <p:cNvPr id="12" name="TextBox 11">
+            <a:extLst>
+              <a:ext uri="{FF2B5EF4-FFF2-40B4-BE49-F238E27FC236}">
+                <a16:creationId xmlns:a16="http://schemas.microsoft.com/office/drawing/2014/main" id="{94E444D3-78E4-9085-BB6D-F919381FB8B8}"/>
+              </a:ext>
+            </a:extLst>
+          </p:cNvPr>
+          <p:cNvSpPr txBox="1"/>
+          <p:nvPr/>
+        </p:nvSpPr>
+        <p:spPr>
+          <a:xfrm>
+            <a:off x="1811524" y="1647825"/>
+            <a:ext cx="1296144" cy="276999"/>
+          </a:xfrm>
+          <a:prstGeom prst="rect">
+            <a:avLst/>
+          </a:prstGeom>
+          <a:noFill/>
+        </p:spPr>
+        <p:txBody>
+          <a:bodyPr wrap="square" rtlCol="0">
+            <a:spAutoFit/>
+          </a:bodyPr>
+          <a:lstStyle/>
+          <a:p>
+            <a:r>
+              <a:rPr lang="en-US" sz="600" b="1">
+                <a:solidFill>
+                  <a:schemeClr val="bg1"/>
+                </a:solidFill>
+              </a:rPr>
+              <a:t>GNDC</a:t>
+            </a:r>
+          </a:p>
+          <a:p>
+            <a:r>
+              <a:rPr lang="en-US" sz="600">
+                <a:solidFill>
+                  <a:schemeClr val="bg1"/>
+                </a:solidFill>
+              </a:rPr>
+              <a:t>Filtered CAN ground reference</a:t>
+            </a:r>
+          </a:p>
+        </p:txBody>
+      </p:sp>
+      <p:sp>
+        <p:nvSpPr>
+          <p:cNvPr id="14" name="TextBox 13">
+            <a:extLst>
+              <a:ext uri="{FF2B5EF4-FFF2-40B4-BE49-F238E27FC236}">
+                <a16:creationId xmlns:a16="http://schemas.microsoft.com/office/drawing/2014/main" id="{7F7C5643-2E96-E19A-332D-C0DEEAE84FA6}"/>
+              </a:ext>
+            </a:extLst>
+          </p:cNvPr>
+          <p:cNvSpPr txBox="1"/>
+          <p:nvPr/>
+        </p:nvSpPr>
+        <p:spPr>
+          <a:xfrm>
+            <a:off x="2459596" y="2560081"/>
+            <a:ext cx="1148605" cy="276999"/>
+          </a:xfrm>
+          <a:prstGeom prst="rect">
+            <a:avLst/>
+          </a:prstGeom>
+          <a:noFill/>
+        </p:spPr>
+        <p:txBody>
+          <a:bodyPr wrap="square" rtlCol="0">
+            <a:spAutoFit/>
+          </a:bodyPr>
+          <a:lstStyle/>
+          <a:p>
+            <a:pPr algn="r"/>
+            <a:r>
+              <a:rPr lang="en-US" sz="600" b="1">
+                <a:solidFill>
+                  <a:schemeClr val="bg1"/>
+                </a:solidFill>
+              </a:rPr>
+              <a:t>NET-C</a:t>
+            </a:r>
+          </a:p>
+          <a:p>
+            <a:pPr algn="r"/>
+            <a:r>
+              <a:rPr lang="en-US" sz="600">
+                <a:solidFill>
+                  <a:schemeClr val="bg1"/>
+                </a:solidFill>
+              </a:rPr>
+              <a:t>NMEA 2000 Ground</a:t>
+            </a:r>
+          </a:p>
+        </p:txBody>
+      </p:sp>
+      <p:sp>
+        <p:nvSpPr>
+          <p:cNvPr id="16" name="TextBox 15">
+            <a:extLst>
+              <a:ext uri="{FF2B5EF4-FFF2-40B4-BE49-F238E27FC236}">
+                <a16:creationId xmlns:a16="http://schemas.microsoft.com/office/drawing/2014/main" id="{3076611E-9414-A7D1-466D-DAE4BC7FC5CF}"/>
+              </a:ext>
+            </a:extLst>
+          </p:cNvPr>
+          <p:cNvSpPr txBox="1"/>
+          <p:nvPr/>
+        </p:nvSpPr>
+        <p:spPr>
+          <a:xfrm>
             <a:off x="3824201" y="584683"/>
-            <a:ext cx="1219396" cy="276999"/>
+            <a:ext cx="1980612" cy="276999"/>
           </a:xfrm>
           <a:prstGeom prst="rect">
             <a:avLst/>
@@ -7441,7 +7439,7 @@
                   </a:schemeClr>
                 </a:solidFill>
               </a:rPr>
-              <a:t>Digital Domain Ground</a:t>
+              <a:t>Digital domain signal ground reference</a:t>
             </a:r>
           </a:p>
         </p:txBody>
@@ -7460,8 +7458,8 @@
         </p:nvSpPr>
         <p:spPr>
           <a:xfrm>
-            <a:off x="5233503" y="2743388"/>
-            <a:ext cx="1294545" cy="1801736"/>
+            <a:off x="5465770" y="2600908"/>
+            <a:ext cx="1054093" cy="2609267"/>
           </a:xfrm>
           <a:prstGeom prst="rect">
             <a:avLst/>
@@ -7473,7 +7471,9 @@
           </a:solidFill>
           <a:ln w="19050">
             <a:solidFill>
-              <a:srgbClr val="11838F"/>
+              <a:schemeClr val="accent4">
+                <a:lumMod val="50000"/>
+              </a:schemeClr>
             </a:solidFill>
           </a:ln>
         </p:spPr>
@@ -7523,8 +7523,8 @@
         </p:nvSpPr>
         <p:spPr>
           <a:xfrm>
-            <a:off x="5233503" y="2743388"/>
-            <a:ext cx="1233488" cy="276999"/>
+            <a:off x="5437951" y="2654856"/>
+            <a:ext cx="1054093" cy="369332"/>
           </a:xfrm>
           <a:prstGeom prst="rect">
             <a:avLst/>
@@ -7555,6 +7555,351 @@
               </a:rPr>
               <a:t>SeaTalk / NMEA 0183 Ground</a:t>
             </a:r>
+          </a:p>
+        </p:txBody>
+      </p:sp>
+      <p:sp>
+        <p:nvSpPr>
+          <p:cNvPr id="23" name="TextBox 22">
+            <a:extLst>
+              <a:ext uri="{FF2B5EF4-FFF2-40B4-BE49-F238E27FC236}">
+                <a16:creationId xmlns:a16="http://schemas.microsoft.com/office/drawing/2014/main" id="{F239AEEB-5E0F-E83E-045D-7B3D1976FC9B}"/>
+              </a:ext>
+            </a:extLst>
+          </p:cNvPr>
+          <p:cNvSpPr txBox="1"/>
+          <p:nvPr/>
+        </p:nvSpPr>
+        <p:spPr>
+          <a:xfrm>
+            <a:off x="2248633" y="2353930"/>
+            <a:ext cx="482824" cy="246221"/>
+          </a:xfrm>
+          <a:prstGeom prst="rect">
+            <a:avLst/>
+          </a:prstGeom>
+          <a:noFill/>
+        </p:spPr>
+        <p:txBody>
+          <a:bodyPr wrap="none" rtlCol="0">
+            <a:spAutoFit/>
+          </a:bodyPr>
+          <a:lstStyle/>
+          <a:p>
+            <a:pPr algn="ctr"/>
+            <a:r>
+              <a:rPr lang="en-US" sz="500" b="1">
+                <a:solidFill>
+                  <a:schemeClr val="bg1"/>
+                </a:solidFill>
+              </a:rPr>
+              <a:t>CM Choke</a:t>
+            </a:r>
+          </a:p>
+          <a:p>
+            <a:pPr algn="ctr"/>
+            <a:r>
+              <a:rPr lang="en-US" sz="500" b="1">
+                <a:solidFill>
+                  <a:schemeClr val="bg1"/>
+                </a:solidFill>
+              </a:rPr>
+              <a:t>(12V)</a:t>
+            </a:r>
+          </a:p>
+        </p:txBody>
+      </p:sp>
+      <p:sp>
+        <p:nvSpPr>
+          <p:cNvPr id="24" name="TextBox 23">
+            <a:extLst>
+              <a:ext uri="{FF2B5EF4-FFF2-40B4-BE49-F238E27FC236}">
+                <a16:creationId xmlns:a16="http://schemas.microsoft.com/office/drawing/2014/main" id="{3DCADC81-F222-B9CC-7E44-48B9F1DA2A0E}"/>
+              </a:ext>
+            </a:extLst>
+          </p:cNvPr>
+          <p:cNvSpPr txBox="1"/>
+          <p:nvPr/>
+        </p:nvSpPr>
+        <p:spPr>
+          <a:xfrm>
+            <a:off x="2772093" y="2354687"/>
+            <a:ext cx="482824" cy="246221"/>
+          </a:xfrm>
+          <a:prstGeom prst="rect">
+            <a:avLst/>
+          </a:prstGeom>
+          <a:noFill/>
+        </p:spPr>
+        <p:txBody>
+          <a:bodyPr wrap="none" rtlCol="0">
+            <a:spAutoFit/>
+          </a:bodyPr>
+          <a:lstStyle/>
+          <a:p>
+            <a:pPr algn="ctr"/>
+            <a:r>
+              <a:rPr lang="en-US" sz="500" b="1">
+                <a:solidFill>
+                  <a:schemeClr val="bg1"/>
+                </a:solidFill>
+              </a:rPr>
+              <a:t>CM Choke</a:t>
+            </a:r>
+          </a:p>
+          <a:p>
+            <a:pPr algn="ctr"/>
+            <a:r>
+              <a:rPr lang="en-US" sz="500" b="1">
+                <a:solidFill>
+                  <a:schemeClr val="bg1"/>
+                </a:solidFill>
+              </a:rPr>
+              <a:t>(CAN)</a:t>
+            </a:r>
+          </a:p>
+        </p:txBody>
+      </p:sp>
+      <p:sp>
+        <p:nvSpPr>
+          <p:cNvPr id="25" name="TextBox 24">
+            <a:extLst>
+              <a:ext uri="{FF2B5EF4-FFF2-40B4-BE49-F238E27FC236}">
+                <a16:creationId xmlns:a16="http://schemas.microsoft.com/office/drawing/2014/main" id="{EEF26AE9-DADD-B8AE-0DF6-A43F241A72CD}"/>
+              </a:ext>
+            </a:extLst>
+          </p:cNvPr>
+          <p:cNvSpPr txBox="1"/>
+          <p:nvPr/>
+        </p:nvSpPr>
+        <p:spPr>
+          <a:xfrm>
+            <a:off x="2079355" y="1419171"/>
+            <a:ext cx="410690" cy="169277"/>
+          </a:xfrm>
+          <a:prstGeom prst="rect">
+            <a:avLst/>
+          </a:prstGeom>
+          <a:noFill/>
+        </p:spPr>
+        <p:txBody>
+          <a:bodyPr wrap="none" rtlCol="0">
+            <a:spAutoFit/>
+          </a:bodyPr>
+          <a:lstStyle/>
+          <a:p>
+            <a:pPr algn="ctr"/>
+            <a:r>
+              <a:rPr lang="en-US" sz="500" b="1">
+                <a:solidFill>
+                  <a:schemeClr val="bg1"/>
+                </a:solidFill>
+              </a:rPr>
+              <a:t>Ferrites</a:t>
+            </a:r>
+          </a:p>
+        </p:txBody>
+      </p:sp>
+      <p:sp>
+        <p:nvSpPr>
+          <p:cNvPr id="26" name="TextBox 25">
+            <a:extLst>
+              <a:ext uri="{FF2B5EF4-FFF2-40B4-BE49-F238E27FC236}">
+                <a16:creationId xmlns:a16="http://schemas.microsoft.com/office/drawing/2014/main" id="{CC9EAC7F-2A61-2754-15E9-07EEE73D3CE2}"/>
+              </a:ext>
+            </a:extLst>
+          </p:cNvPr>
+          <p:cNvSpPr txBox="1"/>
+          <p:nvPr/>
+        </p:nvSpPr>
+        <p:spPr>
+          <a:xfrm rot="16200000">
+            <a:off x="3562287" y="794989"/>
+            <a:ext cx="410690" cy="169277"/>
+          </a:xfrm>
+          <a:prstGeom prst="rect">
+            <a:avLst/>
+          </a:prstGeom>
+          <a:noFill/>
+        </p:spPr>
+        <p:txBody>
+          <a:bodyPr wrap="none" rtlCol="0">
+            <a:spAutoFit/>
+          </a:bodyPr>
+          <a:lstStyle/>
+          <a:p>
+            <a:pPr algn="ctr"/>
+            <a:r>
+              <a:rPr lang="en-US" sz="500" b="1">
+                <a:solidFill>
+                  <a:schemeClr val="bg1"/>
+                </a:solidFill>
+              </a:rPr>
+              <a:t>Ferrites</a:t>
+            </a:r>
+          </a:p>
+        </p:txBody>
+      </p:sp>
+      <p:sp>
+        <p:nvSpPr>
+          <p:cNvPr id="27" name="TextBox 26">
+            <a:extLst>
+              <a:ext uri="{FF2B5EF4-FFF2-40B4-BE49-F238E27FC236}">
+                <a16:creationId xmlns:a16="http://schemas.microsoft.com/office/drawing/2014/main" id="{3BE5D57A-23A1-F6B8-CF32-1845C85BE49B}"/>
+              </a:ext>
+            </a:extLst>
+          </p:cNvPr>
+          <p:cNvSpPr txBox="1"/>
+          <p:nvPr/>
+        </p:nvSpPr>
+        <p:spPr>
+          <a:xfrm>
+            <a:off x="5688087" y="2393008"/>
+            <a:ext cx="609462" cy="169277"/>
+          </a:xfrm>
+          <a:prstGeom prst="rect">
+            <a:avLst/>
+          </a:prstGeom>
+          <a:noFill/>
+        </p:spPr>
+        <p:txBody>
+          <a:bodyPr wrap="none" rtlCol="0">
+            <a:spAutoFit/>
+          </a:bodyPr>
+          <a:lstStyle/>
+          <a:p>
+            <a:pPr algn="ctr"/>
+            <a:r>
+              <a:rPr lang="en-US" sz="500" b="1">
+                <a:solidFill>
+                  <a:schemeClr val="bg1"/>
+                </a:solidFill>
+              </a:rPr>
+              <a:t>Opto-isolators</a:t>
+            </a:r>
+          </a:p>
+        </p:txBody>
+      </p:sp>
+      <p:sp>
+        <p:nvSpPr>
+          <p:cNvPr id="28" name="TextBox 27">
+            <a:extLst>
+              <a:ext uri="{FF2B5EF4-FFF2-40B4-BE49-F238E27FC236}">
+                <a16:creationId xmlns:a16="http://schemas.microsoft.com/office/drawing/2014/main" id="{F4AD931B-5F0B-2AA5-3279-C6E851071151}"/>
+              </a:ext>
+            </a:extLst>
+          </p:cNvPr>
+          <p:cNvSpPr txBox="1"/>
+          <p:nvPr/>
+        </p:nvSpPr>
+        <p:spPr>
+          <a:xfrm>
+            <a:off x="4302654" y="2803817"/>
+            <a:ext cx="671979" cy="307777"/>
+          </a:xfrm>
+          <a:prstGeom prst="rect">
+            <a:avLst/>
+          </a:prstGeom>
+          <a:noFill/>
+        </p:spPr>
+        <p:txBody>
+          <a:bodyPr wrap="none" rtlCol="0">
+            <a:spAutoFit/>
+          </a:bodyPr>
+          <a:lstStyle/>
+          <a:p>
+            <a:pPr algn="ctr"/>
+            <a:r>
+              <a:rPr lang="en-US" sz="700" b="1">
+                <a:solidFill>
+                  <a:schemeClr val="tx1">
+                    <a:lumMod val="85000"/>
+                    <a:lumOff val="15000"/>
+                  </a:schemeClr>
+                </a:solidFill>
+              </a:rPr>
+              <a:t>Display FFC</a:t>
+            </a:r>
+            <a:br>
+              <a:rPr lang="en-US" sz="700" b="1">
+                <a:solidFill>
+                  <a:schemeClr val="tx1">
+                    <a:lumMod val="85000"/>
+                    <a:lumOff val="15000"/>
+                  </a:schemeClr>
+                </a:solidFill>
+              </a:rPr>
+            </a:br>
+            <a:r>
+              <a:rPr lang="en-US" sz="700" b="1">
+                <a:solidFill>
+                  <a:schemeClr val="tx1">
+                    <a:lumMod val="85000"/>
+                    <a:lumOff val="15000"/>
+                  </a:schemeClr>
+                </a:solidFill>
+              </a:rPr>
+              <a:t>Cutout</a:t>
+            </a:r>
+          </a:p>
+        </p:txBody>
+      </p:sp>
+      <p:sp>
+        <p:nvSpPr>
+          <p:cNvPr id="29" name="Rectangle 28">
+            <a:extLst>
+              <a:ext uri="{FF2B5EF4-FFF2-40B4-BE49-F238E27FC236}">
+                <a16:creationId xmlns:a16="http://schemas.microsoft.com/office/drawing/2014/main" id="{92414151-6B52-D96B-C2AF-6D8F21352EAA}"/>
+              </a:ext>
+            </a:extLst>
+          </p:cNvPr>
+          <p:cNvSpPr/>
+          <p:nvPr/>
+        </p:nvSpPr>
+        <p:spPr>
+          <a:xfrm>
+            <a:off x="4070521" y="2636912"/>
+            <a:ext cx="1296144" cy="540060"/>
+          </a:xfrm>
+          <a:prstGeom prst="rect">
+            <a:avLst/>
+          </a:prstGeom>
+          <a:noFill/>
+          <a:ln w="19050">
+            <a:solidFill>
+              <a:srgbClr val="FF0000"/>
+            </a:solidFill>
+          </a:ln>
+        </p:spPr>
+        <p:style>
+          <a:lnRef idx="2">
+            <a:schemeClr val="accent1">
+              <a:shade val="15000"/>
+            </a:schemeClr>
+          </a:lnRef>
+          <a:fillRef idx="1">
+            <a:schemeClr val="accent1"/>
+          </a:fillRef>
+          <a:effectRef idx="0">
+            <a:schemeClr val="accent1"/>
+          </a:effectRef>
+          <a:fontRef idx="minor">
+            <a:schemeClr val="lt1"/>
+          </a:fontRef>
+        </p:style>
+        <p:txBody>
+          <a:bodyPr rtlCol="0" anchor="ctr"/>
+          <a:lstStyle/>
+          <a:p>
+            <a:pPr algn="ctr"/>
+            <a:endParaRPr lang="en-US">
+              <a:solidFill>
+                <a:schemeClr val="tx1">
+                  <a:lumMod val="75000"/>
+                  <a:lumOff val="25000"/>
+                </a:schemeClr>
+              </a:solidFill>
+            </a:endParaRPr>
           </a:p>
         </p:txBody>
       </p:sp>
@@ -7572,6 +7917,582 @@
 </file>
 
 <file path=ppt/slides/slide5.xml><?xml version="1.0" encoding="utf-8"?>
+<p:sld xmlns:a="http://schemas.openxmlformats.org/drawingml/2006/main" xmlns:r="http://schemas.openxmlformats.org/officeDocument/2006/relationships" xmlns:p="http://schemas.openxmlformats.org/presentationml/2006/main">
+  <p:cSld>
+    <p:bg>
+      <p:bgPr>
+        <a:solidFill>
+          <a:srgbClr val="F5F4EF"/>
+        </a:solidFill>
+        <a:effectLst/>
+      </p:bgPr>
+    </p:bg>
+    <p:spTree>
+      <p:nvGrpSpPr>
+        <p:cNvPr id="1" name="">
+          <a:extLst>
+            <a:ext uri="{FF2B5EF4-FFF2-40B4-BE49-F238E27FC236}">
+              <a16:creationId xmlns:a16="http://schemas.microsoft.com/office/drawing/2014/main" id="{04776D50-D360-937A-95AE-07D20605AE6A}"/>
+            </a:ext>
+          </a:extLst>
+        </p:cNvPr>
+        <p:cNvGrpSpPr/>
+        <p:nvPr/>
+      </p:nvGrpSpPr>
+      <p:grpSpPr>
+        <a:xfrm>
+          <a:off x="0" y="0"/>
+          <a:ext cx="0" cy="0"/>
+          <a:chOff x="0" y="0"/>
+          <a:chExt cx="0" cy="0"/>
+        </a:xfrm>
+      </p:grpSpPr>
+      <p:sp>
+        <p:nvSpPr>
+          <p:cNvPr id="4" name="Rectangle 3">
+            <a:extLst>
+              <a:ext uri="{FF2B5EF4-FFF2-40B4-BE49-F238E27FC236}">
+                <a16:creationId xmlns:a16="http://schemas.microsoft.com/office/drawing/2014/main" id="{BC536EF5-13FA-B8AB-D6E8-EB2FAAE79285}"/>
+              </a:ext>
+            </a:extLst>
+          </p:cNvPr>
+          <p:cNvSpPr/>
+          <p:nvPr/>
+        </p:nvSpPr>
+        <p:spPr>
+          <a:xfrm>
+            <a:off x="1235460" y="152636"/>
+            <a:ext cx="5868652" cy="6120680"/>
+          </a:xfrm>
+          <a:prstGeom prst="rect">
+            <a:avLst/>
+          </a:prstGeom>
+          <a:solidFill>
+            <a:srgbClr val="F5F4EF"/>
+          </a:solidFill>
+          <a:ln w="19050">
+            <a:solidFill>
+              <a:srgbClr val="840000"/>
+            </a:solidFill>
+          </a:ln>
+        </p:spPr>
+        <p:style>
+          <a:lnRef idx="2">
+            <a:schemeClr val="accent1">
+              <a:shade val="15000"/>
+            </a:schemeClr>
+          </a:lnRef>
+          <a:fillRef idx="1">
+            <a:schemeClr val="accent1"/>
+          </a:fillRef>
+          <a:effectRef idx="0">
+            <a:schemeClr val="accent1"/>
+          </a:effectRef>
+          <a:fontRef idx="minor">
+            <a:schemeClr val="lt1"/>
+          </a:fontRef>
+        </p:style>
+        <p:txBody>
+          <a:bodyPr rtlCol="0" anchor="ctr"/>
+          <a:lstStyle/>
+          <a:p>
+            <a:pPr algn="ctr"/>
+            <a:endParaRPr lang="en-US">
+              <a:solidFill>
+                <a:schemeClr val="tx1">
+                  <a:lumMod val="75000"/>
+                  <a:lumOff val="25000"/>
+                </a:schemeClr>
+              </a:solidFill>
+            </a:endParaRPr>
+          </a:p>
+        </p:txBody>
+      </p:sp>
+      <p:pic>
+        <p:nvPicPr>
+          <p:cNvPr id="6" name="Picture 5">
+            <a:extLst>
+              <a:ext uri="{FF2B5EF4-FFF2-40B4-BE49-F238E27FC236}">
+                <a16:creationId xmlns:a16="http://schemas.microsoft.com/office/drawing/2014/main" id="{E12EACED-0E19-21E6-AC73-BF7F8E5E7DA3}"/>
+              </a:ext>
+            </a:extLst>
+          </p:cNvPr>
+          <p:cNvPicPr>
+            <a:picLocks noChangeAspect="1"/>
+          </p:cNvPicPr>
+          <p:nvPr/>
+        </p:nvPicPr>
+        <p:blipFill>
+          <a:blip r:embed="rId2"/>
+          <a:stretch>
+            <a:fillRect/>
+          </a:stretch>
+        </p:blipFill>
+        <p:spPr>
+          <a:xfrm>
+            <a:off x="1713729" y="415274"/>
+            <a:ext cx="4978943" cy="4947331"/>
+          </a:xfrm>
+          <a:prstGeom prst="rect">
+            <a:avLst/>
+          </a:prstGeom>
+        </p:spPr>
+      </p:pic>
+      <p:sp>
+        <p:nvSpPr>
+          <p:cNvPr id="2" name="Title 1">
+            <a:extLst>
+              <a:ext uri="{FF2B5EF4-FFF2-40B4-BE49-F238E27FC236}">
+                <a16:creationId xmlns:a16="http://schemas.microsoft.com/office/drawing/2014/main" id="{E7217E81-ED03-849E-C61D-F5A86E7B15BA}"/>
+              </a:ext>
+            </a:extLst>
+          </p:cNvPr>
+          <p:cNvSpPr>
+            <a:spLocks noGrp="1"/>
+          </p:cNvSpPr>
+          <p:nvPr>
+            <p:ph type="title"/>
+          </p:nvPr>
+        </p:nvSpPr>
+        <p:spPr>
+          <a:xfrm>
+            <a:off x="1343472" y="5553236"/>
+            <a:ext cx="3025552" cy="720080"/>
+          </a:xfrm>
+        </p:spPr>
+        <p:txBody>
+          <a:bodyPr vert="horz" lIns="91440" tIns="45720" rIns="91440" bIns="45720" rtlCol="0" anchor="ctr">
+            <a:normAutofit/>
+          </a:bodyPr>
+          <a:lstStyle/>
+          <a:p>
+            <a:r>
+              <a:rPr lang="en-US" sz="1800" i="1">
+                <a:solidFill>
+                  <a:schemeClr val="tx1">
+                    <a:lumMod val="65000"/>
+                    <a:lumOff val="35000"/>
+                  </a:schemeClr>
+                </a:solidFill>
+                <a:latin typeface="Eras Demi ITC" panose="020B0805030504020804" pitchFamily="34" charset="0"/>
+              </a:rPr>
+              <a:t>MDD400 Ground Planes</a:t>
+            </a:r>
+          </a:p>
+        </p:txBody>
+      </p:sp>
+      <p:sp>
+        <p:nvSpPr>
+          <p:cNvPr id="26" name="TextBox 25">
+            <a:extLst>
+              <a:ext uri="{FF2B5EF4-FFF2-40B4-BE49-F238E27FC236}">
+                <a16:creationId xmlns:a16="http://schemas.microsoft.com/office/drawing/2014/main" id="{750EA29D-C1F2-C859-0EAF-A0A57E36C3C1}"/>
+              </a:ext>
+            </a:extLst>
+          </p:cNvPr>
+          <p:cNvSpPr txBox="1"/>
+          <p:nvPr/>
+        </p:nvSpPr>
+        <p:spPr>
+          <a:xfrm rot="16200000">
+            <a:off x="3562287" y="794989"/>
+            <a:ext cx="410690" cy="169277"/>
+          </a:xfrm>
+          <a:prstGeom prst="rect">
+            <a:avLst/>
+          </a:prstGeom>
+          <a:noFill/>
+        </p:spPr>
+        <p:txBody>
+          <a:bodyPr wrap="none" rtlCol="0">
+            <a:spAutoFit/>
+          </a:bodyPr>
+          <a:lstStyle/>
+          <a:p>
+            <a:pPr algn="ctr"/>
+            <a:r>
+              <a:rPr lang="en-US" sz="500" b="1">
+                <a:solidFill>
+                  <a:schemeClr val="bg1"/>
+                </a:solidFill>
+              </a:rPr>
+              <a:t>Ferrites</a:t>
+            </a:r>
+          </a:p>
+        </p:txBody>
+      </p:sp>
+      <p:sp>
+        <p:nvSpPr>
+          <p:cNvPr id="27" name="TextBox 26">
+            <a:extLst>
+              <a:ext uri="{FF2B5EF4-FFF2-40B4-BE49-F238E27FC236}">
+                <a16:creationId xmlns:a16="http://schemas.microsoft.com/office/drawing/2014/main" id="{C7775AF3-E1FC-B231-255F-995DFE9BED29}"/>
+              </a:ext>
+            </a:extLst>
+          </p:cNvPr>
+          <p:cNvSpPr txBox="1"/>
+          <p:nvPr/>
+        </p:nvSpPr>
+        <p:spPr>
+          <a:xfrm>
+            <a:off x="5688087" y="2393008"/>
+            <a:ext cx="609462" cy="169277"/>
+          </a:xfrm>
+          <a:prstGeom prst="rect">
+            <a:avLst/>
+          </a:prstGeom>
+          <a:noFill/>
+        </p:spPr>
+        <p:txBody>
+          <a:bodyPr wrap="none" rtlCol="0">
+            <a:spAutoFit/>
+          </a:bodyPr>
+          <a:lstStyle/>
+          <a:p>
+            <a:pPr algn="ctr"/>
+            <a:r>
+              <a:rPr lang="en-US" sz="500" b="1">
+                <a:solidFill>
+                  <a:schemeClr val="bg1"/>
+                </a:solidFill>
+              </a:rPr>
+              <a:t>Opto-isolators</a:t>
+            </a:r>
+          </a:p>
+        </p:txBody>
+      </p:sp>
+      <p:sp>
+        <p:nvSpPr>
+          <p:cNvPr id="28" name="TextBox 27">
+            <a:extLst>
+              <a:ext uri="{FF2B5EF4-FFF2-40B4-BE49-F238E27FC236}">
+                <a16:creationId xmlns:a16="http://schemas.microsoft.com/office/drawing/2014/main" id="{224DD0B2-845F-C9A1-3FA2-BD874A6CAD6C}"/>
+              </a:ext>
+            </a:extLst>
+          </p:cNvPr>
+          <p:cNvSpPr txBox="1"/>
+          <p:nvPr/>
+        </p:nvSpPr>
+        <p:spPr>
+          <a:xfrm>
+            <a:off x="4302654" y="2803817"/>
+            <a:ext cx="671979" cy="307777"/>
+          </a:xfrm>
+          <a:prstGeom prst="rect">
+            <a:avLst/>
+          </a:prstGeom>
+          <a:noFill/>
+        </p:spPr>
+        <p:txBody>
+          <a:bodyPr wrap="none" rtlCol="0">
+            <a:spAutoFit/>
+          </a:bodyPr>
+          <a:lstStyle/>
+          <a:p>
+            <a:pPr algn="ctr"/>
+            <a:r>
+              <a:rPr lang="en-US" sz="700" b="1">
+                <a:solidFill>
+                  <a:schemeClr val="tx1">
+                    <a:lumMod val="85000"/>
+                    <a:lumOff val="15000"/>
+                  </a:schemeClr>
+                </a:solidFill>
+              </a:rPr>
+              <a:t>Display FFC</a:t>
+            </a:r>
+            <a:br>
+              <a:rPr lang="en-US" sz="700" b="1">
+                <a:solidFill>
+                  <a:schemeClr val="tx1">
+                    <a:lumMod val="85000"/>
+                    <a:lumOff val="15000"/>
+                  </a:schemeClr>
+                </a:solidFill>
+              </a:rPr>
+            </a:br>
+            <a:r>
+              <a:rPr lang="en-US" sz="700" b="1">
+                <a:solidFill>
+                  <a:schemeClr val="tx1">
+                    <a:lumMod val="85000"/>
+                    <a:lumOff val="15000"/>
+                  </a:schemeClr>
+                </a:solidFill>
+              </a:rPr>
+              <a:t>Cutout</a:t>
+            </a:r>
+          </a:p>
+        </p:txBody>
+      </p:sp>
+      <p:sp>
+        <p:nvSpPr>
+          <p:cNvPr id="3" name="Rectangle 2">
+            <a:extLst>
+              <a:ext uri="{FF2B5EF4-FFF2-40B4-BE49-F238E27FC236}">
+                <a16:creationId xmlns:a16="http://schemas.microsoft.com/office/drawing/2014/main" id="{24616145-BD9B-5A7E-5896-7EA21D594744}"/>
+              </a:ext>
+            </a:extLst>
+          </p:cNvPr>
+          <p:cNvSpPr/>
+          <p:nvPr/>
+        </p:nvSpPr>
+        <p:spPr>
+          <a:xfrm>
+            <a:off x="1893632" y="3897052"/>
+            <a:ext cx="1656183" cy="1276896"/>
+          </a:xfrm>
+          <a:prstGeom prst="rect">
+            <a:avLst/>
+          </a:prstGeom>
+          <a:noFill/>
+          <a:ln w="19050">
+            <a:solidFill>
+              <a:srgbClr val="FFFF00"/>
+            </a:solidFill>
+          </a:ln>
+        </p:spPr>
+        <p:style>
+          <a:lnRef idx="2">
+            <a:schemeClr val="accent1">
+              <a:shade val="15000"/>
+            </a:schemeClr>
+          </a:lnRef>
+          <a:fillRef idx="1">
+            <a:schemeClr val="accent1"/>
+          </a:fillRef>
+          <a:effectRef idx="0">
+            <a:schemeClr val="accent1"/>
+          </a:effectRef>
+          <a:fontRef idx="minor">
+            <a:schemeClr val="lt1"/>
+          </a:fontRef>
+        </p:style>
+        <p:txBody>
+          <a:bodyPr rtlCol="0" anchor="ctr"/>
+          <a:lstStyle/>
+          <a:p>
+            <a:pPr algn="ctr"/>
+            <a:endParaRPr lang="en-US">
+              <a:solidFill>
+                <a:schemeClr val="tx1">
+                  <a:lumMod val="75000"/>
+                  <a:lumOff val="25000"/>
+                </a:schemeClr>
+              </a:solidFill>
+            </a:endParaRPr>
+          </a:p>
+        </p:txBody>
+      </p:sp>
+      <p:sp>
+        <p:nvSpPr>
+          <p:cNvPr id="5" name="Speech Bubble: Rectangle with Corners Rounded 4">
+            <a:extLst>
+              <a:ext uri="{FF2B5EF4-FFF2-40B4-BE49-F238E27FC236}">
+                <a16:creationId xmlns:a16="http://schemas.microsoft.com/office/drawing/2014/main" id="{60D38A7C-783F-26D5-5EDF-F20641F8F94B}"/>
+              </a:ext>
+            </a:extLst>
+          </p:cNvPr>
+          <p:cNvSpPr/>
+          <p:nvPr/>
+        </p:nvSpPr>
+        <p:spPr>
+          <a:xfrm>
+            <a:off x="5433317" y="1572911"/>
+            <a:ext cx="1044116" cy="432048"/>
+          </a:xfrm>
+          <a:prstGeom prst="wedgeRoundRectCallout">
+            <a:avLst>
+              <a:gd name="adj1" fmla="val -45058"/>
+              <a:gd name="adj2" fmla="val 147744"/>
+              <a:gd name="adj3" fmla="val 16667"/>
+            </a:avLst>
+          </a:prstGeom>
+          <a:solidFill>
+            <a:srgbClr val="F5F4EF"/>
+          </a:solidFill>
+          <a:ln w="19050">
+            <a:solidFill>
+              <a:srgbClr val="840000"/>
+            </a:solidFill>
+          </a:ln>
+        </p:spPr>
+        <p:style>
+          <a:lnRef idx="2">
+            <a:schemeClr val="accent1">
+              <a:shade val="15000"/>
+            </a:schemeClr>
+          </a:lnRef>
+          <a:fillRef idx="1">
+            <a:schemeClr val="accent1"/>
+          </a:fillRef>
+          <a:effectRef idx="0">
+            <a:schemeClr val="accent1"/>
+          </a:effectRef>
+          <a:fontRef idx="minor">
+            <a:schemeClr val="lt1"/>
+          </a:fontRef>
+        </p:style>
+        <p:txBody>
+          <a:bodyPr rtlCol="0" anchor="ctr"/>
+          <a:lstStyle/>
+          <a:p>
+            <a:pPr algn="ctr"/>
+            <a:r>
+              <a:rPr lang="en-US" sz="800" b="1">
+                <a:solidFill>
+                  <a:schemeClr val="tx1">
+                    <a:lumMod val="75000"/>
+                    <a:lumOff val="25000"/>
+                  </a:schemeClr>
+                </a:solidFill>
+              </a:rPr>
+              <a:t>No components or traces in this area</a:t>
+            </a:r>
+          </a:p>
+        </p:txBody>
+      </p:sp>
+      <p:sp>
+        <p:nvSpPr>
+          <p:cNvPr id="11" name="Rectangle 10">
+            <a:extLst>
+              <a:ext uri="{FF2B5EF4-FFF2-40B4-BE49-F238E27FC236}">
+                <a16:creationId xmlns:a16="http://schemas.microsoft.com/office/drawing/2014/main" id="{F85345CF-C1CD-C635-DB5A-F748C20213F2}"/>
+              </a:ext>
+            </a:extLst>
+          </p:cNvPr>
+          <p:cNvSpPr/>
+          <p:nvPr/>
+        </p:nvSpPr>
+        <p:spPr>
+          <a:xfrm>
+            <a:off x="3810551" y="2472958"/>
+            <a:ext cx="1656183" cy="2772308"/>
+          </a:xfrm>
+          <a:prstGeom prst="rect">
+            <a:avLst/>
+          </a:prstGeom>
+          <a:noFill/>
+          <a:ln w="19050">
+            <a:solidFill>
+              <a:srgbClr val="FFFF00"/>
+            </a:solidFill>
+          </a:ln>
+        </p:spPr>
+        <p:style>
+          <a:lnRef idx="2">
+            <a:schemeClr val="accent1">
+              <a:shade val="15000"/>
+            </a:schemeClr>
+          </a:lnRef>
+          <a:fillRef idx="1">
+            <a:schemeClr val="accent1"/>
+          </a:fillRef>
+          <a:effectRef idx="0">
+            <a:schemeClr val="accent1"/>
+          </a:effectRef>
+          <a:fontRef idx="minor">
+            <a:schemeClr val="lt1"/>
+          </a:fontRef>
+        </p:style>
+        <p:txBody>
+          <a:bodyPr rtlCol="0" anchor="ctr"/>
+          <a:lstStyle/>
+          <a:p>
+            <a:pPr algn="ctr"/>
+            <a:endParaRPr lang="en-US">
+              <a:solidFill>
+                <a:schemeClr val="tx1">
+                  <a:lumMod val="75000"/>
+                  <a:lumOff val="25000"/>
+                </a:schemeClr>
+              </a:solidFill>
+            </a:endParaRPr>
+          </a:p>
+        </p:txBody>
+      </p:sp>
+      <p:sp>
+        <p:nvSpPr>
+          <p:cNvPr id="13" name="Speech Bubble: Rectangle with Corners Rounded 12">
+            <a:extLst>
+              <a:ext uri="{FF2B5EF4-FFF2-40B4-BE49-F238E27FC236}">
+                <a16:creationId xmlns:a16="http://schemas.microsoft.com/office/drawing/2014/main" id="{89844778-551B-BB2B-445E-9CE52BA3AF72}"/>
+              </a:ext>
+            </a:extLst>
+          </p:cNvPr>
+          <p:cNvSpPr/>
+          <p:nvPr/>
+        </p:nvSpPr>
+        <p:spPr>
+          <a:xfrm>
+            <a:off x="2274334" y="2981467"/>
+            <a:ext cx="1044116" cy="432048"/>
+          </a:xfrm>
+          <a:prstGeom prst="wedgeRoundRectCallout">
+            <a:avLst>
+              <a:gd name="adj1" fmla="val -45058"/>
+              <a:gd name="adj2" fmla="val 147744"/>
+              <a:gd name="adj3" fmla="val 16667"/>
+            </a:avLst>
+          </a:prstGeom>
+          <a:solidFill>
+            <a:srgbClr val="F5F4EF"/>
+          </a:solidFill>
+          <a:ln w="19050">
+            <a:solidFill>
+              <a:srgbClr val="840000"/>
+            </a:solidFill>
+          </a:ln>
+        </p:spPr>
+        <p:style>
+          <a:lnRef idx="2">
+            <a:schemeClr val="accent1">
+              <a:shade val="15000"/>
+            </a:schemeClr>
+          </a:lnRef>
+          <a:fillRef idx="1">
+            <a:schemeClr val="accent1"/>
+          </a:fillRef>
+          <a:effectRef idx="0">
+            <a:schemeClr val="accent1"/>
+          </a:effectRef>
+          <a:fontRef idx="minor">
+            <a:schemeClr val="lt1"/>
+          </a:fontRef>
+        </p:style>
+        <p:txBody>
+          <a:bodyPr rtlCol="0" anchor="ctr"/>
+          <a:lstStyle/>
+          <a:p>
+            <a:pPr algn="ctr"/>
+            <a:r>
+              <a:rPr lang="en-US" sz="800" b="1">
+                <a:solidFill>
+                  <a:schemeClr val="tx1">
+                    <a:lumMod val="75000"/>
+                    <a:lumOff val="25000"/>
+                  </a:schemeClr>
+                </a:solidFill>
+              </a:rPr>
+              <a:t>No components or traces in this area</a:t>
+            </a:r>
+          </a:p>
+        </p:txBody>
+      </p:sp>
+    </p:spTree>
+    <p:extLst>
+      <p:ext uri="{BB962C8B-B14F-4D97-AF65-F5344CB8AC3E}">
+        <p14:creationId xmlns:p14="http://schemas.microsoft.com/office/powerpoint/2010/main" val="1425979937"/>
+      </p:ext>
+    </p:extLst>
+  </p:cSld>
+  <p:clrMapOvr>
+    <a:masterClrMapping/>
+  </p:clrMapOvr>
+</p:sld>
+</file>
+
+<file path=ppt/slides/slide6.xml><?xml version="1.0" encoding="utf-8"?>
 <p:sld xmlns:a="http://schemas.openxmlformats.org/drawingml/2006/main" xmlns:r="http://schemas.openxmlformats.org/officeDocument/2006/relationships" xmlns:p="http://schemas.openxmlformats.org/presentationml/2006/main">
   <p:cSld>
     <p:spTree>

</xml_diff>

<commit_message>
v0.1.5 New VCAN design section.
</commit_message>
<xml_diff>
--- a/.assets/diagrams.pptx
+++ b/.assets/diagrams.pptx
@@ -5,7 +5,7 @@
     <p:sldMasterId id="2147483648" r:id="rId1"/>
   </p:sldMasterIdLst>
   <p:notesMasterIdLst>
-    <p:notesMasterId r:id="rId8"/>
+    <p:notesMasterId r:id="rId9"/>
   </p:notesMasterIdLst>
   <p:sldIdLst>
     <p:sldId id="256" r:id="rId2"/>
@@ -14,6 +14,7 @@
     <p:sldId id="258" r:id="rId5"/>
     <p:sldId id="261" r:id="rId6"/>
     <p:sldId id="259" r:id="rId7"/>
+    <p:sldId id="262" r:id="rId8"/>
   </p:sldIdLst>
   <p:sldSz cx="12192000" cy="6858000"/>
   <p:notesSz cx="6858000" cy="9144000"/>
@@ -202,7 +203,7 @@
           <a:p>
             <a:fld id="{3709B85E-FD1D-4C87-B36A-F5C287A24482}" type="datetimeFigureOut">
               <a:rPr lang="en-US" smtClean="0"/>
-              <a:t>7/28/2025</a:t>
+              <a:t>7/31/2025</a:t>
             </a:fld>
             <a:endParaRPr lang="en-US"/>
           </a:p>
@@ -700,7 +701,7 @@
           <a:p>
             <a:fld id="{67C30635-7F4C-458C-AB0B-9951B311FD29}" type="datetimeFigureOut">
               <a:rPr lang="en-US" smtClean="0"/>
-              <a:t>7/28/2025</a:t>
+              <a:t>7/31/2025</a:t>
             </a:fld>
             <a:endParaRPr lang="en-US"/>
           </a:p>
@@ -898,7 +899,7 @@
           <a:p>
             <a:fld id="{67C30635-7F4C-458C-AB0B-9951B311FD29}" type="datetimeFigureOut">
               <a:rPr lang="en-US" smtClean="0"/>
-              <a:t>7/28/2025</a:t>
+              <a:t>7/31/2025</a:t>
             </a:fld>
             <a:endParaRPr lang="en-US"/>
           </a:p>
@@ -1106,7 +1107,7 @@
           <a:p>
             <a:fld id="{67C30635-7F4C-458C-AB0B-9951B311FD29}" type="datetimeFigureOut">
               <a:rPr lang="en-US" smtClean="0"/>
-              <a:t>7/28/2025</a:t>
+              <a:t>7/31/2025</a:t>
             </a:fld>
             <a:endParaRPr lang="en-US"/>
           </a:p>
@@ -1304,7 +1305,7 @@
           <a:p>
             <a:fld id="{67C30635-7F4C-458C-AB0B-9951B311FD29}" type="datetimeFigureOut">
               <a:rPr lang="en-US" smtClean="0"/>
-              <a:t>7/28/2025</a:t>
+              <a:t>7/31/2025</a:t>
             </a:fld>
             <a:endParaRPr lang="en-US"/>
           </a:p>
@@ -1579,7 +1580,7 @@
           <a:p>
             <a:fld id="{67C30635-7F4C-458C-AB0B-9951B311FD29}" type="datetimeFigureOut">
               <a:rPr lang="en-US" smtClean="0"/>
-              <a:t>7/28/2025</a:t>
+              <a:t>7/31/2025</a:t>
             </a:fld>
             <a:endParaRPr lang="en-US"/>
           </a:p>
@@ -1844,7 +1845,7 @@
           <a:p>
             <a:fld id="{67C30635-7F4C-458C-AB0B-9951B311FD29}" type="datetimeFigureOut">
               <a:rPr lang="en-US" smtClean="0"/>
-              <a:t>7/28/2025</a:t>
+              <a:t>7/31/2025</a:t>
             </a:fld>
             <a:endParaRPr lang="en-US"/>
           </a:p>
@@ -2256,7 +2257,7 @@
           <a:p>
             <a:fld id="{67C30635-7F4C-458C-AB0B-9951B311FD29}" type="datetimeFigureOut">
               <a:rPr lang="en-US" smtClean="0"/>
-              <a:t>7/28/2025</a:t>
+              <a:t>7/31/2025</a:t>
             </a:fld>
             <a:endParaRPr lang="en-US"/>
           </a:p>
@@ -2397,7 +2398,7 @@
           <a:p>
             <a:fld id="{67C30635-7F4C-458C-AB0B-9951B311FD29}" type="datetimeFigureOut">
               <a:rPr lang="en-US" smtClean="0"/>
-              <a:t>7/28/2025</a:t>
+              <a:t>7/31/2025</a:t>
             </a:fld>
             <a:endParaRPr lang="en-US"/>
           </a:p>
@@ -2510,7 +2511,7 @@
           <a:p>
             <a:fld id="{67C30635-7F4C-458C-AB0B-9951B311FD29}" type="datetimeFigureOut">
               <a:rPr lang="en-US" smtClean="0"/>
-              <a:t>7/28/2025</a:t>
+              <a:t>7/31/2025</a:t>
             </a:fld>
             <a:endParaRPr lang="en-US"/>
           </a:p>
@@ -2821,7 +2822,7 @@
           <a:p>
             <a:fld id="{67C30635-7F4C-458C-AB0B-9951B311FD29}" type="datetimeFigureOut">
               <a:rPr lang="en-US" smtClean="0"/>
-              <a:t>7/28/2025</a:t>
+              <a:t>7/31/2025</a:t>
             </a:fld>
             <a:endParaRPr lang="en-US"/>
           </a:p>
@@ -3109,7 +3110,7 @@
           <a:p>
             <a:fld id="{67C30635-7F4C-458C-AB0B-9951B311FD29}" type="datetimeFigureOut">
               <a:rPr lang="en-US" smtClean="0"/>
-              <a:t>7/28/2025</a:t>
+              <a:t>7/31/2025</a:t>
             </a:fld>
             <a:endParaRPr lang="en-US"/>
           </a:p>
@@ -3353,7 +3354,7 @@
           <a:p>
             <a:fld id="{67C30635-7F4C-458C-AB0B-9951B311FD29}" type="datetimeFigureOut">
               <a:rPr lang="en-US" smtClean="0"/>
-              <a:t>7/28/2025</a:t>
+              <a:t>7/31/2025</a:t>
             </a:fld>
             <a:endParaRPr lang="en-US"/>
           </a:p>
@@ -9206,6 +9207,224 @@
     <p:extLst>
       <p:ext uri="{BB962C8B-B14F-4D97-AF65-F5344CB8AC3E}">
         <p14:creationId xmlns:p14="http://schemas.microsoft.com/office/powerpoint/2010/main" val="1794798923"/>
+      </p:ext>
+    </p:extLst>
+  </p:cSld>
+  <p:clrMapOvr>
+    <a:masterClrMapping/>
+  </p:clrMapOvr>
+</p:sld>
+</file>
+
+<file path=ppt/slides/slide7.xml><?xml version="1.0" encoding="utf-8"?>
+<p:sld xmlns:a="http://schemas.openxmlformats.org/drawingml/2006/main" xmlns:r="http://schemas.openxmlformats.org/officeDocument/2006/relationships" xmlns:p="http://schemas.openxmlformats.org/presentationml/2006/main">
+  <p:cSld>
+    <p:bg>
+      <p:bgPr>
+        <a:solidFill>
+          <a:srgbClr val="F5F4EF"/>
+        </a:solidFill>
+        <a:effectLst/>
+      </p:bgPr>
+    </p:bg>
+    <p:spTree>
+      <p:nvGrpSpPr>
+        <p:cNvPr id="1" name="">
+          <a:extLst>
+            <a:ext uri="{FF2B5EF4-FFF2-40B4-BE49-F238E27FC236}">
+              <a16:creationId xmlns:a16="http://schemas.microsoft.com/office/drawing/2014/main" id="{DC973DDE-3556-6273-883D-E3759EAF2496}"/>
+            </a:ext>
+          </a:extLst>
+        </p:cNvPr>
+        <p:cNvGrpSpPr/>
+        <p:nvPr/>
+      </p:nvGrpSpPr>
+      <p:grpSpPr>
+        <a:xfrm>
+          <a:off x="0" y="0"/>
+          <a:ext cx="0" cy="0"/>
+          <a:chOff x="0" y="0"/>
+          <a:chExt cx="0" cy="0"/>
+        </a:xfrm>
+      </p:grpSpPr>
+      <p:sp>
+        <p:nvSpPr>
+          <p:cNvPr id="4" name="Rectangle 3">
+            <a:extLst>
+              <a:ext uri="{FF2B5EF4-FFF2-40B4-BE49-F238E27FC236}">
+                <a16:creationId xmlns:a16="http://schemas.microsoft.com/office/drawing/2014/main" id="{98D0CEA3-D61B-5199-66C5-566C884A81BB}"/>
+              </a:ext>
+            </a:extLst>
+          </p:cNvPr>
+          <p:cNvSpPr/>
+          <p:nvPr/>
+        </p:nvSpPr>
+        <p:spPr>
+          <a:xfrm>
+            <a:off x="1019436" y="1844824"/>
+            <a:ext cx="6624736" cy="4428492"/>
+          </a:xfrm>
+          <a:prstGeom prst="rect">
+            <a:avLst/>
+          </a:prstGeom>
+          <a:solidFill>
+            <a:srgbClr val="F5F4EF"/>
+          </a:solidFill>
+          <a:ln w="19050">
+            <a:solidFill>
+              <a:srgbClr val="840000"/>
+            </a:solidFill>
+          </a:ln>
+        </p:spPr>
+        <p:style>
+          <a:lnRef idx="2">
+            <a:schemeClr val="accent1">
+              <a:shade val="15000"/>
+            </a:schemeClr>
+          </a:lnRef>
+          <a:fillRef idx="1">
+            <a:schemeClr val="accent1"/>
+          </a:fillRef>
+          <a:effectRef idx="0">
+            <a:schemeClr val="accent1"/>
+          </a:effectRef>
+          <a:fontRef idx="minor">
+            <a:schemeClr val="lt1"/>
+          </a:fontRef>
+        </p:style>
+        <p:txBody>
+          <a:bodyPr rtlCol="0" anchor="ctr"/>
+          <a:lstStyle/>
+          <a:p>
+            <a:pPr algn="ctr"/>
+            <a:endParaRPr lang="en-US">
+              <a:solidFill>
+                <a:schemeClr val="tx1">
+                  <a:lumMod val="75000"/>
+                  <a:lumOff val="25000"/>
+                </a:schemeClr>
+              </a:solidFill>
+            </a:endParaRPr>
+          </a:p>
+        </p:txBody>
+      </p:sp>
+      <p:sp>
+        <p:nvSpPr>
+          <p:cNvPr id="2" name="Title 1">
+            <a:extLst>
+              <a:ext uri="{FF2B5EF4-FFF2-40B4-BE49-F238E27FC236}">
+                <a16:creationId xmlns:a16="http://schemas.microsoft.com/office/drawing/2014/main" id="{3A7BCF9E-6035-669C-5ADB-8BD409FB9213}"/>
+              </a:ext>
+            </a:extLst>
+          </p:cNvPr>
+          <p:cNvSpPr>
+            <a:spLocks noGrp="1"/>
+          </p:cNvSpPr>
+          <p:nvPr>
+            <p:ph type="title"/>
+          </p:nvPr>
+        </p:nvSpPr>
+        <p:spPr>
+          <a:xfrm>
+            <a:off x="1343472" y="5553236"/>
+            <a:ext cx="3780420" cy="720080"/>
+          </a:xfrm>
+        </p:spPr>
+        <p:txBody>
+          <a:bodyPr vert="horz" lIns="91440" tIns="45720" rIns="91440" bIns="45720" rtlCol="0" anchor="ctr">
+            <a:normAutofit/>
+          </a:bodyPr>
+          <a:lstStyle/>
+          <a:p>
+            <a:r>
+              <a:rPr lang="en-US" sz="1600" i="1">
+                <a:solidFill>
+                  <a:schemeClr val="tx1">
+                    <a:lumMod val="65000"/>
+                    <a:lumOff val="35000"/>
+                  </a:schemeClr>
+                </a:solidFill>
+                <a:latin typeface="Eras Demi ITC" panose="020B0805030504020804" pitchFamily="34" charset="0"/>
+              </a:rPr>
+              <a:t>SMPS Ground Plane and Layout</a:t>
+            </a:r>
+          </a:p>
+        </p:txBody>
+      </p:sp>
+      <p:sp>
+        <p:nvSpPr>
+          <p:cNvPr id="26" name="TextBox 25">
+            <a:extLst>
+              <a:ext uri="{FF2B5EF4-FFF2-40B4-BE49-F238E27FC236}">
+                <a16:creationId xmlns:a16="http://schemas.microsoft.com/office/drawing/2014/main" id="{FB571846-D08F-4F66-274B-CDE43FE5E5FA}"/>
+              </a:ext>
+            </a:extLst>
+          </p:cNvPr>
+          <p:cNvSpPr txBox="1"/>
+          <p:nvPr/>
+        </p:nvSpPr>
+        <p:spPr>
+          <a:xfrm rot="16200000">
+            <a:off x="3562287" y="794989"/>
+            <a:ext cx="410690" cy="169277"/>
+          </a:xfrm>
+          <a:prstGeom prst="rect">
+            <a:avLst/>
+          </a:prstGeom>
+          <a:noFill/>
+        </p:spPr>
+        <p:txBody>
+          <a:bodyPr wrap="none" rtlCol="0">
+            <a:spAutoFit/>
+          </a:bodyPr>
+          <a:lstStyle/>
+          <a:p>
+            <a:pPr algn="ctr"/>
+            <a:r>
+              <a:rPr lang="en-US" sz="500" b="1">
+                <a:solidFill>
+                  <a:schemeClr val="bg1"/>
+                </a:solidFill>
+              </a:rPr>
+              <a:t>Ferrites</a:t>
+            </a:r>
+          </a:p>
+        </p:txBody>
+      </p:sp>
+      <p:pic>
+        <p:nvPicPr>
+          <p:cNvPr id="5" name="Picture 4">
+            <a:extLst>
+              <a:ext uri="{FF2B5EF4-FFF2-40B4-BE49-F238E27FC236}">
+                <a16:creationId xmlns:a16="http://schemas.microsoft.com/office/drawing/2014/main" id="{C14E5FA6-45DF-A9E3-6EDB-6A71F2D92833}"/>
+              </a:ext>
+            </a:extLst>
+          </p:cNvPr>
+          <p:cNvPicPr>
+            <a:picLocks noChangeAspect="1"/>
+          </p:cNvPicPr>
+          <p:nvPr/>
+        </p:nvPicPr>
+        <p:blipFill>
+          <a:blip r:embed="rId2"/>
+          <a:stretch>
+            <a:fillRect/>
+          </a:stretch>
+        </p:blipFill>
+        <p:spPr>
+          <a:xfrm>
+            <a:off x="1523492" y="2520360"/>
+            <a:ext cx="5832648" cy="3144245"/>
+          </a:xfrm>
+          <a:prstGeom prst="rect">
+            <a:avLst/>
+          </a:prstGeom>
+        </p:spPr>
+      </p:pic>
+    </p:spTree>
+    <p:extLst>
+      <p:ext uri="{BB962C8B-B14F-4D97-AF65-F5344CB8AC3E}">
+        <p14:creationId xmlns:p14="http://schemas.microsoft.com/office/powerpoint/2010/main" val="2759011068"/>
       </p:ext>
     </p:extLst>
   </p:cSld>

</xml_diff>

<commit_message>
v0.1.6 Complete re-structure in progress.
</commit_message>
<xml_diff>
--- a/.assets/diagrams.pptx
+++ b/.assets/diagrams.pptx
@@ -5,16 +5,17 @@
     <p:sldMasterId id="2147483648" r:id="rId1"/>
   </p:sldMasterIdLst>
   <p:notesMasterIdLst>
-    <p:notesMasterId r:id="rId9"/>
+    <p:notesMasterId r:id="rId10"/>
   </p:notesMasterIdLst>
   <p:sldIdLst>
     <p:sldId id="256" r:id="rId2"/>
-    <p:sldId id="257" r:id="rId3"/>
+    <p:sldId id="263" r:id="rId3"/>
     <p:sldId id="260" r:id="rId4"/>
-    <p:sldId id="258" r:id="rId5"/>
-    <p:sldId id="261" r:id="rId6"/>
-    <p:sldId id="259" r:id="rId7"/>
-    <p:sldId id="262" r:id="rId8"/>
+    <p:sldId id="257" r:id="rId5"/>
+    <p:sldId id="258" r:id="rId6"/>
+    <p:sldId id="261" r:id="rId7"/>
+    <p:sldId id="259" r:id="rId8"/>
+    <p:sldId id="262" r:id="rId9"/>
   </p:sldIdLst>
   <p:sldSz cx="12192000" cy="6858000"/>
   <p:notesSz cx="6858000" cy="9144000"/>
@@ -203,7 +204,7 @@
           <a:p>
             <a:fld id="{3709B85E-FD1D-4C87-B36A-F5C287A24482}" type="datetimeFigureOut">
               <a:rPr lang="en-US" smtClean="0"/>
-              <a:t>7/31/2025</a:t>
+              <a:t>8/1/2025</a:t>
             </a:fld>
             <a:endParaRPr lang="en-US"/>
           </a:p>
@@ -535,7 +536,91 @@
           <a:p>
             <a:fld id="{9CD017A1-7FA2-4FB5-A9B9-704691091C1D}" type="slidenum">
               <a:rPr lang="en-US" smtClean="0"/>
-              <a:t>6</a:t>
+              <a:t>3</a:t>
+            </a:fld>
+            <a:endParaRPr lang="en-US"/>
+          </a:p>
+        </p:txBody>
+      </p:sp>
+    </p:spTree>
+    <p:extLst>
+      <p:ext uri="{BB962C8B-B14F-4D97-AF65-F5344CB8AC3E}">
+        <p14:creationId xmlns:p14="http://schemas.microsoft.com/office/powerpoint/2010/main" val="55493619"/>
+      </p:ext>
+    </p:extLst>
+  </p:cSld>
+  <p:clrMapOvr>
+    <a:masterClrMapping/>
+  </p:clrMapOvr>
+</p:notes>
+</file>
+
+<file path=ppt/notesSlides/notesSlide2.xml><?xml version="1.0" encoding="utf-8"?>
+<p:notes xmlns:a="http://schemas.openxmlformats.org/drawingml/2006/main" xmlns:r="http://schemas.openxmlformats.org/officeDocument/2006/relationships" xmlns:p="http://schemas.openxmlformats.org/presentationml/2006/main">
+  <p:cSld>
+    <p:spTree>
+      <p:nvGrpSpPr>
+        <p:cNvPr id="1" name=""/>
+        <p:cNvGrpSpPr/>
+        <p:nvPr/>
+      </p:nvGrpSpPr>
+      <p:grpSpPr>
+        <a:xfrm>
+          <a:off x="0" y="0"/>
+          <a:ext cx="0" cy="0"/>
+          <a:chOff x="0" y="0"/>
+          <a:chExt cx="0" cy="0"/>
+        </a:xfrm>
+      </p:grpSpPr>
+      <p:sp>
+        <p:nvSpPr>
+          <p:cNvPr id="2" name="Slide Image Placeholder 1"/>
+          <p:cNvSpPr>
+            <a:spLocks noGrp="1" noRot="1" noChangeAspect="1"/>
+          </p:cNvSpPr>
+          <p:nvPr>
+            <p:ph type="sldImg"/>
+          </p:nvPr>
+        </p:nvSpPr>
+        <p:spPr/>
+      </p:sp>
+      <p:sp>
+        <p:nvSpPr>
+          <p:cNvPr id="3" name="Notes Placeholder 2"/>
+          <p:cNvSpPr>
+            <a:spLocks noGrp="1"/>
+          </p:cNvSpPr>
+          <p:nvPr>
+            <p:ph type="body" idx="1"/>
+          </p:nvPr>
+        </p:nvSpPr>
+        <p:spPr/>
+        <p:txBody>
+          <a:bodyPr/>
+          <a:lstStyle/>
+          <a:p>
+            <a:endParaRPr lang="en-US"/>
+          </a:p>
+        </p:txBody>
+      </p:sp>
+      <p:sp>
+        <p:nvSpPr>
+          <p:cNvPr id="4" name="Slide Number Placeholder 3"/>
+          <p:cNvSpPr>
+            <a:spLocks noGrp="1"/>
+          </p:cNvSpPr>
+          <p:nvPr>
+            <p:ph type="sldNum" sz="quarter" idx="5"/>
+          </p:nvPr>
+        </p:nvSpPr>
+        <p:spPr/>
+        <p:txBody>
+          <a:bodyPr/>
+          <a:lstStyle/>
+          <a:p>
+            <a:fld id="{9CD017A1-7FA2-4FB5-A9B9-704691091C1D}" type="slidenum">
+              <a:rPr lang="en-US" smtClean="0"/>
+              <a:t>7</a:t>
             </a:fld>
             <a:endParaRPr lang="en-US"/>
           </a:p>
@@ -701,7 +786,7 @@
           <a:p>
             <a:fld id="{67C30635-7F4C-458C-AB0B-9951B311FD29}" type="datetimeFigureOut">
               <a:rPr lang="en-US" smtClean="0"/>
-              <a:t>7/31/2025</a:t>
+              <a:t>8/1/2025</a:t>
             </a:fld>
             <a:endParaRPr lang="en-US"/>
           </a:p>
@@ -899,7 +984,7 @@
           <a:p>
             <a:fld id="{67C30635-7F4C-458C-AB0B-9951B311FD29}" type="datetimeFigureOut">
               <a:rPr lang="en-US" smtClean="0"/>
-              <a:t>7/31/2025</a:t>
+              <a:t>8/1/2025</a:t>
             </a:fld>
             <a:endParaRPr lang="en-US"/>
           </a:p>
@@ -1107,7 +1192,7 @@
           <a:p>
             <a:fld id="{67C30635-7F4C-458C-AB0B-9951B311FD29}" type="datetimeFigureOut">
               <a:rPr lang="en-US" smtClean="0"/>
-              <a:t>7/31/2025</a:t>
+              <a:t>8/1/2025</a:t>
             </a:fld>
             <a:endParaRPr lang="en-US"/>
           </a:p>
@@ -1305,7 +1390,7 @@
           <a:p>
             <a:fld id="{67C30635-7F4C-458C-AB0B-9951B311FD29}" type="datetimeFigureOut">
               <a:rPr lang="en-US" smtClean="0"/>
-              <a:t>7/31/2025</a:t>
+              <a:t>8/1/2025</a:t>
             </a:fld>
             <a:endParaRPr lang="en-US"/>
           </a:p>
@@ -1580,7 +1665,7 @@
           <a:p>
             <a:fld id="{67C30635-7F4C-458C-AB0B-9951B311FD29}" type="datetimeFigureOut">
               <a:rPr lang="en-US" smtClean="0"/>
-              <a:t>7/31/2025</a:t>
+              <a:t>8/1/2025</a:t>
             </a:fld>
             <a:endParaRPr lang="en-US"/>
           </a:p>
@@ -1845,7 +1930,7 @@
           <a:p>
             <a:fld id="{67C30635-7F4C-458C-AB0B-9951B311FD29}" type="datetimeFigureOut">
               <a:rPr lang="en-US" smtClean="0"/>
-              <a:t>7/31/2025</a:t>
+              <a:t>8/1/2025</a:t>
             </a:fld>
             <a:endParaRPr lang="en-US"/>
           </a:p>
@@ -2257,7 +2342,7 @@
           <a:p>
             <a:fld id="{67C30635-7F4C-458C-AB0B-9951B311FD29}" type="datetimeFigureOut">
               <a:rPr lang="en-US" smtClean="0"/>
-              <a:t>7/31/2025</a:t>
+              <a:t>8/1/2025</a:t>
             </a:fld>
             <a:endParaRPr lang="en-US"/>
           </a:p>
@@ -2398,7 +2483,7 @@
           <a:p>
             <a:fld id="{67C30635-7F4C-458C-AB0B-9951B311FD29}" type="datetimeFigureOut">
               <a:rPr lang="en-US" smtClean="0"/>
-              <a:t>7/31/2025</a:t>
+              <a:t>8/1/2025</a:t>
             </a:fld>
             <a:endParaRPr lang="en-US"/>
           </a:p>
@@ -2511,7 +2596,7 @@
           <a:p>
             <a:fld id="{67C30635-7F4C-458C-AB0B-9951B311FD29}" type="datetimeFigureOut">
               <a:rPr lang="en-US" smtClean="0"/>
-              <a:t>7/31/2025</a:t>
+              <a:t>8/1/2025</a:t>
             </a:fld>
             <a:endParaRPr lang="en-US"/>
           </a:p>
@@ -2822,7 +2907,7 @@
           <a:p>
             <a:fld id="{67C30635-7F4C-458C-AB0B-9951B311FD29}" type="datetimeFigureOut">
               <a:rPr lang="en-US" smtClean="0"/>
-              <a:t>7/31/2025</a:t>
+              <a:t>8/1/2025</a:t>
             </a:fld>
             <a:endParaRPr lang="en-US"/>
           </a:p>
@@ -3110,7 +3195,7 @@
           <a:p>
             <a:fld id="{67C30635-7F4C-458C-AB0B-9951B311FD29}" type="datetimeFigureOut">
               <a:rPr lang="en-US" smtClean="0"/>
-              <a:t>7/31/2025</a:t>
+              <a:t>8/1/2025</a:t>
             </a:fld>
             <a:endParaRPr lang="en-US"/>
           </a:p>
@@ -3354,7 +3439,7 @@
           <a:p>
             <a:fld id="{67C30635-7F4C-458C-AB0B-9951B311FD29}" type="datetimeFigureOut">
               <a:rPr lang="en-US" smtClean="0"/>
-              <a:t>7/31/2025</a:t>
+              <a:t>8/1/2025</a:t>
             </a:fld>
             <a:endParaRPr lang="en-US"/>
           </a:p>
@@ -3757,6 +3842,14 @@
 <file path=ppt/slides/slide1.xml><?xml version="1.0" encoding="utf-8"?>
 <p:sld xmlns:a="http://schemas.openxmlformats.org/drawingml/2006/main" xmlns:r="http://schemas.openxmlformats.org/officeDocument/2006/relationships" xmlns:p="http://schemas.openxmlformats.org/presentationml/2006/main">
   <p:cSld>
+    <p:bg>
+      <p:bgPr>
+        <a:solidFill>
+          <a:srgbClr val="F5F4EF"/>
+        </a:solidFill>
+        <a:effectLst/>
+      </p:bgPr>
+    </p:bg>
     <p:spTree>
       <p:nvGrpSpPr>
         <p:cNvPr id="1" name=""/>
@@ -4936,6 +5029,1417 @@
 </file>
 
 <file path=ppt/slides/slide2.xml><?xml version="1.0" encoding="utf-8"?>
+<p:sld xmlns:a="http://schemas.openxmlformats.org/drawingml/2006/main" xmlns:r="http://schemas.openxmlformats.org/officeDocument/2006/relationships" xmlns:p="http://schemas.openxmlformats.org/presentationml/2006/main">
+  <p:cSld>
+    <p:bg>
+      <p:bgPr>
+        <a:solidFill>
+          <a:srgbClr val="F5F4EF"/>
+        </a:solidFill>
+        <a:effectLst/>
+      </p:bgPr>
+    </p:bg>
+    <p:spTree>
+      <p:nvGrpSpPr>
+        <p:cNvPr id="1" name="">
+          <a:extLst>
+            <a:ext uri="{FF2B5EF4-FFF2-40B4-BE49-F238E27FC236}">
+              <a16:creationId xmlns:a16="http://schemas.microsoft.com/office/drawing/2014/main" id="{56EB97F2-863B-E67A-012D-B24AB963DA29}"/>
+            </a:ext>
+          </a:extLst>
+        </p:cNvPr>
+        <p:cNvGrpSpPr/>
+        <p:nvPr/>
+      </p:nvGrpSpPr>
+      <p:grpSpPr>
+        <a:xfrm>
+          <a:off x="0" y="0"/>
+          <a:ext cx="0" cy="0"/>
+          <a:chOff x="0" y="0"/>
+          <a:chExt cx="0" cy="0"/>
+        </a:xfrm>
+      </p:grpSpPr>
+      <p:sp>
+        <p:nvSpPr>
+          <p:cNvPr id="9" name="Rectangle 8">
+            <a:extLst>
+              <a:ext uri="{FF2B5EF4-FFF2-40B4-BE49-F238E27FC236}">
+                <a16:creationId xmlns:a16="http://schemas.microsoft.com/office/drawing/2014/main" id="{78713097-7DE6-D47F-90AF-938979A22FAF}"/>
+              </a:ext>
+            </a:extLst>
+          </p:cNvPr>
+          <p:cNvSpPr/>
+          <p:nvPr/>
+        </p:nvSpPr>
+        <p:spPr>
+          <a:xfrm>
+            <a:off x="1235460" y="152636"/>
+            <a:ext cx="5868652" cy="6120680"/>
+          </a:xfrm>
+          <a:prstGeom prst="rect">
+            <a:avLst/>
+          </a:prstGeom>
+          <a:solidFill>
+            <a:srgbClr val="F5F4EF"/>
+          </a:solidFill>
+          <a:ln w="19050">
+            <a:solidFill>
+              <a:srgbClr val="840000"/>
+            </a:solidFill>
+          </a:ln>
+        </p:spPr>
+        <p:style>
+          <a:lnRef idx="2">
+            <a:schemeClr val="accent1">
+              <a:shade val="15000"/>
+            </a:schemeClr>
+          </a:lnRef>
+          <a:fillRef idx="1">
+            <a:schemeClr val="accent1"/>
+          </a:fillRef>
+          <a:effectRef idx="0">
+            <a:schemeClr val="accent1"/>
+          </a:effectRef>
+          <a:fontRef idx="minor">
+            <a:schemeClr val="lt1"/>
+          </a:fontRef>
+        </p:style>
+        <p:txBody>
+          <a:bodyPr rtlCol="0" anchor="ctr"/>
+          <a:lstStyle/>
+          <a:p>
+            <a:pPr algn="ctr"/>
+            <a:endParaRPr lang="en-US">
+              <a:solidFill>
+                <a:schemeClr val="tx1">
+                  <a:lumMod val="75000"/>
+                  <a:lumOff val="25000"/>
+                </a:schemeClr>
+              </a:solidFill>
+            </a:endParaRPr>
+          </a:p>
+        </p:txBody>
+      </p:sp>
+      <p:cxnSp>
+        <p:nvCxnSpPr>
+          <p:cNvPr id="12" name="Straight Connector 11">
+            <a:extLst>
+              <a:ext uri="{FF2B5EF4-FFF2-40B4-BE49-F238E27FC236}">
+                <a16:creationId xmlns:a16="http://schemas.microsoft.com/office/drawing/2014/main" id="{32000295-89BC-AE7C-D56F-F0E1D8CB7ED2}"/>
+              </a:ext>
+            </a:extLst>
+          </p:cNvPr>
+          <p:cNvCxnSpPr>
+            <a:cxnSpLocks/>
+          </p:cNvCxnSpPr>
+          <p:nvPr/>
+        </p:nvCxnSpPr>
+        <p:spPr>
+          <a:xfrm flipH="1" flipV="1">
+            <a:off x="8713132" y="2241259"/>
+            <a:ext cx="934224" cy="1"/>
+          </a:xfrm>
+          <a:prstGeom prst="line">
+            <a:avLst/>
+          </a:prstGeom>
+          <a:ln>
+            <a:solidFill>
+              <a:srgbClr val="009600"/>
+            </a:solidFill>
+          </a:ln>
+        </p:spPr>
+        <p:style>
+          <a:lnRef idx="2">
+            <a:schemeClr val="accent1"/>
+          </a:lnRef>
+          <a:fillRef idx="0">
+            <a:schemeClr val="accent1"/>
+          </a:fillRef>
+          <a:effectRef idx="1">
+            <a:schemeClr val="accent1"/>
+          </a:effectRef>
+          <a:fontRef idx="minor">
+            <a:schemeClr val="tx1"/>
+          </a:fontRef>
+        </p:style>
+      </p:cxnSp>
+      <p:cxnSp>
+        <p:nvCxnSpPr>
+          <p:cNvPr id="13" name="Straight Connector 12">
+            <a:extLst>
+              <a:ext uri="{FF2B5EF4-FFF2-40B4-BE49-F238E27FC236}">
+                <a16:creationId xmlns:a16="http://schemas.microsoft.com/office/drawing/2014/main" id="{943FB382-3D40-0857-74BE-C1423D5AA464}"/>
+              </a:ext>
+            </a:extLst>
+          </p:cNvPr>
+          <p:cNvCxnSpPr/>
+          <p:nvPr/>
+        </p:nvCxnSpPr>
+        <p:spPr>
+          <a:xfrm flipH="1" flipV="1">
+            <a:off x="8699686" y="2873268"/>
+            <a:ext cx="934224" cy="1"/>
+          </a:xfrm>
+          <a:prstGeom prst="line">
+            <a:avLst/>
+          </a:prstGeom>
+          <a:ln>
+            <a:solidFill>
+              <a:srgbClr val="009600"/>
+            </a:solidFill>
+          </a:ln>
+        </p:spPr>
+        <p:style>
+          <a:lnRef idx="2">
+            <a:schemeClr val="accent1"/>
+          </a:lnRef>
+          <a:fillRef idx="0">
+            <a:schemeClr val="accent1"/>
+          </a:fillRef>
+          <a:effectRef idx="1">
+            <a:schemeClr val="accent1"/>
+          </a:effectRef>
+          <a:fontRef idx="minor">
+            <a:schemeClr val="tx1"/>
+          </a:fontRef>
+        </p:style>
+      </p:cxnSp>
+      <p:cxnSp>
+        <p:nvCxnSpPr>
+          <p:cNvPr id="14" name="Straight Connector 13">
+            <a:extLst>
+              <a:ext uri="{FF2B5EF4-FFF2-40B4-BE49-F238E27FC236}">
+                <a16:creationId xmlns:a16="http://schemas.microsoft.com/office/drawing/2014/main" id="{59C1A0B1-99D8-7649-FDED-BD0EEECA4AA7}"/>
+              </a:ext>
+            </a:extLst>
+          </p:cNvPr>
+          <p:cNvCxnSpPr/>
+          <p:nvPr/>
+        </p:nvCxnSpPr>
+        <p:spPr>
+          <a:xfrm flipH="1" flipV="1">
+            <a:off x="8713132" y="4005064"/>
+            <a:ext cx="934224" cy="1"/>
+          </a:xfrm>
+          <a:prstGeom prst="line">
+            <a:avLst/>
+          </a:prstGeom>
+          <a:ln>
+            <a:solidFill>
+              <a:srgbClr val="009600"/>
+            </a:solidFill>
+          </a:ln>
+        </p:spPr>
+        <p:style>
+          <a:lnRef idx="2">
+            <a:schemeClr val="accent1"/>
+          </a:lnRef>
+          <a:fillRef idx="0">
+            <a:schemeClr val="accent1"/>
+          </a:fillRef>
+          <a:effectRef idx="1">
+            <a:schemeClr val="accent1"/>
+          </a:effectRef>
+          <a:fontRef idx="minor">
+            <a:schemeClr val="tx1"/>
+          </a:fontRef>
+        </p:style>
+      </p:cxnSp>
+      <p:sp>
+        <p:nvSpPr>
+          <p:cNvPr id="3" name="Rectangle 2">
+            <a:extLst>
+              <a:ext uri="{FF2B5EF4-FFF2-40B4-BE49-F238E27FC236}">
+                <a16:creationId xmlns:a16="http://schemas.microsoft.com/office/drawing/2014/main" id="{EF5871CA-689B-7CE8-49AF-93DFAA2B3721}"/>
+              </a:ext>
+            </a:extLst>
+          </p:cNvPr>
+          <p:cNvSpPr/>
+          <p:nvPr/>
+        </p:nvSpPr>
+        <p:spPr>
+          <a:xfrm>
+            <a:off x="3935760" y="1268760"/>
+            <a:ext cx="2160240" cy="1836205"/>
+          </a:xfrm>
+          <a:prstGeom prst="rect">
+            <a:avLst/>
+          </a:prstGeom>
+          <a:solidFill>
+            <a:srgbClr val="D1D1D1">
+              <a:alpha val="89804"/>
+            </a:srgbClr>
+          </a:solidFill>
+          <a:ln w="19050">
+            <a:solidFill>
+              <a:schemeClr val="tx1">
+                <a:lumMod val="65000"/>
+                <a:lumOff val="35000"/>
+              </a:schemeClr>
+            </a:solidFill>
+          </a:ln>
+        </p:spPr>
+        <p:style>
+          <a:lnRef idx="2">
+            <a:schemeClr val="accent1">
+              <a:shade val="15000"/>
+            </a:schemeClr>
+          </a:lnRef>
+          <a:fillRef idx="1">
+            <a:schemeClr val="accent1"/>
+          </a:fillRef>
+          <a:effectRef idx="0">
+            <a:schemeClr val="accent1"/>
+          </a:effectRef>
+          <a:fontRef idx="minor">
+            <a:schemeClr val="lt1"/>
+          </a:fontRef>
+        </p:style>
+        <p:txBody>
+          <a:bodyPr rtlCol="0" anchor="ctr"/>
+          <a:lstStyle/>
+          <a:p>
+            <a:pPr algn="ctr"/>
+            <a:r>
+              <a:rPr lang="en-US" sz="1100" b="1">
+                <a:solidFill>
+                  <a:schemeClr val="tx1">
+                    <a:lumMod val="75000"/>
+                    <a:lumOff val="25000"/>
+                  </a:schemeClr>
+                </a:solidFill>
+              </a:rPr>
+              <a:t>DIGITAL Domain</a:t>
+            </a:r>
+          </a:p>
+        </p:txBody>
+      </p:sp>
+      <p:sp>
+        <p:nvSpPr>
+          <p:cNvPr id="11" name="Title 1">
+            <a:extLst>
+              <a:ext uri="{FF2B5EF4-FFF2-40B4-BE49-F238E27FC236}">
+                <a16:creationId xmlns:a16="http://schemas.microsoft.com/office/drawing/2014/main" id="{8695C892-67DC-C513-168D-833E815C026C}"/>
+              </a:ext>
+            </a:extLst>
+          </p:cNvPr>
+          <p:cNvSpPr txBox="1">
+            <a:spLocks/>
+          </p:cNvSpPr>
+          <p:nvPr/>
+        </p:nvSpPr>
+        <p:spPr>
+          <a:xfrm>
+            <a:off x="1307468" y="5553280"/>
+            <a:ext cx="5283290" cy="576036"/>
+          </a:xfrm>
+          <a:prstGeom prst="rect">
+            <a:avLst/>
+          </a:prstGeom>
+        </p:spPr>
+        <p:txBody>
+          <a:bodyPr vert="horz" lIns="91440" tIns="45720" rIns="91440" bIns="45720" rtlCol="0" anchor="b">
+            <a:normAutofit/>
+          </a:bodyPr>
+          <a:lstStyle>
+            <a:lvl1pPr algn="ctr" defTabSz="914400" rtl="0" eaLnBrk="1" latinLnBrk="0" hangingPunct="1">
+              <a:lnSpc>
+                <a:spcPct val="90000"/>
+              </a:lnSpc>
+              <a:spcBef>
+                <a:spcPct val="0"/>
+              </a:spcBef>
+              <a:buNone/>
+              <a:defRPr sz="6000" kern="1200">
+                <a:solidFill>
+                  <a:schemeClr val="tx1"/>
+                </a:solidFill>
+                <a:latin typeface="+mj-lt"/>
+                <a:ea typeface="+mj-ea"/>
+                <a:cs typeface="+mj-cs"/>
+              </a:defRPr>
+            </a:lvl1pPr>
+          </a:lstStyle>
+          <a:p>
+            <a:pPr algn="l"/>
+            <a:r>
+              <a:rPr lang="en-US" sz="1800" i="1">
+                <a:solidFill>
+                  <a:schemeClr val="tx1">
+                    <a:lumMod val="65000"/>
+                    <a:lumOff val="35000"/>
+                  </a:schemeClr>
+                </a:solidFill>
+                <a:latin typeface="Eras Demi ITC" panose="020B0805030504020804" pitchFamily="34" charset="0"/>
+              </a:rPr>
+              <a:t>MDD400 Isolated Domains</a:t>
+            </a:r>
+          </a:p>
+        </p:txBody>
+      </p:sp>
+      <p:sp>
+        <p:nvSpPr>
+          <p:cNvPr id="21" name="Arrow: Right 20">
+            <a:extLst>
+              <a:ext uri="{FF2B5EF4-FFF2-40B4-BE49-F238E27FC236}">
+                <a16:creationId xmlns:a16="http://schemas.microsoft.com/office/drawing/2014/main" id="{B2651D19-6C23-0DE8-9513-29840F354807}"/>
+              </a:ext>
+            </a:extLst>
+          </p:cNvPr>
+          <p:cNvSpPr/>
+          <p:nvPr/>
+        </p:nvSpPr>
+        <p:spPr>
+          <a:xfrm>
+            <a:off x="3590717" y="1725622"/>
+            <a:ext cx="236198" cy="198022"/>
+          </a:xfrm>
+          <a:prstGeom prst="rightArrow">
+            <a:avLst/>
+          </a:prstGeom>
+          <a:solidFill>
+            <a:srgbClr val="F5F4EF"/>
+          </a:solidFill>
+          <a:ln w="19050">
+            <a:solidFill>
+              <a:srgbClr val="840000"/>
+            </a:solidFill>
+          </a:ln>
+        </p:spPr>
+        <p:style>
+          <a:lnRef idx="2">
+            <a:schemeClr val="accent1">
+              <a:shade val="15000"/>
+            </a:schemeClr>
+          </a:lnRef>
+          <a:fillRef idx="1">
+            <a:schemeClr val="accent1"/>
+          </a:fillRef>
+          <a:effectRef idx="0">
+            <a:schemeClr val="accent1"/>
+          </a:effectRef>
+          <a:fontRef idx="minor">
+            <a:schemeClr val="lt1"/>
+          </a:fontRef>
+        </p:style>
+        <p:txBody>
+          <a:bodyPr rtlCol="0" anchor="ctr"/>
+          <a:lstStyle/>
+          <a:p>
+            <a:pPr algn="ctr"/>
+            <a:endParaRPr lang="en-US">
+              <a:solidFill>
+                <a:schemeClr val="tx1">
+                  <a:lumMod val="75000"/>
+                  <a:lumOff val="25000"/>
+                </a:schemeClr>
+              </a:solidFill>
+            </a:endParaRPr>
+          </a:p>
+        </p:txBody>
+      </p:sp>
+      <p:sp>
+        <p:nvSpPr>
+          <p:cNvPr id="23" name="Arrow: Left-Right 22">
+            <a:extLst>
+              <a:ext uri="{FF2B5EF4-FFF2-40B4-BE49-F238E27FC236}">
+                <a16:creationId xmlns:a16="http://schemas.microsoft.com/office/drawing/2014/main" id="{4B099A6F-BE01-9A83-EBF5-054729F10885}"/>
+              </a:ext>
+            </a:extLst>
+          </p:cNvPr>
+          <p:cNvSpPr/>
+          <p:nvPr/>
+        </p:nvSpPr>
+        <p:spPr>
+          <a:xfrm>
+            <a:off x="3590717" y="2873268"/>
+            <a:ext cx="236198" cy="141686"/>
+          </a:xfrm>
+          <a:prstGeom prst="leftRightArrow">
+            <a:avLst/>
+          </a:prstGeom>
+          <a:solidFill>
+            <a:srgbClr val="F5F4EF"/>
+          </a:solidFill>
+          <a:ln w="19050">
+            <a:solidFill>
+              <a:srgbClr val="840000"/>
+            </a:solidFill>
+          </a:ln>
+        </p:spPr>
+        <p:style>
+          <a:lnRef idx="2">
+            <a:schemeClr val="accent1">
+              <a:shade val="15000"/>
+            </a:schemeClr>
+          </a:lnRef>
+          <a:fillRef idx="1">
+            <a:schemeClr val="accent1"/>
+          </a:fillRef>
+          <a:effectRef idx="0">
+            <a:schemeClr val="accent1"/>
+          </a:effectRef>
+          <a:fontRef idx="minor">
+            <a:schemeClr val="lt1"/>
+          </a:fontRef>
+        </p:style>
+        <p:txBody>
+          <a:bodyPr rtlCol="0" anchor="ctr"/>
+          <a:lstStyle/>
+          <a:p>
+            <a:pPr algn="ctr"/>
+            <a:endParaRPr lang="en-US">
+              <a:solidFill>
+                <a:schemeClr val="tx1">
+                  <a:lumMod val="75000"/>
+                  <a:lumOff val="25000"/>
+                </a:schemeClr>
+              </a:solidFill>
+            </a:endParaRPr>
+          </a:p>
+        </p:txBody>
+      </p:sp>
+      <p:sp>
+        <p:nvSpPr>
+          <p:cNvPr id="24" name="Arrow: Left-Right 23">
+            <a:extLst>
+              <a:ext uri="{FF2B5EF4-FFF2-40B4-BE49-F238E27FC236}">
+                <a16:creationId xmlns:a16="http://schemas.microsoft.com/office/drawing/2014/main" id="{719B4B48-21EB-F521-33A6-8ED073A092C8}"/>
+              </a:ext>
+            </a:extLst>
+          </p:cNvPr>
+          <p:cNvSpPr/>
+          <p:nvPr/>
+        </p:nvSpPr>
+        <p:spPr>
+          <a:xfrm rot="5400000">
+            <a:off x="5329829" y="3235049"/>
+            <a:ext cx="236198" cy="141686"/>
+          </a:xfrm>
+          <a:prstGeom prst="leftRightArrow">
+            <a:avLst/>
+          </a:prstGeom>
+          <a:solidFill>
+            <a:srgbClr val="F5F4EF"/>
+          </a:solidFill>
+          <a:ln w="19050">
+            <a:solidFill>
+              <a:srgbClr val="840000"/>
+            </a:solidFill>
+          </a:ln>
+        </p:spPr>
+        <p:style>
+          <a:lnRef idx="2">
+            <a:schemeClr val="accent1">
+              <a:shade val="15000"/>
+            </a:schemeClr>
+          </a:lnRef>
+          <a:fillRef idx="1">
+            <a:schemeClr val="accent1"/>
+          </a:fillRef>
+          <a:effectRef idx="0">
+            <a:schemeClr val="accent1"/>
+          </a:effectRef>
+          <a:fontRef idx="minor">
+            <a:schemeClr val="lt1"/>
+          </a:fontRef>
+        </p:style>
+        <p:txBody>
+          <a:bodyPr rtlCol="0" anchor="ctr"/>
+          <a:lstStyle/>
+          <a:p>
+            <a:pPr algn="ctr"/>
+            <a:endParaRPr lang="en-US">
+              <a:solidFill>
+                <a:schemeClr val="tx1">
+                  <a:lumMod val="75000"/>
+                  <a:lumOff val="25000"/>
+                </a:schemeClr>
+              </a:solidFill>
+            </a:endParaRPr>
+          </a:p>
+        </p:txBody>
+      </p:sp>
+      <p:sp>
+        <p:nvSpPr>
+          <p:cNvPr id="5" name="Rectangle 4">
+            <a:extLst>
+              <a:ext uri="{FF2B5EF4-FFF2-40B4-BE49-F238E27FC236}">
+                <a16:creationId xmlns:a16="http://schemas.microsoft.com/office/drawing/2014/main" id="{457D4381-EFF1-3A96-CC4E-CF77D35490FF}"/>
+              </a:ext>
+            </a:extLst>
+          </p:cNvPr>
+          <p:cNvSpPr/>
+          <p:nvPr/>
+        </p:nvSpPr>
+        <p:spPr>
+          <a:xfrm>
+            <a:off x="1775520" y="2708920"/>
+            <a:ext cx="1692188" cy="2844360"/>
+          </a:xfrm>
+          <a:prstGeom prst="rect">
+            <a:avLst/>
+          </a:prstGeom>
+          <a:solidFill>
+            <a:srgbClr val="A20000">
+              <a:alpha val="89804"/>
+            </a:srgbClr>
+          </a:solidFill>
+          <a:ln w="19050">
+            <a:solidFill>
+              <a:schemeClr val="tx2">
+                <a:lumMod val="90000"/>
+                <a:lumOff val="10000"/>
+              </a:schemeClr>
+            </a:solidFill>
+          </a:ln>
+        </p:spPr>
+        <p:style>
+          <a:lnRef idx="2">
+            <a:schemeClr val="accent1">
+              <a:shade val="15000"/>
+            </a:schemeClr>
+          </a:lnRef>
+          <a:fillRef idx="1">
+            <a:schemeClr val="accent1"/>
+          </a:fillRef>
+          <a:effectRef idx="0">
+            <a:schemeClr val="accent1"/>
+          </a:effectRef>
+          <a:fontRef idx="minor">
+            <a:schemeClr val="lt1"/>
+          </a:fontRef>
+        </p:style>
+        <p:txBody>
+          <a:bodyPr rtlCol="0" anchor="ctr"/>
+          <a:lstStyle/>
+          <a:p>
+            <a:pPr algn="ctr"/>
+            <a:r>
+              <a:rPr lang="en-US" sz="1100" b="1">
+                <a:solidFill>
+                  <a:schemeClr val="bg1"/>
+                </a:solidFill>
+              </a:rPr>
+              <a:t>CAN Domain</a:t>
+            </a:r>
+          </a:p>
+        </p:txBody>
+      </p:sp>
+      <p:sp>
+        <p:nvSpPr>
+          <p:cNvPr id="2" name="Rectangle 1">
+            <a:extLst>
+              <a:ext uri="{FF2B5EF4-FFF2-40B4-BE49-F238E27FC236}">
+                <a16:creationId xmlns:a16="http://schemas.microsoft.com/office/drawing/2014/main" id="{007D4F74-1475-657A-59E8-8E6BD60DA7DE}"/>
+              </a:ext>
+            </a:extLst>
+          </p:cNvPr>
+          <p:cNvSpPr/>
+          <p:nvPr/>
+        </p:nvSpPr>
+        <p:spPr>
+          <a:xfrm>
+            <a:off x="1775520" y="1268760"/>
+            <a:ext cx="1692188" cy="1111747"/>
+          </a:xfrm>
+          <a:prstGeom prst="rect">
+            <a:avLst/>
+          </a:prstGeom>
+          <a:solidFill>
+            <a:srgbClr val="215F9A">
+              <a:alpha val="89804"/>
+            </a:srgbClr>
+          </a:solidFill>
+          <a:ln w="19050">
+            <a:solidFill>
+              <a:schemeClr val="tx2">
+                <a:lumMod val="90000"/>
+                <a:lumOff val="10000"/>
+              </a:schemeClr>
+            </a:solidFill>
+          </a:ln>
+        </p:spPr>
+        <p:style>
+          <a:lnRef idx="2">
+            <a:schemeClr val="accent1">
+              <a:shade val="15000"/>
+            </a:schemeClr>
+          </a:lnRef>
+          <a:fillRef idx="1">
+            <a:schemeClr val="accent1"/>
+          </a:fillRef>
+          <a:effectRef idx="0">
+            <a:schemeClr val="accent1"/>
+          </a:effectRef>
+          <a:fontRef idx="minor">
+            <a:schemeClr val="lt1"/>
+          </a:fontRef>
+        </p:style>
+        <p:txBody>
+          <a:bodyPr rtlCol="0" anchor="ctr"/>
+          <a:lstStyle/>
+          <a:p>
+            <a:pPr algn="ctr"/>
+            <a:r>
+              <a:rPr lang="en-US" sz="1100" b="1">
+                <a:solidFill>
+                  <a:schemeClr val="bg1"/>
+                </a:solidFill>
+              </a:rPr>
+              <a:t>SMPS Domain</a:t>
+            </a:r>
+          </a:p>
+        </p:txBody>
+      </p:sp>
+      <p:sp>
+        <p:nvSpPr>
+          <p:cNvPr id="20" name="Arrow: Right 19">
+            <a:extLst>
+              <a:ext uri="{FF2B5EF4-FFF2-40B4-BE49-F238E27FC236}">
+                <a16:creationId xmlns:a16="http://schemas.microsoft.com/office/drawing/2014/main" id="{2129D5C6-DB59-D56C-C577-BCC8FC71E744}"/>
+              </a:ext>
+            </a:extLst>
+          </p:cNvPr>
+          <p:cNvSpPr/>
+          <p:nvPr/>
+        </p:nvSpPr>
+        <p:spPr>
+          <a:xfrm rot="16200000">
+            <a:off x="2494514" y="2445703"/>
+            <a:ext cx="236198" cy="198022"/>
+          </a:xfrm>
+          <a:prstGeom prst="rightArrow">
+            <a:avLst/>
+          </a:prstGeom>
+          <a:solidFill>
+            <a:srgbClr val="F5F4EF"/>
+          </a:solidFill>
+          <a:ln w="19050">
+            <a:solidFill>
+              <a:srgbClr val="840000"/>
+            </a:solidFill>
+          </a:ln>
+        </p:spPr>
+        <p:style>
+          <a:lnRef idx="2">
+            <a:schemeClr val="accent1">
+              <a:shade val="15000"/>
+            </a:schemeClr>
+          </a:lnRef>
+          <a:fillRef idx="1">
+            <a:schemeClr val="accent1"/>
+          </a:fillRef>
+          <a:effectRef idx="0">
+            <a:schemeClr val="accent1"/>
+          </a:effectRef>
+          <a:fontRef idx="minor">
+            <a:schemeClr val="lt1"/>
+          </a:fontRef>
+        </p:style>
+        <p:txBody>
+          <a:bodyPr rtlCol="0" anchor="ctr"/>
+          <a:lstStyle/>
+          <a:p>
+            <a:pPr algn="ctr"/>
+            <a:endParaRPr lang="en-US">
+              <a:solidFill>
+                <a:schemeClr val="tx1">
+                  <a:lumMod val="75000"/>
+                  <a:lumOff val="25000"/>
+                </a:schemeClr>
+              </a:solidFill>
+            </a:endParaRPr>
+          </a:p>
+        </p:txBody>
+      </p:sp>
+      <p:sp>
+        <p:nvSpPr>
+          <p:cNvPr id="4" name="Rectangle 3">
+            <a:extLst>
+              <a:ext uri="{FF2B5EF4-FFF2-40B4-BE49-F238E27FC236}">
+                <a16:creationId xmlns:a16="http://schemas.microsoft.com/office/drawing/2014/main" id="{456956C1-036D-851B-EFF9-0D464E9E5C35}"/>
+              </a:ext>
+            </a:extLst>
+          </p:cNvPr>
+          <p:cNvSpPr/>
+          <p:nvPr/>
+        </p:nvSpPr>
+        <p:spPr>
+          <a:xfrm>
+            <a:off x="4727848" y="3499990"/>
+            <a:ext cx="1368152" cy="2053289"/>
+          </a:xfrm>
+          <a:prstGeom prst="rect">
+            <a:avLst/>
+          </a:prstGeom>
+          <a:solidFill>
+            <a:srgbClr val="11838F">
+              <a:alpha val="89804"/>
+            </a:srgbClr>
+          </a:solidFill>
+          <a:ln w="19050">
+            <a:solidFill>
+              <a:srgbClr val="11838F"/>
+            </a:solidFill>
+          </a:ln>
+        </p:spPr>
+        <p:style>
+          <a:lnRef idx="2">
+            <a:schemeClr val="accent1">
+              <a:shade val="15000"/>
+            </a:schemeClr>
+          </a:lnRef>
+          <a:fillRef idx="1">
+            <a:schemeClr val="accent1"/>
+          </a:fillRef>
+          <a:effectRef idx="0">
+            <a:schemeClr val="accent1"/>
+          </a:effectRef>
+          <a:fontRef idx="minor">
+            <a:schemeClr val="lt1"/>
+          </a:fontRef>
+        </p:style>
+        <p:txBody>
+          <a:bodyPr rtlCol="0" anchor="ctr"/>
+          <a:lstStyle/>
+          <a:p>
+            <a:pPr algn="ctr"/>
+            <a:r>
+              <a:rPr lang="en-US" sz="1100" b="1">
+                <a:solidFill>
+                  <a:schemeClr val="bg1"/>
+                </a:solidFill>
+              </a:rPr>
+              <a:t>LEGACY IO Domain</a:t>
+            </a:r>
+          </a:p>
+        </p:txBody>
+      </p:sp>
+    </p:spTree>
+    <p:extLst>
+      <p:ext uri="{BB962C8B-B14F-4D97-AF65-F5344CB8AC3E}">
+        <p14:creationId xmlns:p14="http://schemas.microsoft.com/office/powerpoint/2010/main" val="3065089136"/>
+      </p:ext>
+    </p:extLst>
+  </p:cSld>
+  <p:clrMapOvr>
+    <a:masterClrMapping/>
+  </p:clrMapOvr>
+</p:sld>
+</file>
+
+<file path=ppt/slides/slide3.xml><?xml version="1.0" encoding="utf-8"?>
+<p:sld xmlns:a="http://schemas.openxmlformats.org/drawingml/2006/main" xmlns:r="http://schemas.openxmlformats.org/officeDocument/2006/relationships" xmlns:p="http://schemas.openxmlformats.org/presentationml/2006/main">
+  <p:cSld>
+    <p:spTree>
+      <p:nvGrpSpPr>
+        <p:cNvPr id="1" name="">
+          <a:extLst>
+            <a:ext uri="{FF2B5EF4-FFF2-40B4-BE49-F238E27FC236}">
+              <a16:creationId xmlns:a16="http://schemas.microsoft.com/office/drawing/2014/main" id="{1FBCE37E-8C86-F5E5-0B83-5B9C5D42A1F2}"/>
+            </a:ext>
+          </a:extLst>
+        </p:cNvPr>
+        <p:cNvGrpSpPr/>
+        <p:nvPr/>
+      </p:nvGrpSpPr>
+      <p:grpSpPr>
+        <a:xfrm>
+          <a:off x="0" y="0"/>
+          <a:ext cx="0" cy="0"/>
+          <a:chOff x="0" y="0"/>
+          <a:chExt cx="0" cy="0"/>
+        </a:xfrm>
+      </p:grpSpPr>
+      <p:sp>
+        <p:nvSpPr>
+          <p:cNvPr id="6" name="Rectangle 5">
+            <a:extLst>
+              <a:ext uri="{FF2B5EF4-FFF2-40B4-BE49-F238E27FC236}">
+                <a16:creationId xmlns:a16="http://schemas.microsoft.com/office/drawing/2014/main" id="{153F6315-E101-F542-ADAD-AF2A8B2A60B5}"/>
+              </a:ext>
+            </a:extLst>
+          </p:cNvPr>
+          <p:cNvSpPr/>
+          <p:nvPr/>
+        </p:nvSpPr>
+        <p:spPr>
+          <a:xfrm>
+            <a:off x="1235460" y="152636"/>
+            <a:ext cx="5868652" cy="6120680"/>
+          </a:xfrm>
+          <a:prstGeom prst="rect">
+            <a:avLst/>
+          </a:prstGeom>
+          <a:solidFill>
+            <a:srgbClr val="F5F4EF"/>
+          </a:solidFill>
+          <a:ln w="19050">
+            <a:solidFill>
+              <a:srgbClr val="840000"/>
+            </a:solidFill>
+          </a:ln>
+        </p:spPr>
+        <p:style>
+          <a:lnRef idx="2">
+            <a:schemeClr val="accent1">
+              <a:shade val="15000"/>
+            </a:schemeClr>
+          </a:lnRef>
+          <a:fillRef idx="1">
+            <a:schemeClr val="accent1"/>
+          </a:fillRef>
+          <a:effectRef idx="0">
+            <a:schemeClr val="accent1"/>
+          </a:effectRef>
+          <a:fontRef idx="minor">
+            <a:schemeClr val="lt1"/>
+          </a:fontRef>
+        </p:style>
+        <p:txBody>
+          <a:bodyPr rtlCol="0" anchor="ctr"/>
+          <a:lstStyle/>
+          <a:p>
+            <a:pPr algn="ctr"/>
+            <a:endParaRPr lang="en-US">
+              <a:solidFill>
+                <a:schemeClr val="tx1">
+                  <a:lumMod val="75000"/>
+                  <a:lumOff val="25000"/>
+                </a:schemeClr>
+              </a:solidFill>
+            </a:endParaRPr>
+          </a:p>
+        </p:txBody>
+      </p:sp>
+      <p:pic>
+        <p:nvPicPr>
+          <p:cNvPr id="7" name="Picture 6">
+            <a:extLst>
+              <a:ext uri="{FF2B5EF4-FFF2-40B4-BE49-F238E27FC236}">
+                <a16:creationId xmlns:a16="http://schemas.microsoft.com/office/drawing/2014/main" id="{475B0CCB-B588-E010-6D89-4405D1BB1C2A}"/>
+              </a:ext>
+            </a:extLst>
+          </p:cNvPr>
+          <p:cNvPicPr>
+            <a:picLocks noChangeAspect="1"/>
+          </p:cNvPicPr>
+          <p:nvPr/>
+        </p:nvPicPr>
+        <p:blipFill>
+          <a:blip r:embed="rId3"/>
+          <a:stretch>
+            <a:fillRect/>
+          </a:stretch>
+        </p:blipFill>
+        <p:spPr>
+          <a:xfrm>
+            <a:off x="1706960" y="404664"/>
+            <a:ext cx="4965104" cy="4929611"/>
+          </a:xfrm>
+          <a:prstGeom prst="rect">
+            <a:avLst/>
+          </a:prstGeom>
+        </p:spPr>
+      </p:pic>
+      <p:sp>
+        <p:nvSpPr>
+          <p:cNvPr id="2" name="Title 1">
+            <a:extLst>
+              <a:ext uri="{FF2B5EF4-FFF2-40B4-BE49-F238E27FC236}">
+                <a16:creationId xmlns:a16="http://schemas.microsoft.com/office/drawing/2014/main" id="{F701D1CF-C2FF-ABD6-13F6-ACBD672DD0E7}"/>
+              </a:ext>
+            </a:extLst>
+          </p:cNvPr>
+          <p:cNvSpPr>
+            <a:spLocks noGrp="1"/>
+          </p:cNvSpPr>
+          <p:nvPr>
+            <p:ph type="title"/>
+          </p:nvPr>
+        </p:nvSpPr>
+        <p:spPr>
+          <a:xfrm>
+            <a:off x="1343471" y="5239356"/>
+            <a:ext cx="9532957" cy="1325563"/>
+          </a:xfrm>
+        </p:spPr>
+        <p:txBody>
+          <a:bodyPr>
+            <a:normAutofit/>
+          </a:bodyPr>
+          <a:lstStyle/>
+          <a:p>
+            <a:r>
+              <a:rPr lang="en-US" sz="1800" i="1">
+                <a:solidFill>
+                  <a:schemeClr val="tx1">
+                    <a:lumMod val="65000"/>
+                    <a:lumOff val="35000"/>
+                  </a:schemeClr>
+                </a:solidFill>
+                <a:latin typeface="Eras Demi ITC" panose="020B0805030504020804" pitchFamily="34" charset="0"/>
+              </a:rPr>
+              <a:t>MDD400 Isolation Domains</a:t>
+            </a:r>
+          </a:p>
+        </p:txBody>
+      </p:sp>
+      <p:sp>
+        <p:nvSpPr>
+          <p:cNvPr id="15" name="Rectangle 14">
+            <a:extLst>
+              <a:ext uri="{FF2B5EF4-FFF2-40B4-BE49-F238E27FC236}">
+                <a16:creationId xmlns:a16="http://schemas.microsoft.com/office/drawing/2014/main" id="{21D1683D-5C5A-ADB2-A87B-C75F7E22DA90}"/>
+              </a:ext>
+            </a:extLst>
+          </p:cNvPr>
+          <p:cNvSpPr/>
+          <p:nvPr/>
+        </p:nvSpPr>
+        <p:spPr>
+          <a:xfrm>
+            <a:off x="1811524" y="1628800"/>
+            <a:ext cx="1692188" cy="3564396"/>
+          </a:xfrm>
+          <a:prstGeom prst="rect">
+            <a:avLst/>
+          </a:prstGeom>
+          <a:solidFill>
+            <a:srgbClr val="A20000">
+              <a:alpha val="89804"/>
+            </a:srgbClr>
+          </a:solidFill>
+          <a:ln w="19050">
+            <a:solidFill>
+              <a:schemeClr val="tx2">
+                <a:lumMod val="90000"/>
+                <a:lumOff val="10000"/>
+              </a:schemeClr>
+            </a:solidFill>
+          </a:ln>
+        </p:spPr>
+        <p:style>
+          <a:lnRef idx="2">
+            <a:schemeClr val="accent1">
+              <a:shade val="15000"/>
+            </a:schemeClr>
+          </a:lnRef>
+          <a:fillRef idx="1">
+            <a:schemeClr val="accent1"/>
+          </a:fillRef>
+          <a:effectRef idx="0">
+            <a:schemeClr val="accent1"/>
+          </a:effectRef>
+          <a:fontRef idx="minor">
+            <a:schemeClr val="lt1"/>
+          </a:fontRef>
+        </p:style>
+        <p:txBody>
+          <a:bodyPr rtlCol="0" anchor="ctr"/>
+          <a:lstStyle/>
+          <a:p>
+            <a:pPr algn="ctr"/>
+            <a:endParaRPr lang="en-US">
+              <a:solidFill>
+                <a:schemeClr val="tx1">
+                  <a:lumMod val="75000"/>
+                  <a:lumOff val="25000"/>
+                </a:schemeClr>
+              </a:solidFill>
+            </a:endParaRPr>
+          </a:p>
+        </p:txBody>
+      </p:sp>
+      <p:sp>
+        <p:nvSpPr>
+          <p:cNvPr id="16" name="TextBox 15">
+            <a:extLst>
+              <a:ext uri="{FF2B5EF4-FFF2-40B4-BE49-F238E27FC236}">
+                <a16:creationId xmlns:a16="http://schemas.microsoft.com/office/drawing/2014/main" id="{5714729A-7240-EDDB-2619-1AFF0AD01113}"/>
+              </a:ext>
+            </a:extLst>
+          </p:cNvPr>
+          <p:cNvSpPr txBox="1"/>
+          <p:nvPr/>
+        </p:nvSpPr>
+        <p:spPr>
+          <a:xfrm>
+            <a:off x="2236847" y="3180166"/>
+            <a:ext cx="1012505" cy="230832"/>
+          </a:xfrm>
+          <a:prstGeom prst="rect">
+            <a:avLst/>
+          </a:prstGeom>
+          <a:noFill/>
+        </p:spPr>
+        <p:txBody>
+          <a:bodyPr wrap="square" rtlCol="0">
+            <a:spAutoFit/>
+          </a:bodyPr>
+          <a:lstStyle/>
+          <a:p>
+            <a:pPr algn="ctr"/>
+            <a:r>
+              <a:rPr lang="en-US" sz="900" b="1">
+                <a:solidFill>
+                  <a:schemeClr val="bg1"/>
+                </a:solidFill>
+              </a:rPr>
+              <a:t>CAN Domain</a:t>
+            </a:r>
+            <a:endParaRPr lang="en-US" sz="900">
+              <a:solidFill>
+                <a:schemeClr val="bg1"/>
+              </a:solidFill>
+            </a:endParaRPr>
+          </a:p>
+        </p:txBody>
+      </p:sp>
+      <p:sp>
+        <p:nvSpPr>
+          <p:cNvPr id="27" name="Rectangle 26">
+            <a:extLst>
+              <a:ext uri="{FF2B5EF4-FFF2-40B4-BE49-F238E27FC236}">
+                <a16:creationId xmlns:a16="http://schemas.microsoft.com/office/drawing/2014/main" id="{2B306B46-087D-7AB3-CE15-CD7969033EEF}"/>
+              </a:ext>
+            </a:extLst>
+          </p:cNvPr>
+          <p:cNvSpPr/>
+          <p:nvPr/>
+        </p:nvSpPr>
+        <p:spPr>
+          <a:xfrm>
+            <a:off x="5447927" y="2708920"/>
+            <a:ext cx="1008113" cy="2412267"/>
+          </a:xfrm>
+          <a:prstGeom prst="rect">
+            <a:avLst/>
+          </a:prstGeom>
+          <a:solidFill>
+            <a:srgbClr val="11838F">
+              <a:alpha val="89804"/>
+            </a:srgbClr>
+          </a:solidFill>
+          <a:ln w="19050">
+            <a:solidFill>
+              <a:srgbClr val="11838F"/>
+            </a:solidFill>
+          </a:ln>
+        </p:spPr>
+        <p:style>
+          <a:lnRef idx="2">
+            <a:schemeClr val="accent1">
+              <a:shade val="15000"/>
+            </a:schemeClr>
+          </a:lnRef>
+          <a:fillRef idx="1">
+            <a:schemeClr val="accent1"/>
+          </a:fillRef>
+          <a:effectRef idx="0">
+            <a:schemeClr val="accent1"/>
+          </a:effectRef>
+          <a:fontRef idx="minor">
+            <a:schemeClr val="lt1"/>
+          </a:fontRef>
+        </p:style>
+        <p:txBody>
+          <a:bodyPr rtlCol="0" anchor="ctr"/>
+          <a:lstStyle/>
+          <a:p>
+            <a:pPr algn="ctr"/>
+            <a:endParaRPr lang="en-US">
+              <a:solidFill>
+                <a:schemeClr val="tx1">
+                  <a:lumMod val="75000"/>
+                  <a:lumOff val="25000"/>
+                </a:schemeClr>
+              </a:solidFill>
+            </a:endParaRPr>
+          </a:p>
+        </p:txBody>
+      </p:sp>
+      <p:sp>
+        <p:nvSpPr>
+          <p:cNvPr id="29" name="Rectangle 28">
+            <a:extLst>
+              <a:ext uri="{FF2B5EF4-FFF2-40B4-BE49-F238E27FC236}">
+                <a16:creationId xmlns:a16="http://schemas.microsoft.com/office/drawing/2014/main" id="{6592937F-A08A-E0A9-C170-2179CCFA61FF}"/>
+              </a:ext>
+            </a:extLst>
+          </p:cNvPr>
+          <p:cNvSpPr/>
+          <p:nvPr/>
+        </p:nvSpPr>
+        <p:spPr>
+          <a:xfrm>
+            <a:off x="3935760" y="584684"/>
+            <a:ext cx="2520280" cy="1656184"/>
+          </a:xfrm>
+          <a:prstGeom prst="rect">
+            <a:avLst/>
+          </a:prstGeom>
+          <a:solidFill>
+            <a:srgbClr val="D1D1D1">
+              <a:alpha val="89804"/>
+            </a:srgbClr>
+          </a:solidFill>
+          <a:ln w="19050">
+            <a:solidFill>
+              <a:schemeClr val="tx1">
+                <a:lumMod val="65000"/>
+                <a:lumOff val="35000"/>
+              </a:schemeClr>
+            </a:solidFill>
+          </a:ln>
+        </p:spPr>
+        <p:style>
+          <a:lnRef idx="2">
+            <a:schemeClr val="accent1">
+              <a:shade val="15000"/>
+            </a:schemeClr>
+          </a:lnRef>
+          <a:fillRef idx="1">
+            <a:schemeClr val="accent1"/>
+          </a:fillRef>
+          <a:effectRef idx="0">
+            <a:schemeClr val="accent1"/>
+          </a:effectRef>
+          <a:fontRef idx="minor">
+            <a:schemeClr val="lt1"/>
+          </a:fontRef>
+        </p:style>
+        <p:txBody>
+          <a:bodyPr rtlCol="0" anchor="ctr"/>
+          <a:lstStyle/>
+          <a:p>
+            <a:pPr algn="ctr"/>
+            <a:endParaRPr lang="en-US">
+              <a:solidFill>
+                <a:schemeClr val="tx1">
+                  <a:lumMod val="75000"/>
+                  <a:lumOff val="25000"/>
+                </a:schemeClr>
+              </a:solidFill>
+            </a:endParaRPr>
+          </a:p>
+        </p:txBody>
+      </p:sp>
+      <p:sp>
+        <p:nvSpPr>
+          <p:cNvPr id="30" name="TextBox 29">
+            <a:extLst>
+              <a:ext uri="{FF2B5EF4-FFF2-40B4-BE49-F238E27FC236}">
+                <a16:creationId xmlns:a16="http://schemas.microsoft.com/office/drawing/2014/main" id="{9FFEB827-922C-BF19-E371-85AE27290659}"/>
+              </a:ext>
+            </a:extLst>
+          </p:cNvPr>
+          <p:cNvSpPr txBox="1"/>
+          <p:nvPr/>
+        </p:nvSpPr>
+        <p:spPr>
+          <a:xfrm>
+            <a:off x="4537197" y="1367108"/>
+            <a:ext cx="1404156" cy="230832"/>
+          </a:xfrm>
+          <a:prstGeom prst="rect">
+            <a:avLst/>
+          </a:prstGeom>
+          <a:noFill/>
+        </p:spPr>
+        <p:txBody>
+          <a:bodyPr wrap="square" rtlCol="0">
+            <a:spAutoFit/>
+          </a:bodyPr>
+          <a:lstStyle/>
+          <a:p>
+            <a:pPr algn="ctr"/>
+            <a:r>
+              <a:rPr lang="en-US" sz="900" b="1">
+                <a:solidFill>
+                  <a:schemeClr val="bg2">
+                    <a:lumMod val="25000"/>
+                  </a:schemeClr>
+                </a:solidFill>
+              </a:rPr>
+              <a:t>DIGITAL Domain</a:t>
+            </a:r>
+            <a:endParaRPr lang="en-US" sz="900">
+              <a:solidFill>
+                <a:schemeClr val="bg2">
+                  <a:lumMod val="25000"/>
+                </a:schemeClr>
+              </a:solidFill>
+            </a:endParaRPr>
+          </a:p>
+        </p:txBody>
+      </p:sp>
+      <p:sp>
+        <p:nvSpPr>
+          <p:cNvPr id="3" name="TextBox 2">
+            <a:extLst>
+              <a:ext uri="{FF2B5EF4-FFF2-40B4-BE49-F238E27FC236}">
+                <a16:creationId xmlns:a16="http://schemas.microsoft.com/office/drawing/2014/main" id="{2DCD5BE2-9F0E-9246-166F-EAA9624B988B}"/>
+              </a:ext>
+            </a:extLst>
+          </p:cNvPr>
+          <p:cNvSpPr txBox="1"/>
+          <p:nvPr/>
+        </p:nvSpPr>
+        <p:spPr>
+          <a:xfrm>
+            <a:off x="5447927" y="3330130"/>
+            <a:ext cx="1080121" cy="369332"/>
+          </a:xfrm>
+          <a:prstGeom prst="rect">
+            <a:avLst/>
+          </a:prstGeom>
+          <a:noFill/>
+        </p:spPr>
+        <p:txBody>
+          <a:bodyPr wrap="square" rtlCol="0">
+            <a:spAutoFit/>
+          </a:bodyPr>
+          <a:lstStyle/>
+          <a:p>
+            <a:pPr algn="ctr"/>
+            <a:r>
+              <a:rPr lang="en-US" sz="900" b="1">
+                <a:solidFill>
+                  <a:schemeClr val="bg1"/>
+                </a:solidFill>
+              </a:rPr>
+              <a:t>LEGACY IO Domain</a:t>
+            </a:r>
+          </a:p>
+        </p:txBody>
+      </p:sp>
+      <p:sp>
+        <p:nvSpPr>
+          <p:cNvPr id="8" name="Rectangle 7">
+            <a:extLst>
+              <a:ext uri="{FF2B5EF4-FFF2-40B4-BE49-F238E27FC236}">
+                <a16:creationId xmlns:a16="http://schemas.microsoft.com/office/drawing/2014/main" id="{444CC541-6ACB-2E9A-0978-AFAB40E8B142}"/>
+              </a:ext>
+            </a:extLst>
+          </p:cNvPr>
+          <p:cNvSpPr/>
+          <p:nvPr/>
+        </p:nvSpPr>
+        <p:spPr>
+          <a:xfrm>
+            <a:off x="1811524" y="548680"/>
+            <a:ext cx="1692188" cy="900100"/>
+          </a:xfrm>
+          <a:prstGeom prst="rect">
+            <a:avLst/>
+          </a:prstGeom>
+          <a:solidFill>
+            <a:srgbClr val="215F9A">
+              <a:alpha val="89804"/>
+            </a:srgbClr>
+          </a:solidFill>
+          <a:ln w="19050">
+            <a:solidFill>
+              <a:schemeClr val="tx2">
+                <a:lumMod val="90000"/>
+                <a:lumOff val="10000"/>
+              </a:schemeClr>
+            </a:solidFill>
+          </a:ln>
+        </p:spPr>
+        <p:style>
+          <a:lnRef idx="2">
+            <a:schemeClr val="accent1">
+              <a:shade val="15000"/>
+            </a:schemeClr>
+          </a:lnRef>
+          <a:fillRef idx="1">
+            <a:schemeClr val="accent1"/>
+          </a:fillRef>
+          <a:effectRef idx="0">
+            <a:schemeClr val="accent1"/>
+          </a:effectRef>
+          <a:fontRef idx="minor">
+            <a:schemeClr val="lt1"/>
+          </a:fontRef>
+        </p:style>
+        <p:txBody>
+          <a:bodyPr rtlCol="0" anchor="ctr"/>
+          <a:lstStyle/>
+          <a:p>
+            <a:pPr algn="ctr"/>
+            <a:endParaRPr lang="en-US">
+              <a:solidFill>
+                <a:schemeClr val="tx1">
+                  <a:lumMod val="75000"/>
+                  <a:lumOff val="25000"/>
+                </a:schemeClr>
+              </a:solidFill>
+            </a:endParaRPr>
+          </a:p>
+        </p:txBody>
+      </p:sp>
+      <p:sp>
+        <p:nvSpPr>
+          <p:cNvPr id="10" name="TextBox 9">
+            <a:extLst>
+              <a:ext uri="{FF2B5EF4-FFF2-40B4-BE49-F238E27FC236}">
+                <a16:creationId xmlns:a16="http://schemas.microsoft.com/office/drawing/2014/main" id="{54E450E8-4C54-1773-E908-40922E0FBB06}"/>
+              </a:ext>
+            </a:extLst>
+          </p:cNvPr>
+          <p:cNvSpPr txBox="1"/>
+          <p:nvPr/>
+        </p:nvSpPr>
+        <p:spPr>
+          <a:xfrm>
+            <a:off x="2169367" y="883314"/>
+            <a:ext cx="1012505" cy="230832"/>
+          </a:xfrm>
+          <a:prstGeom prst="rect">
+            <a:avLst/>
+          </a:prstGeom>
+          <a:noFill/>
+        </p:spPr>
+        <p:txBody>
+          <a:bodyPr wrap="square" rtlCol="0">
+            <a:spAutoFit/>
+          </a:bodyPr>
+          <a:lstStyle/>
+          <a:p>
+            <a:pPr algn="ctr"/>
+            <a:r>
+              <a:rPr lang="en-US" sz="900" b="1">
+                <a:solidFill>
+                  <a:schemeClr val="bg1"/>
+                </a:solidFill>
+              </a:rPr>
+              <a:t>SMPS Domain</a:t>
+            </a:r>
+            <a:endParaRPr lang="en-US" sz="900">
+              <a:solidFill>
+                <a:schemeClr val="bg1"/>
+              </a:solidFill>
+            </a:endParaRPr>
+          </a:p>
+        </p:txBody>
+      </p:sp>
+    </p:spTree>
+    <p:extLst>
+      <p:ext uri="{BB962C8B-B14F-4D97-AF65-F5344CB8AC3E}">
+        <p14:creationId xmlns:p14="http://schemas.microsoft.com/office/powerpoint/2010/main" val="3344487222"/>
+      </p:ext>
+    </p:extLst>
+  </p:cSld>
+  <p:clrMapOvr>
+    <a:masterClrMapping/>
+  </p:clrMapOvr>
+</p:sld>
+</file>
+
+<file path=ppt/slides/slide4.xml><?xml version="1.0" encoding="utf-8"?>
 <p:sld xmlns:a="http://schemas.openxmlformats.org/drawingml/2006/main" xmlns:r="http://schemas.openxmlformats.org/officeDocument/2006/relationships" xmlns:p="http://schemas.openxmlformats.org/presentationml/2006/main">
   <p:cSld>
     <p:spTree>
@@ -5274,8 +6778,8 @@
         </p:nvSpPr>
         <p:spPr>
           <a:xfrm>
-            <a:off x="1343471" y="5239356"/>
-            <a:ext cx="9532957" cy="1325563"/>
+            <a:off x="1343471" y="5711320"/>
+            <a:ext cx="5283290" cy="576036"/>
           </a:xfrm>
         </p:spPr>
         <p:txBody>
@@ -6104,504 +7608,7 @@
 </p:sld>
 </file>
 
-<file path=ppt/slides/slide3.xml><?xml version="1.0" encoding="utf-8"?>
-<p:sld xmlns:a="http://schemas.openxmlformats.org/drawingml/2006/main" xmlns:r="http://schemas.openxmlformats.org/officeDocument/2006/relationships" xmlns:p="http://schemas.openxmlformats.org/presentationml/2006/main">
-  <p:cSld>
-    <p:spTree>
-      <p:nvGrpSpPr>
-        <p:cNvPr id="1" name="">
-          <a:extLst>
-            <a:ext uri="{FF2B5EF4-FFF2-40B4-BE49-F238E27FC236}">
-              <a16:creationId xmlns:a16="http://schemas.microsoft.com/office/drawing/2014/main" id="{1FBCE37E-8C86-F5E5-0B83-5B9C5D42A1F2}"/>
-            </a:ext>
-          </a:extLst>
-        </p:cNvPr>
-        <p:cNvGrpSpPr/>
-        <p:nvPr/>
-      </p:nvGrpSpPr>
-      <p:grpSpPr>
-        <a:xfrm>
-          <a:off x="0" y="0"/>
-          <a:ext cx="0" cy="0"/>
-          <a:chOff x="0" y="0"/>
-          <a:chExt cx="0" cy="0"/>
-        </a:xfrm>
-      </p:grpSpPr>
-      <p:sp>
-        <p:nvSpPr>
-          <p:cNvPr id="6" name="Rectangle 5">
-            <a:extLst>
-              <a:ext uri="{FF2B5EF4-FFF2-40B4-BE49-F238E27FC236}">
-                <a16:creationId xmlns:a16="http://schemas.microsoft.com/office/drawing/2014/main" id="{153F6315-E101-F542-ADAD-AF2A8B2A60B5}"/>
-              </a:ext>
-            </a:extLst>
-          </p:cNvPr>
-          <p:cNvSpPr/>
-          <p:nvPr/>
-        </p:nvSpPr>
-        <p:spPr>
-          <a:xfrm>
-            <a:off x="1235460" y="152636"/>
-            <a:ext cx="5868652" cy="6120680"/>
-          </a:xfrm>
-          <a:prstGeom prst="rect">
-            <a:avLst/>
-          </a:prstGeom>
-          <a:solidFill>
-            <a:srgbClr val="F5F4EF"/>
-          </a:solidFill>
-          <a:ln w="19050">
-            <a:solidFill>
-              <a:srgbClr val="840000"/>
-            </a:solidFill>
-          </a:ln>
-        </p:spPr>
-        <p:style>
-          <a:lnRef idx="2">
-            <a:schemeClr val="accent1">
-              <a:shade val="15000"/>
-            </a:schemeClr>
-          </a:lnRef>
-          <a:fillRef idx="1">
-            <a:schemeClr val="accent1"/>
-          </a:fillRef>
-          <a:effectRef idx="0">
-            <a:schemeClr val="accent1"/>
-          </a:effectRef>
-          <a:fontRef idx="minor">
-            <a:schemeClr val="lt1"/>
-          </a:fontRef>
-        </p:style>
-        <p:txBody>
-          <a:bodyPr rtlCol="0" anchor="ctr"/>
-          <a:lstStyle/>
-          <a:p>
-            <a:pPr algn="ctr"/>
-            <a:endParaRPr lang="en-US">
-              <a:solidFill>
-                <a:schemeClr val="tx1">
-                  <a:lumMod val="75000"/>
-                  <a:lumOff val="25000"/>
-                </a:schemeClr>
-              </a:solidFill>
-            </a:endParaRPr>
-          </a:p>
-        </p:txBody>
-      </p:sp>
-      <p:pic>
-        <p:nvPicPr>
-          <p:cNvPr id="5" name="Picture 4">
-            <a:extLst>
-              <a:ext uri="{FF2B5EF4-FFF2-40B4-BE49-F238E27FC236}">
-                <a16:creationId xmlns:a16="http://schemas.microsoft.com/office/drawing/2014/main" id="{C6600E61-157A-019D-0181-26A8445C4D06}"/>
-              </a:ext>
-            </a:extLst>
-          </p:cNvPr>
-          <p:cNvPicPr>
-            <a:picLocks noChangeAspect="1"/>
-          </p:cNvPicPr>
-          <p:nvPr/>
-        </p:nvPicPr>
-        <p:blipFill>
-          <a:blip r:embed="rId2"/>
-          <a:stretch>
-            <a:fillRect/>
-          </a:stretch>
-        </p:blipFill>
-        <p:spPr>
-          <a:xfrm>
-            <a:off x="1713729" y="404664"/>
-            <a:ext cx="5024144" cy="4968552"/>
-          </a:xfrm>
-          <a:prstGeom prst="rect">
-            <a:avLst/>
-          </a:prstGeom>
-        </p:spPr>
-      </p:pic>
-      <p:sp>
-        <p:nvSpPr>
-          <p:cNvPr id="2" name="Title 1">
-            <a:extLst>
-              <a:ext uri="{FF2B5EF4-FFF2-40B4-BE49-F238E27FC236}">
-                <a16:creationId xmlns:a16="http://schemas.microsoft.com/office/drawing/2014/main" id="{F701D1CF-C2FF-ABD6-13F6-ACBD672DD0E7}"/>
-              </a:ext>
-            </a:extLst>
-          </p:cNvPr>
-          <p:cNvSpPr>
-            <a:spLocks noGrp="1"/>
-          </p:cNvSpPr>
-          <p:nvPr>
-            <p:ph type="title"/>
-          </p:nvPr>
-        </p:nvSpPr>
-        <p:spPr>
-          <a:xfrm>
-            <a:off x="1343471" y="5239356"/>
-            <a:ext cx="9532957" cy="1325563"/>
-          </a:xfrm>
-        </p:spPr>
-        <p:txBody>
-          <a:bodyPr>
-            <a:normAutofit/>
-          </a:bodyPr>
-          <a:lstStyle/>
-          <a:p>
-            <a:r>
-              <a:rPr lang="en-US" sz="1800" i="1">
-                <a:solidFill>
-                  <a:schemeClr val="tx1">
-                    <a:lumMod val="65000"/>
-                    <a:lumOff val="35000"/>
-                  </a:schemeClr>
-                </a:solidFill>
-                <a:latin typeface="Eras Demi ITC" panose="020B0805030504020804" pitchFamily="34" charset="0"/>
-              </a:rPr>
-              <a:t>MDD400 Isolation Domains</a:t>
-            </a:r>
-          </a:p>
-        </p:txBody>
-      </p:sp>
-      <p:sp>
-        <p:nvSpPr>
-          <p:cNvPr id="15" name="Rectangle 14">
-            <a:extLst>
-              <a:ext uri="{FF2B5EF4-FFF2-40B4-BE49-F238E27FC236}">
-                <a16:creationId xmlns:a16="http://schemas.microsoft.com/office/drawing/2014/main" id="{21D1683D-5C5A-ADB2-A87B-C75F7E22DA90}"/>
-              </a:ext>
-            </a:extLst>
-          </p:cNvPr>
-          <p:cNvSpPr/>
-          <p:nvPr/>
-        </p:nvSpPr>
-        <p:spPr>
-          <a:xfrm>
-            <a:off x="1811524" y="548680"/>
-            <a:ext cx="1692188" cy="3528392"/>
-          </a:xfrm>
-          <a:prstGeom prst="rect">
-            <a:avLst/>
-          </a:prstGeom>
-          <a:solidFill>
-            <a:srgbClr val="A20000">
-              <a:alpha val="89804"/>
-            </a:srgbClr>
-          </a:solidFill>
-          <a:ln w="19050">
-            <a:solidFill>
-              <a:schemeClr val="tx2">
-                <a:lumMod val="90000"/>
-                <a:lumOff val="10000"/>
-              </a:schemeClr>
-            </a:solidFill>
-          </a:ln>
-        </p:spPr>
-        <p:style>
-          <a:lnRef idx="2">
-            <a:schemeClr val="accent1">
-              <a:shade val="15000"/>
-            </a:schemeClr>
-          </a:lnRef>
-          <a:fillRef idx="1">
-            <a:schemeClr val="accent1"/>
-          </a:fillRef>
-          <a:effectRef idx="0">
-            <a:schemeClr val="accent1"/>
-          </a:effectRef>
-          <a:fontRef idx="minor">
-            <a:schemeClr val="lt1"/>
-          </a:fontRef>
-        </p:style>
-        <p:txBody>
-          <a:bodyPr rtlCol="0" anchor="ctr"/>
-          <a:lstStyle/>
-          <a:p>
-            <a:pPr algn="ctr"/>
-            <a:endParaRPr lang="en-US">
-              <a:solidFill>
-                <a:schemeClr val="tx1">
-                  <a:lumMod val="75000"/>
-                  <a:lumOff val="25000"/>
-                </a:schemeClr>
-              </a:solidFill>
-            </a:endParaRPr>
-          </a:p>
-        </p:txBody>
-      </p:sp>
-      <p:sp>
-        <p:nvSpPr>
-          <p:cNvPr id="16" name="TextBox 15">
-            <a:extLst>
-              <a:ext uri="{FF2B5EF4-FFF2-40B4-BE49-F238E27FC236}">
-                <a16:creationId xmlns:a16="http://schemas.microsoft.com/office/drawing/2014/main" id="{5714729A-7240-EDDB-2619-1AFF0AD01113}"/>
-              </a:ext>
-            </a:extLst>
-          </p:cNvPr>
-          <p:cNvSpPr txBox="1"/>
-          <p:nvPr/>
-        </p:nvSpPr>
-        <p:spPr>
-          <a:xfrm>
-            <a:off x="1771127" y="728700"/>
-            <a:ext cx="1012505" cy="230832"/>
-          </a:xfrm>
-          <a:prstGeom prst="rect">
-            <a:avLst/>
-          </a:prstGeom>
-          <a:noFill/>
-        </p:spPr>
-        <p:txBody>
-          <a:bodyPr wrap="square" rtlCol="0">
-            <a:spAutoFit/>
-          </a:bodyPr>
-          <a:lstStyle/>
-          <a:p>
-            <a:r>
-              <a:rPr lang="en-US" sz="900" b="1">
-                <a:solidFill>
-                  <a:schemeClr val="bg1"/>
-                </a:solidFill>
-              </a:rPr>
-              <a:t>CAN Domain</a:t>
-            </a:r>
-            <a:endParaRPr lang="en-US" sz="900">
-              <a:solidFill>
-                <a:schemeClr val="bg1"/>
-              </a:solidFill>
-            </a:endParaRPr>
-          </a:p>
-        </p:txBody>
-      </p:sp>
-      <p:sp>
-        <p:nvSpPr>
-          <p:cNvPr id="27" name="Rectangle 26">
-            <a:extLst>
-              <a:ext uri="{FF2B5EF4-FFF2-40B4-BE49-F238E27FC236}">
-                <a16:creationId xmlns:a16="http://schemas.microsoft.com/office/drawing/2014/main" id="{2B306B46-087D-7AB3-CE15-CD7969033EEF}"/>
-              </a:ext>
-            </a:extLst>
-          </p:cNvPr>
-          <p:cNvSpPr/>
-          <p:nvPr/>
-        </p:nvSpPr>
-        <p:spPr>
-          <a:xfrm>
-            <a:off x="5303911" y="2807310"/>
-            <a:ext cx="1152129" cy="1665806"/>
-          </a:xfrm>
-          <a:prstGeom prst="rect">
-            <a:avLst/>
-          </a:prstGeom>
-          <a:solidFill>
-            <a:srgbClr val="11838F">
-              <a:alpha val="89804"/>
-            </a:srgbClr>
-          </a:solidFill>
-          <a:ln w="19050">
-            <a:solidFill>
-              <a:srgbClr val="11838F"/>
-            </a:solidFill>
-          </a:ln>
-        </p:spPr>
-        <p:style>
-          <a:lnRef idx="2">
-            <a:schemeClr val="accent1">
-              <a:shade val="15000"/>
-            </a:schemeClr>
-          </a:lnRef>
-          <a:fillRef idx="1">
-            <a:schemeClr val="accent1"/>
-          </a:fillRef>
-          <a:effectRef idx="0">
-            <a:schemeClr val="accent1"/>
-          </a:effectRef>
-          <a:fontRef idx="minor">
-            <a:schemeClr val="lt1"/>
-          </a:fontRef>
-        </p:style>
-        <p:txBody>
-          <a:bodyPr rtlCol="0" anchor="ctr"/>
-          <a:lstStyle/>
-          <a:p>
-            <a:pPr algn="ctr"/>
-            <a:endParaRPr lang="en-US">
-              <a:solidFill>
-                <a:schemeClr val="tx1">
-                  <a:lumMod val="75000"/>
-                  <a:lumOff val="25000"/>
-                </a:schemeClr>
-              </a:solidFill>
-            </a:endParaRPr>
-          </a:p>
-        </p:txBody>
-      </p:sp>
-      <p:sp>
-        <p:nvSpPr>
-          <p:cNvPr id="29" name="Rectangle 28">
-            <a:extLst>
-              <a:ext uri="{FF2B5EF4-FFF2-40B4-BE49-F238E27FC236}">
-                <a16:creationId xmlns:a16="http://schemas.microsoft.com/office/drawing/2014/main" id="{6592937F-A08A-E0A9-C170-2179CCFA61FF}"/>
-              </a:ext>
-            </a:extLst>
-          </p:cNvPr>
-          <p:cNvSpPr/>
-          <p:nvPr/>
-        </p:nvSpPr>
-        <p:spPr>
-          <a:xfrm>
-            <a:off x="3871988" y="584684"/>
-            <a:ext cx="2584052" cy="1944216"/>
-          </a:xfrm>
-          <a:prstGeom prst="rect">
-            <a:avLst/>
-          </a:prstGeom>
-          <a:solidFill>
-            <a:srgbClr val="D1D1D1">
-              <a:alpha val="89804"/>
-            </a:srgbClr>
-          </a:solidFill>
-          <a:ln w="19050">
-            <a:solidFill>
-              <a:schemeClr val="tx1">
-                <a:lumMod val="65000"/>
-                <a:lumOff val="35000"/>
-              </a:schemeClr>
-            </a:solidFill>
-          </a:ln>
-        </p:spPr>
-        <p:style>
-          <a:lnRef idx="2">
-            <a:schemeClr val="accent1">
-              <a:shade val="15000"/>
-            </a:schemeClr>
-          </a:lnRef>
-          <a:fillRef idx="1">
-            <a:schemeClr val="accent1"/>
-          </a:fillRef>
-          <a:effectRef idx="0">
-            <a:schemeClr val="accent1"/>
-          </a:effectRef>
-          <a:fontRef idx="minor">
-            <a:schemeClr val="lt1"/>
-          </a:fontRef>
-        </p:style>
-        <p:txBody>
-          <a:bodyPr rtlCol="0" anchor="ctr"/>
-          <a:lstStyle/>
-          <a:p>
-            <a:pPr algn="ctr"/>
-            <a:endParaRPr lang="en-US">
-              <a:solidFill>
-                <a:schemeClr val="tx1">
-                  <a:lumMod val="75000"/>
-                  <a:lumOff val="25000"/>
-                </a:schemeClr>
-              </a:solidFill>
-            </a:endParaRPr>
-          </a:p>
-        </p:txBody>
-      </p:sp>
-      <p:sp>
-        <p:nvSpPr>
-          <p:cNvPr id="30" name="TextBox 29">
-            <a:extLst>
-              <a:ext uri="{FF2B5EF4-FFF2-40B4-BE49-F238E27FC236}">
-                <a16:creationId xmlns:a16="http://schemas.microsoft.com/office/drawing/2014/main" id="{9FFEB827-922C-BF19-E371-85AE27290659}"/>
-              </a:ext>
-            </a:extLst>
-          </p:cNvPr>
-          <p:cNvSpPr txBox="1"/>
-          <p:nvPr/>
-        </p:nvSpPr>
-        <p:spPr>
-          <a:xfrm>
-            <a:off x="5216301" y="1310571"/>
-            <a:ext cx="1404156" cy="230832"/>
-          </a:xfrm>
-          <a:prstGeom prst="rect">
-            <a:avLst/>
-          </a:prstGeom>
-          <a:noFill/>
-        </p:spPr>
-        <p:txBody>
-          <a:bodyPr wrap="square" rtlCol="0">
-            <a:spAutoFit/>
-          </a:bodyPr>
-          <a:lstStyle/>
-          <a:p>
-            <a:pPr algn="ctr"/>
-            <a:r>
-              <a:rPr lang="en-US" sz="900" b="1">
-                <a:solidFill>
-                  <a:schemeClr val="bg2">
-                    <a:lumMod val="25000"/>
-                  </a:schemeClr>
-                </a:solidFill>
-              </a:rPr>
-              <a:t>DIGITAL Domain</a:t>
-            </a:r>
-            <a:endParaRPr lang="en-US" sz="900">
-              <a:solidFill>
-                <a:schemeClr val="bg2">
-                  <a:lumMod val="25000"/>
-                </a:schemeClr>
-              </a:solidFill>
-            </a:endParaRPr>
-          </a:p>
-        </p:txBody>
-      </p:sp>
-      <p:sp>
-        <p:nvSpPr>
-          <p:cNvPr id="3" name="TextBox 2">
-            <a:extLst>
-              <a:ext uri="{FF2B5EF4-FFF2-40B4-BE49-F238E27FC236}">
-                <a16:creationId xmlns:a16="http://schemas.microsoft.com/office/drawing/2014/main" id="{2DCD5BE2-9F0E-9246-166F-EAA9624B988B}"/>
-              </a:ext>
-            </a:extLst>
-          </p:cNvPr>
-          <p:cNvSpPr txBox="1"/>
-          <p:nvPr/>
-        </p:nvSpPr>
-        <p:spPr>
-          <a:xfrm>
-            <a:off x="5227184" y="2857070"/>
-            <a:ext cx="1300864" cy="369332"/>
-          </a:xfrm>
-          <a:prstGeom prst="rect">
-            <a:avLst/>
-          </a:prstGeom>
-          <a:noFill/>
-        </p:spPr>
-        <p:txBody>
-          <a:bodyPr wrap="square" rtlCol="0">
-            <a:spAutoFit/>
-          </a:bodyPr>
-          <a:lstStyle/>
-          <a:p>
-            <a:r>
-              <a:rPr lang="en-US" sz="900" b="1">
-                <a:solidFill>
-                  <a:schemeClr val="bg1"/>
-                </a:solidFill>
-              </a:rPr>
-              <a:t>LEGACY INTERFACE Domain</a:t>
-            </a:r>
-          </a:p>
-        </p:txBody>
-      </p:sp>
-    </p:spTree>
-    <p:extLst>
-      <p:ext uri="{BB962C8B-B14F-4D97-AF65-F5344CB8AC3E}">
-        <p14:creationId xmlns:p14="http://schemas.microsoft.com/office/powerpoint/2010/main" val="3344487222"/>
-      </p:ext>
-    </p:extLst>
-  </p:cSld>
-  <p:clrMapOvr>
-    <a:masterClrMapping/>
-  </p:clrMapOvr>
-</p:sld>
-</file>
-
-<file path=ppt/slides/slide4.xml><?xml version="1.0" encoding="utf-8"?>
+<file path=ppt/slides/slide5.xml><?xml version="1.0" encoding="utf-8"?>
 <p:sld xmlns:a="http://schemas.openxmlformats.org/drawingml/2006/main" xmlns:r="http://schemas.openxmlformats.org/officeDocument/2006/relationships" xmlns:p="http://schemas.openxmlformats.org/presentationml/2006/main">
   <p:cSld>
     <p:bg>
@@ -7917,7 +8924,7 @@
 </p:sld>
 </file>
 
-<file path=ppt/slides/slide5.xml><?xml version="1.0" encoding="utf-8"?>
+<file path=ppt/slides/slide6.xml><?xml version="1.0" encoding="utf-8"?>
 <p:sld xmlns:a="http://schemas.openxmlformats.org/drawingml/2006/main" xmlns:r="http://schemas.openxmlformats.org/officeDocument/2006/relationships" xmlns:p="http://schemas.openxmlformats.org/presentationml/2006/main">
   <p:cSld>
     <p:bg>
@@ -8493,7 +9500,7 @@
 </p:sld>
 </file>
 
-<file path=ppt/slides/slide6.xml><?xml version="1.0" encoding="utf-8"?>
+<file path=ppt/slides/slide7.xml><?xml version="1.0" encoding="utf-8"?>
 <p:sld xmlns:a="http://schemas.openxmlformats.org/drawingml/2006/main" xmlns:r="http://schemas.openxmlformats.org/officeDocument/2006/relationships" xmlns:p="http://schemas.openxmlformats.org/presentationml/2006/main">
   <p:cSld>
     <p:spTree>
@@ -9216,7 +10223,7 @@
 </p:sld>
 </file>
 
-<file path=ppt/slides/slide7.xml><?xml version="1.0" encoding="utf-8"?>
+<file path=ppt/slides/slide8.xml><?xml version="1.0" encoding="utf-8"?>
 <p:sld xmlns:a="http://schemas.openxmlformats.org/drawingml/2006/main" xmlns:r="http://schemas.openxmlformats.org/officeDocument/2006/relationships" xmlns:p="http://schemas.openxmlformats.org/presentationml/2006/main">
   <p:cSld>
     <p:bg>

</xml_diff>

<commit_message>
v0.1.8 Re-worked buzzer circuit.
</commit_message>
<xml_diff>
--- a/.assets/diagrams.pptx
+++ b/.assets/diagrams.pptx
@@ -5,7 +5,7 @@
     <p:sldMasterId id="2147483648" r:id="rId1"/>
   </p:sldMasterIdLst>
   <p:notesMasterIdLst>
-    <p:notesMasterId r:id="rId10"/>
+    <p:notesMasterId r:id="rId11"/>
   </p:notesMasterIdLst>
   <p:sldIdLst>
     <p:sldId id="256" r:id="rId2"/>
@@ -16,6 +16,7 @@
     <p:sldId id="261" r:id="rId7"/>
     <p:sldId id="259" r:id="rId8"/>
     <p:sldId id="262" r:id="rId9"/>
+    <p:sldId id="264" r:id="rId10"/>
   </p:sldIdLst>
   <p:sldSz cx="12192000" cy="6858000"/>
   <p:notesSz cx="6858000" cy="9144000"/>
@@ -204,7 +205,7 @@
           <a:p>
             <a:fld id="{3709B85E-FD1D-4C87-B36A-F5C287A24482}" type="datetimeFigureOut">
               <a:rPr lang="en-US" smtClean="0"/>
-              <a:t>8/1/2025</a:t>
+              <a:t>8/3/2025</a:t>
             </a:fld>
             <a:endParaRPr lang="en-US"/>
           </a:p>
@@ -639,6 +640,90 @@
 </p:notes>
 </file>
 
+<file path=ppt/notesSlides/notesSlide3.xml><?xml version="1.0" encoding="utf-8"?>
+<p:notes xmlns:a="http://schemas.openxmlformats.org/drawingml/2006/main" xmlns:r="http://schemas.openxmlformats.org/officeDocument/2006/relationships" xmlns:p="http://schemas.openxmlformats.org/presentationml/2006/main">
+  <p:cSld>
+    <p:spTree>
+      <p:nvGrpSpPr>
+        <p:cNvPr id="1" name=""/>
+        <p:cNvGrpSpPr/>
+        <p:nvPr/>
+      </p:nvGrpSpPr>
+      <p:grpSpPr>
+        <a:xfrm>
+          <a:off x="0" y="0"/>
+          <a:ext cx="0" cy="0"/>
+          <a:chOff x="0" y="0"/>
+          <a:chExt cx="0" cy="0"/>
+        </a:xfrm>
+      </p:grpSpPr>
+      <p:sp>
+        <p:nvSpPr>
+          <p:cNvPr id="2" name="Slide Image Placeholder 1"/>
+          <p:cNvSpPr>
+            <a:spLocks noGrp="1" noRot="1" noChangeAspect="1"/>
+          </p:cNvSpPr>
+          <p:nvPr>
+            <p:ph type="sldImg"/>
+          </p:nvPr>
+        </p:nvSpPr>
+        <p:spPr/>
+      </p:sp>
+      <p:sp>
+        <p:nvSpPr>
+          <p:cNvPr id="3" name="Notes Placeholder 2"/>
+          <p:cNvSpPr>
+            <a:spLocks noGrp="1"/>
+          </p:cNvSpPr>
+          <p:nvPr>
+            <p:ph type="body" idx="1"/>
+          </p:nvPr>
+        </p:nvSpPr>
+        <p:spPr/>
+        <p:txBody>
+          <a:bodyPr/>
+          <a:lstStyle/>
+          <a:p>
+            <a:endParaRPr lang="en-US"/>
+          </a:p>
+        </p:txBody>
+      </p:sp>
+      <p:sp>
+        <p:nvSpPr>
+          <p:cNvPr id="4" name="Slide Number Placeholder 3"/>
+          <p:cNvSpPr>
+            <a:spLocks noGrp="1"/>
+          </p:cNvSpPr>
+          <p:nvPr>
+            <p:ph type="sldNum" sz="quarter" idx="5"/>
+          </p:nvPr>
+        </p:nvSpPr>
+        <p:spPr/>
+        <p:txBody>
+          <a:bodyPr/>
+          <a:lstStyle/>
+          <a:p>
+            <a:fld id="{9CD017A1-7FA2-4FB5-A9B9-704691091C1D}" type="slidenum">
+              <a:rPr lang="en-US" smtClean="0"/>
+              <a:t>9</a:t>
+            </a:fld>
+            <a:endParaRPr lang="en-US"/>
+          </a:p>
+        </p:txBody>
+      </p:sp>
+    </p:spTree>
+    <p:extLst>
+      <p:ext uri="{BB962C8B-B14F-4D97-AF65-F5344CB8AC3E}">
+        <p14:creationId xmlns:p14="http://schemas.microsoft.com/office/powerpoint/2010/main" val="850109797"/>
+      </p:ext>
+    </p:extLst>
+  </p:cSld>
+  <p:clrMapOvr>
+    <a:masterClrMapping/>
+  </p:clrMapOvr>
+</p:notes>
+</file>
+
 <file path=ppt/slideLayouts/slideLayout1.xml><?xml version="1.0" encoding="utf-8"?>
 <p:sldLayout xmlns:a="http://schemas.openxmlformats.org/drawingml/2006/main" xmlns:r="http://schemas.openxmlformats.org/officeDocument/2006/relationships" xmlns:p="http://schemas.openxmlformats.org/presentationml/2006/main" type="title" preserve="1">
   <p:cSld name="Title Slide">
@@ -786,7 +871,7 @@
           <a:p>
             <a:fld id="{67C30635-7F4C-458C-AB0B-9951B311FD29}" type="datetimeFigureOut">
               <a:rPr lang="en-US" smtClean="0"/>
-              <a:t>8/1/2025</a:t>
+              <a:t>8/3/2025</a:t>
             </a:fld>
             <a:endParaRPr lang="en-US"/>
           </a:p>
@@ -984,7 +1069,7 @@
           <a:p>
             <a:fld id="{67C30635-7F4C-458C-AB0B-9951B311FD29}" type="datetimeFigureOut">
               <a:rPr lang="en-US" smtClean="0"/>
-              <a:t>8/1/2025</a:t>
+              <a:t>8/3/2025</a:t>
             </a:fld>
             <a:endParaRPr lang="en-US"/>
           </a:p>
@@ -1192,7 +1277,7 @@
           <a:p>
             <a:fld id="{67C30635-7F4C-458C-AB0B-9951B311FD29}" type="datetimeFigureOut">
               <a:rPr lang="en-US" smtClean="0"/>
-              <a:t>8/1/2025</a:t>
+              <a:t>8/3/2025</a:t>
             </a:fld>
             <a:endParaRPr lang="en-US"/>
           </a:p>
@@ -1390,7 +1475,7 @@
           <a:p>
             <a:fld id="{67C30635-7F4C-458C-AB0B-9951B311FD29}" type="datetimeFigureOut">
               <a:rPr lang="en-US" smtClean="0"/>
-              <a:t>8/1/2025</a:t>
+              <a:t>8/3/2025</a:t>
             </a:fld>
             <a:endParaRPr lang="en-US"/>
           </a:p>
@@ -1665,7 +1750,7 @@
           <a:p>
             <a:fld id="{67C30635-7F4C-458C-AB0B-9951B311FD29}" type="datetimeFigureOut">
               <a:rPr lang="en-US" smtClean="0"/>
-              <a:t>8/1/2025</a:t>
+              <a:t>8/3/2025</a:t>
             </a:fld>
             <a:endParaRPr lang="en-US"/>
           </a:p>
@@ -1930,7 +2015,7 @@
           <a:p>
             <a:fld id="{67C30635-7F4C-458C-AB0B-9951B311FD29}" type="datetimeFigureOut">
               <a:rPr lang="en-US" smtClean="0"/>
-              <a:t>8/1/2025</a:t>
+              <a:t>8/3/2025</a:t>
             </a:fld>
             <a:endParaRPr lang="en-US"/>
           </a:p>
@@ -2342,7 +2427,7 @@
           <a:p>
             <a:fld id="{67C30635-7F4C-458C-AB0B-9951B311FD29}" type="datetimeFigureOut">
               <a:rPr lang="en-US" smtClean="0"/>
-              <a:t>8/1/2025</a:t>
+              <a:t>8/3/2025</a:t>
             </a:fld>
             <a:endParaRPr lang="en-US"/>
           </a:p>
@@ -2483,7 +2568,7 @@
           <a:p>
             <a:fld id="{67C30635-7F4C-458C-AB0B-9951B311FD29}" type="datetimeFigureOut">
               <a:rPr lang="en-US" smtClean="0"/>
-              <a:t>8/1/2025</a:t>
+              <a:t>8/3/2025</a:t>
             </a:fld>
             <a:endParaRPr lang="en-US"/>
           </a:p>
@@ -2596,7 +2681,7 @@
           <a:p>
             <a:fld id="{67C30635-7F4C-458C-AB0B-9951B311FD29}" type="datetimeFigureOut">
               <a:rPr lang="en-US" smtClean="0"/>
-              <a:t>8/1/2025</a:t>
+              <a:t>8/3/2025</a:t>
             </a:fld>
             <a:endParaRPr lang="en-US"/>
           </a:p>
@@ -2907,7 +2992,7 @@
           <a:p>
             <a:fld id="{67C30635-7F4C-458C-AB0B-9951B311FD29}" type="datetimeFigureOut">
               <a:rPr lang="en-US" smtClean="0"/>
-              <a:t>8/1/2025</a:t>
+              <a:t>8/3/2025</a:t>
             </a:fld>
             <a:endParaRPr lang="en-US"/>
           </a:p>
@@ -3195,7 +3280,7 @@
           <a:p>
             <a:fld id="{67C30635-7F4C-458C-AB0B-9951B311FD29}" type="datetimeFigureOut">
               <a:rPr lang="en-US" smtClean="0"/>
-              <a:t>8/1/2025</a:t>
+              <a:t>8/3/2025</a:t>
             </a:fld>
             <a:endParaRPr lang="en-US"/>
           </a:p>
@@ -3439,7 +3524,7 @@
           <a:p>
             <a:fld id="{67C30635-7F4C-458C-AB0B-9951B311FD29}" type="datetimeFigureOut">
               <a:rPr lang="en-US" smtClean="0"/>
-              <a:t>8/1/2025</a:t>
+              <a:t>8/3/2025</a:t>
             </a:fld>
             <a:endParaRPr lang="en-US"/>
           </a:p>
@@ -10432,6 +10517,224 @@
     <p:extLst>
       <p:ext uri="{BB962C8B-B14F-4D97-AF65-F5344CB8AC3E}">
         <p14:creationId xmlns:p14="http://schemas.microsoft.com/office/powerpoint/2010/main" val="2759011068"/>
+      </p:ext>
+    </p:extLst>
+  </p:cSld>
+  <p:clrMapOvr>
+    <a:masterClrMapping/>
+  </p:clrMapOvr>
+</p:sld>
+</file>
+
+<file path=ppt/slides/slide9.xml><?xml version="1.0" encoding="utf-8"?>
+<p:sld xmlns:a="http://schemas.openxmlformats.org/drawingml/2006/main" xmlns:r="http://schemas.openxmlformats.org/officeDocument/2006/relationships" xmlns:p="http://schemas.openxmlformats.org/presentationml/2006/main">
+  <p:cSld>
+    <p:bg>
+      <p:bgPr>
+        <a:solidFill>
+          <a:srgbClr val="F5F4EF"/>
+        </a:solidFill>
+        <a:effectLst/>
+      </p:bgPr>
+    </p:bg>
+    <p:spTree>
+      <p:nvGrpSpPr>
+        <p:cNvPr id="1" name="">
+          <a:extLst>
+            <a:ext uri="{FF2B5EF4-FFF2-40B4-BE49-F238E27FC236}">
+              <a16:creationId xmlns:a16="http://schemas.microsoft.com/office/drawing/2014/main" id="{9CF629B6-AAF2-8DD4-4D95-87E0CCA32176}"/>
+            </a:ext>
+          </a:extLst>
+        </p:cNvPr>
+        <p:cNvGrpSpPr/>
+        <p:nvPr/>
+      </p:nvGrpSpPr>
+      <p:grpSpPr>
+        <a:xfrm>
+          <a:off x="0" y="0"/>
+          <a:ext cx="0" cy="0"/>
+          <a:chOff x="0" y="0"/>
+          <a:chExt cx="0" cy="0"/>
+        </a:xfrm>
+      </p:grpSpPr>
+      <p:sp>
+        <p:nvSpPr>
+          <p:cNvPr id="4" name="Rectangle 3">
+            <a:extLst>
+              <a:ext uri="{FF2B5EF4-FFF2-40B4-BE49-F238E27FC236}">
+                <a16:creationId xmlns:a16="http://schemas.microsoft.com/office/drawing/2014/main" id="{5EAE7B84-6C76-9D8C-D157-83634D4DD3DF}"/>
+              </a:ext>
+            </a:extLst>
+          </p:cNvPr>
+          <p:cNvSpPr/>
+          <p:nvPr/>
+        </p:nvSpPr>
+        <p:spPr>
+          <a:xfrm>
+            <a:off x="1019436" y="1844824"/>
+            <a:ext cx="6624736" cy="4428492"/>
+          </a:xfrm>
+          <a:prstGeom prst="rect">
+            <a:avLst/>
+          </a:prstGeom>
+          <a:solidFill>
+            <a:srgbClr val="F5F4EF"/>
+          </a:solidFill>
+          <a:ln w="19050">
+            <a:solidFill>
+              <a:srgbClr val="840000"/>
+            </a:solidFill>
+          </a:ln>
+        </p:spPr>
+        <p:style>
+          <a:lnRef idx="2">
+            <a:schemeClr val="accent1">
+              <a:shade val="15000"/>
+            </a:schemeClr>
+          </a:lnRef>
+          <a:fillRef idx="1">
+            <a:schemeClr val="accent1"/>
+          </a:fillRef>
+          <a:effectRef idx="0">
+            <a:schemeClr val="accent1"/>
+          </a:effectRef>
+          <a:fontRef idx="minor">
+            <a:schemeClr val="lt1"/>
+          </a:fontRef>
+        </p:style>
+        <p:txBody>
+          <a:bodyPr rtlCol="0" anchor="ctr"/>
+          <a:lstStyle/>
+          <a:p>
+            <a:pPr algn="ctr"/>
+            <a:endParaRPr lang="en-US">
+              <a:solidFill>
+                <a:schemeClr val="tx1">
+                  <a:lumMod val="75000"/>
+                  <a:lumOff val="25000"/>
+                </a:schemeClr>
+              </a:solidFill>
+            </a:endParaRPr>
+          </a:p>
+        </p:txBody>
+      </p:sp>
+      <p:sp>
+        <p:nvSpPr>
+          <p:cNvPr id="2" name="Title 1">
+            <a:extLst>
+              <a:ext uri="{FF2B5EF4-FFF2-40B4-BE49-F238E27FC236}">
+                <a16:creationId xmlns:a16="http://schemas.microsoft.com/office/drawing/2014/main" id="{28AC1989-A459-6D88-A2F0-A95D6D08E14A}"/>
+              </a:ext>
+            </a:extLst>
+          </p:cNvPr>
+          <p:cNvSpPr>
+            <a:spLocks noGrp="1"/>
+          </p:cNvSpPr>
+          <p:nvPr>
+            <p:ph type="title"/>
+          </p:nvPr>
+        </p:nvSpPr>
+        <p:spPr>
+          <a:xfrm>
+            <a:off x="1343472" y="5553236"/>
+            <a:ext cx="3780420" cy="720080"/>
+          </a:xfrm>
+        </p:spPr>
+        <p:txBody>
+          <a:bodyPr vert="horz" lIns="91440" tIns="45720" rIns="91440" bIns="45720" rtlCol="0" anchor="ctr">
+            <a:normAutofit/>
+          </a:bodyPr>
+          <a:lstStyle/>
+          <a:p>
+            <a:r>
+              <a:rPr lang="en-US" sz="1600" i="1">
+                <a:solidFill>
+                  <a:schemeClr val="tx1">
+                    <a:lumMod val="65000"/>
+                    <a:lumOff val="35000"/>
+                  </a:schemeClr>
+                </a:solidFill>
+                <a:latin typeface="Eras Demi ITC" panose="020B0805030504020804" pitchFamily="34" charset="0"/>
+              </a:rPr>
+              <a:t>Shaped Waveform at 2kHz</a:t>
+            </a:r>
+          </a:p>
+        </p:txBody>
+      </p:sp>
+      <p:sp>
+        <p:nvSpPr>
+          <p:cNvPr id="26" name="TextBox 25">
+            <a:extLst>
+              <a:ext uri="{FF2B5EF4-FFF2-40B4-BE49-F238E27FC236}">
+                <a16:creationId xmlns:a16="http://schemas.microsoft.com/office/drawing/2014/main" id="{D2EFCABF-BBF9-D995-13C6-C015C1E30C2A}"/>
+              </a:ext>
+            </a:extLst>
+          </p:cNvPr>
+          <p:cNvSpPr txBox="1"/>
+          <p:nvPr/>
+        </p:nvSpPr>
+        <p:spPr>
+          <a:xfrm rot="16200000">
+            <a:off x="3562287" y="794989"/>
+            <a:ext cx="410690" cy="169277"/>
+          </a:xfrm>
+          <a:prstGeom prst="rect">
+            <a:avLst/>
+          </a:prstGeom>
+          <a:noFill/>
+        </p:spPr>
+        <p:txBody>
+          <a:bodyPr wrap="none" rtlCol="0">
+            <a:spAutoFit/>
+          </a:bodyPr>
+          <a:lstStyle/>
+          <a:p>
+            <a:pPr algn="ctr"/>
+            <a:r>
+              <a:rPr lang="en-US" sz="500" b="1">
+                <a:solidFill>
+                  <a:schemeClr val="bg1"/>
+                </a:solidFill>
+              </a:rPr>
+              <a:t>Ferrites</a:t>
+            </a:r>
+          </a:p>
+        </p:txBody>
+      </p:sp>
+      <p:pic>
+        <p:nvPicPr>
+          <p:cNvPr id="8" name="Picture 7">
+            <a:extLst>
+              <a:ext uri="{FF2B5EF4-FFF2-40B4-BE49-F238E27FC236}">
+                <a16:creationId xmlns:a16="http://schemas.microsoft.com/office/drawing/2014/main" id="{818B891D-9689-2D83-C32E-363BAC4156BE}"/>
+              </a:ext>
+            </a:extLst>
+          </p:cNvPr>
+          <p:cNvPicPr>
+            <a:picLocks noChangeAspect="1"/>
+          </p:cNvPicPr>
+          <p:nvPr/>
+        </p:nvPicPr>
+        <p:blipFill>
+          <a:blip r:embed="rId3"/>
+          <a:stretch>
+            <a:fillRect/>
+          </a:stretch>
+        </p:blipFill>
+        <p:spPr>
+          <a:xfrm>
+            <a:off x="1334393" y="2924944"/>
+            <a:ext cx="5994821" cy="2694642"/>
+          </a:xfrm>
+          <a:prstGeom prst="rect">
+            <a:avLst/>
+          </a:prstGeom>
+        </p:spPr>
+      </p:pic>
+    </p:spTree>
+    <p:extLst>
+      <p:ext uri="{BB962C8B-B14F-4D97-AF65-F5344CB8AC3E}">
+        <p14:creationId xmlns:p14="http://schemas.microsoft.com/office/powerpoint/2010/main" val="2339124129"/>
       </p:ext>
     </p:extLst>
   </p:cSld>

</xml_diff>

<commit_message>
v0.1.9 New MDD400 PCB Design section
</commit_message>
<xml_diff>
--- a/.assets/diagrams.pptx
+++ b/.assets/diagrams.pptx
@@ -205,7 +205,7 @@
           <a:p>
             <a:fld id="{3709B85E-FD1D-4C87-B36A-F5C287A24482}" type="datetimeFigureOut">
               <a:rPr lang="en-US" smtClean="0"/>
-              <a:t>8/3/2025</a:t>
+              <a:t>8/4/2025</a:t>
             </a:fld>
             <a:endParaRPr lang="en-US"/>
           </a:p>
@@ -621,6 +621,90 @@
           <a:p>
             <a:fld id="{9CD017A1-7FA2-4FB5-A9B9-704691091C1D}" type="slidenum">
               <a:rPr lang="en-US" smtClean="0"/>
+              <a:t>6</a:t>
+            </a:fld>
+            <a:endParaRPr lang="en-US"/>
+          </a:p>
+        </p:txBody>
+      </p:sp>
+    </p:spTree>
+    <p:extLst>
+      <p:ext uri="{BB962C8B-B14F-4D97-AF65-F5344CB8AC3E}">
+        <p14:creationId xmlns:p14="http://schemas.microsoft.com/office/powerpoint/2010/main" val="17072575"/>
+      </p:ext>
+    </p:extLst>
+  </p:cSld>
+  <p:clrMapOvr>
+    <a:masterClrMapping/>
+  </p:clrMapOvr>
+</p:notes>
+</file>
+
+<file path=ppt/notesSlides/notesSlide3.xml><?xml version="1.0" encoding="utf-8"?>
+<p:notes xmlns:a="http://schemas.openxmlformats.org/drawingml/2006/main" xmlns:r="http://schemas.openxmlformats.org/officeDocument/2006/relationships" xmlns:p="http://schemas.openxmlformats.org/presentationml/2006/main">
+  <p:cSld>
+    <p:spTree>
+      <p:nvGrpSpPr>
+        <p:cNvPr id="1" name=""/>
+        <p:cNvGrpSpPr/>
+        <p:nvPr/>
+      </p:nvGrpSpPr>
+      <p:grpSpPr>
+        <a:xfrm>
+          <a:off x="0" y="0"/>
+          <a:ext cx="0" cy="0"/>
+          <a:chOff x="0" y="0"/>
+          <a:chExt cx="0" cy="0"/>
+        </a:xfrm>
+      </p:grpSpPr>
+      <p:sp>
+        <p:nvSpPr>
+          <p:cNvPr id="2" name="Slide Image Placeholder 1"/>
+          <p:cNvSpPr>
+            <a:spLocks noGrp="1" noRot="1" noChangeAspect="1"/>
+          </p:cNvSpPr>
+          <p:nvPr>
+            <p:ph type="sldImg"/>
+          </p:nvPr>
+        </p:nvSpPr>
+        <p:spPr/>
+      </p:sp>
+      <p:sp>
+        <p:nvSpPr>
+          <p:cNvPr id="3" name="Notes Placeholder 2"/>
+          <p:cNvSpPr>
+            <a:spLocks noGrp="1"/>
+          </p:cNvSpPr>
+          <p:nvPr>
+            <p:ph type="body" idx="1"/>
+          </p:nvPr>
+        </p:nvSpPr>
+        <p:spPr/>
+        <p:txBody>
+          <a:bodyPr/>
+          <a:lstStyle/>
+          <a:p>
+            <a:endParaRPr lang="en-US"/>
+          </a:p>
+        </p:txBody>
+      </p:sp>
+      <p:sp>
+        <p:nvSpPr>
+          <p:cNvPr id="4" name="Slide Number Placeholder 3"/>
+          <p:cNvSpPr>
+            <a:spLocks noGrp="1"/>
+          </p:cNvSpPr>
+          <p:nvPr>
+            <p:ph type="sldNum" sz="quarter" idx="5"/>
+          </p:nvPr>
+        </p:nvSpPr>
+        <p:spPr/>
+        <p:txBody>
+          <a:bodyPr/>
+          <a:lstStyle/>
+          <a:p>
+            <a:fld id="{9CD017A1-7FA2-4FB5-A9B9-704691091C1D}" type="slidenum">
+              <a:rPr lang="en-US" smtClean="0"/>
               <a:t>7</a:t>
             </a:fld>
             <a:endParaRPr lang="en-US"/>
@@ -640,7 +724,7 @@
 </p:notes>
 </file>
 
-<file path=ppt/notesSlides/notesSlide3.xml><?xml version="1.0" encoding="utf-8"?>
+<file path=ppt/notesSlides/notesSlide4.xml><?xml version="1.0" encoding="utf-8"?>
 <p:notes xmlns:a="http://schemas.openxmlformats.org/drawingml/2006/main" xmlns:r="http://schemas.openxmlformats.org/officeDocument/2006/relationships" xmlns:p="http://schemas.openxmlformats.org/presentationml/2006/main">
   <p:cSld>
     <p:spTree>
@@ -871,7 +955,7 @@
           <a:p>
             <a:fld id="{67C30635-7F4C-458C-AB0B-9951B311FD29}" type="datetimeFigureOut">
               <a:rPr lang="en-US" smtClean="0"/>
-              <a:t>8/3/2025</a:t>
+              <a:t>8/4/2025</a:t>
             </a:fld>
             <a:endParaRPr lang="en-US"/>
           </a:p>
@@ -1069,7 +1153,7 @@
           <a:p>
             <a:fld id="{67C30635-7F4C-458C-AB0B-9951B311FD29}" type="datetimeFigureOut">
               <a:rPr lang="en-US" smtClean="0"/>
-              <a:t>8/3/2025</a:t>
+              <a:t>8/4/2025</a:t>
             </a:fld>
             <a:endParaRPr lang="en-US"/>
           </a:p>
@@ -1277,7 +1361,7 @@
           <a:p>
             <a:fld id="{67C30635-7F4C-458C-AB0B-9951B311FD29}" type="datetimeFigureOut">
               <a:rPr lang="en-US" smtClean="0"/>
-              <a:t>8/3/2025</a:t>
+              <a:t>8/4/2025</a:t>
             </a:fld>
             <a:endParaRPr lang="en-US"/>
           </a:p>
@@ -1475,7 +1559,7 @@
           <a:p>
             <a:fld id="{67C30635-7F4C-458C-AB0B-9951B311FD29}" type="datetimeFigureOut">
               <a:rPr lang="en-US" smtClean="0"/>
-              <a:t>8/3/2025</a:t>
+              <a:t>8/4/2025</a:t>
             </a:fld>
             <a:endParaRPr lang="en-US"/>
           </a:p>
@@ -1750,7 +1834,7 @@
           <a:p>
             <a:fld id="{67C30635-7F4C-458C-AB0B-9951B311FD29}" type="datetimeFigureOut">
               <a:rPr lang="en-US" smtClean="0"/>
-              <a:t>8/3/2025</a:t>
+              <a:t>8/4/2025</a:t>
             </a:fld>
             <a:endParaRPr lang="en-US"/>
           </a:p>
@@ -2015,7 +2099,7 @@
           <a:p>
             <a:fld id="{67C30635-7F4C-458C-AB0B-9951B311FD29}" type="datetimeFigureOut">
               <a:rPr lang="en-US" smtClean="0"/>
-              <a:t>8/3/2025</a:t>
+              <a:t>8/4/2025</a:t>
             </a:fld>
             <a:endParaRPr lang="en-US"/>
           </a:p>
@@ -2427,7 +2511,7 @@
           <a:p>
             <a:fld id="{67C30635-7F4C-458C-AB0B-9951B311FD29}" type="datetimeFigureOut">
               <a:rPr lang="en-US" smtClean="0"/>
-              <a:t>8/3/2025</a:t>
+              <a:t>8/4/2025</a:t>
             </a:fld>
             <a:endParaRPr lang="en-US"/>
           </a:p>
@@ -2568,7 +2652,7 @@
           <a:p>
             <a:fld id="{67C30635-7F4C-458C-AB0B-9951B311FD29}" type="datetimeFigureOut">
               <a:rPr lang="en-US" smtClean="0"/>
-              <a:t>8/3/2025</a:t>
+              <a:t>8/4/2025</a:t>
             </a:fld>
             <a:endParaRPr lang="en-US"/>
           </a:p>
@@ -2681,7 +2765,7 @@
           <a:p>
             <a:fld id="{67C30635-7F4C-458C-AB0B-9951B311FD29}" type="datetimeFigureOut">
               <a:rPr lang="en-US" smtClean="0"/>
-              <a:t>8/3/2025</a:t>
+              <a:t>8/4/2025</a:t>
             </a:fld>
             <a:endParaRPr lang="en-US"/>
           </a:p>
@@ -2992,7 +3076,7 @@
           <a:p>
             <a:fld id="{67C30635-7F4C-458C-AB0B-9951B311FD29}" type="datetimeFigureOut">
               <a:rPr lang="en-US" smtClean="0"/>
-              <a:t>8/3/2025</a:t>
+              <a:t>8/4/2025</a:t>
             </a:fld>
             <a:endParaRPr lang="en-US"/>
           </a:p>
@@ -3280,7 +3364,7 @@
           <a:p>
             <a:fld id="{67C30635-7F4C-458C-AB0B-9951B311FD29}" type="datetimeFigureOut">
               <a:rPr lang="en-US" smtClean="0"/>
-              <a:t>8/3/2025</a:t>
+              <a:t>8/4/2025</a:t>
             </a:fld>
             <a:endParaRPr lang="en-US"/>
           </a:p>
@@ -3524,7 +3608,7 @@
           <a:p>
             <a:fld id="{67C30635-7F4C-458C-AB0B-9951B311FD29}" type="datetimeFigureOut">
               <a:rPr lang="en-US" smtClean="0"/>
-              <a:t>8/3/2025</a:t>
+              <a:t>8/4/2025</a:t>
             </a:fld>
             <a:endParaRPr lang="en-US"/>
           </a:p>
@@ -9103,10 +9187,10 @@
       </p:sp>
       <p:pic>
         <p:nvPicPr>
-          <p:cNvPr id="6" name="Picture 5">
-            <a:extLst>
-              <a:ext uri="{FF2B5EF4-FFF2-40B4-BE49-F238E27FC236}">
-                <a16:creationId xmlns:a16="http://schemas.microsoft.com/office/drawing/2014/main" id="{E12EACED-0E19-21E6-AC73-BF7F8E5E7DA3}"/>
+          <p:cNvPr id="8" name="Picture 7">
+            <a:extLst>
+              <a:ext uri="{FF2B5EF4-FFF2-40B4-BE49-F238E27FC236}">
+                <a16:creationId xmlns:a16="http://schemas.microsoft.com/office/drawing/2014/main" id="{30CC825A-3191-EE57-0FF2-E8F8AE02E227}"/>
               </a:ext>
             </a:extLst>
           </p:cNvPr>
@@ -9116,19 +9200,22 @@
           <p:nvPr/>
         </p:nvPicPr>
         <p:blipFill>
-          <a:blip r:embed="rId2"/>
+          <a:blip r:embed="rId3"/>
           <a:stretch>
             <a:fillRect/>
           </a:stretch>
         </p:blipFill>
         <p:spPr>
           <a:xfrm>
-            <a:off x="1713729" y="415274"/>
-            <a:ext cx="4978943" cy="4947331"/>
+            <a:off x="1685794" y="415274"/>
+            <a:ext cx="4954983" cy="4947331"/>
           </a:xfrm>
           <a:prstGeom prst="rect">
             <a:avLst/>
           </a:prstGeom>
+          <a:solidFill>
+            <a:srgbClr val="A20000"/>
+          </a:solidFill>
         </p:spPr>
       </p:pic>
       <p:sp>
@@ -9149,8 +9236,8 @@
         </p:nvSpPr>
         <p:spPr>
           <a:xfrm>
-            <a:off x="1343472" y="5553236"/>
-            <a:ext cx="3025552" cy="720080"/>
+            <a:off x="1307468" y="5648551"/>
+            <a:ext cx="3384376" cy="720080"/>
           </a:xfrm>
         </p:spPr>
         <p:txBody>
@@ -9160,7 +9247,7 @@
           <a:lstStyle/>
           <a:p>
             <a:r>
-              <a:rPr lang="en-US" sz="1800" i="1">
+              <a:rPr lang="en-US" sz="1600" i="1">
                 <a:solidFill>
                   <a:schemeClr val="tx1">
                     <a:lumMod val="65000"/>
@@ -9169,7 +9256,7 @@
                 </a:solidFill>
                 <a:latin typeface="Eras Demi ITC" panose="020B0805030504020804" pitchFamily="34" charset="0"/>
               </a:rPr>
-              <a:t>MDD400 Ground Planes</a:t>
+              <a:t>MDD400 Functional Domains</a:t>
             </a:r>
           </a:p>
         </p:txBody>
@@ -9188,8 +9275,8 @@
         </p:nvSpPr>
         <p:spPr>
           <a:xfrm rot="16200000">
-            <a:off x="3562287" y="794989"/>
-            <a:ext cx="410690" cy="169277"/>
+            <a:off x="3263039" y="837992"/>
+            <a:ext cx="784189" cy="230832"/>
           </a:xfrm>
           <a:prstGeom prst="rect">
             <a:avLst/>
@@ -9204,9 +9291,89 @@
           <a:p>
             <a:pPr algn="ctr"/>
             <a:r>
-              <a:rPr lang="en-US" sz="500" b="1">
+              <a:rPr lang="en-US" sz="900" b="1">
                 <a:solidFill>
-                  <a:schemeClr val="bg1"/>
+                  <a:srgbClr val="FFFF00"/>
+                </a:solidFill>
+              </a:rPr>
+              <a:t>CM Chokes</a:t>
+            </a:r>
+          </a:p>
+        </p:txBody>
+      </p:sp>
+      <p:sp>
+        <p:nvSpPr>
+          <p:cNvPr id="27" name="TextBox 26">
+            <a:extLst>
+              <a:ext uri="{FF2B5EF4-FFF2-40B4-BE49-F238E27FC236}">
+                <a16:creationId xmlns:a16="http://schemas.microsoft.com/office/drawing/2014/main" id="{C7775AF3-E1FC-B231-255F-995DFE9BED29}"/>
+              </a:ext>
+            </a:extLst>
+          </p:cNvPr>
+          <p:cNvSpPr txBox="1"/>
+          <p:nvPr/>
+        </p:nvSpPr>
+        <p:spPr>
+          <a:xfrm>
+            <a:off x="5518971" y="2393008"/>
+            <a:ext cx="947696" cy="230832"/>
+          </a:xfrm>
+          <a:prstGeom prst="rect">
+            <a:avLst/>
+          </a:prstGeom>
+          <a:noFill/>
+        </p:spPr>
+        <p:txBody>
+          <a:bodyPr wrap="none" rtlCol="0">
+            <a:spAutoFit/>
+          </a:bodyPr>
+          <a:lstStyle/>
+          <a:p>
+            <a:pPr algn="ctr"/>
+            <a:r>
+              <a:rPr lang="en-US" sz="900" b="1">
+                <a:solidFill>
+                  <a:srgbClr val="FFFF00"/>
+                </a:solidFill>
+              </a:rPr>
+              <a:t>Opto-isolators</a:t>
+            </a:r>
+          </a:p>
+        </p:txBody>
+      </p:sp>
+      <p:sp>
+        <p:nvSpPr>
+          <p:cNvPr id="9" name="TextBox 8">
+            <a:extLst>
+              <a:ext uri="{FF2B5EF4-FFF2-40B4-BE49-F238E27FC236}">
+                <a16:creationId xmlns:a16="http://schemas.microsoft.com/office/drawing/2014/main" id="{227ED8AB-371F-F6EF-D4B5-197FA235DD09}"/>
+              </a:ext>
+            </a:extLst>
+          </p:cNvPr>
+          <p:cNvSpPr txBox="1"/>
+          <p:nvPr/>
+        </p:nvSpPr>
+        <p:spPr>
+          <a:xfrm>
+            <a:off x="2135560" y="1412776"/>
+            <a:ext cx="593432" cy="230832"/>
+          </a:xfrm>
+          <a:prstGeom prst="rect">
+            <a:avLst/>
+          </a:prstGeom>
+          <a:noFill/>
+        </p:spPr>
+        <p:txBody>
+          <a:bodyPr wrap="none" rtlCol="0">
+            <a:spAutoFit/>
+          </a:bodyPr>
+          <a:lstStyle/>
+          <a:p>
+            <a:pPr algn="ctr"/>
+            <a:r>
+              <a:rPr lang="en-US" sz="900" b="1">
+                <a:solidFill>
+                  <a:srgbClr val="FFFF00"/>
                 </a:solidFill>
               </a:rPr>
               <a:t>Ferrites</a:t>
@@ -9216,114 +9383,10 @@
       </p:sp>
       <p:sp>
         <p:nvSpPr>
-          <p:cNvPr id="27" name="TextBox 26">
-            <a:extLst>
-              <a:ext uri="{FF2B5EF4-FFF2-40B4-BE49-F238E27FC236}">
-                <a16:creationId xmlns:a16="http://schemas.microsoft.com/office/drawing/2014/main" id="{C7775AF3-E1FC-B231-255F-995DFE9BED29}"/>
-              </a:ext>
-            </a:extLst>
-          </p:cNvPr>
-          <p:cNvSpPr txBox="1"/>
-          <p:nvPr/>
-        </p:nvSpPr>
-        <p:spPr>
-          <a:xfrm>
-            <a:off x="5688087" y="2393008"/>
-            <a:ext cx="609462" cy="169277"/>
-          </a:xfrm>
-          <a:prstGeom prst="rect">
-            <a:avLst/>
-          </a:prstGeom>
-          <a:noFill/>
-        </p:spPr>
-        <p:txBody>
-          <a:bodyPr wrap="none" rtlCol="0">
-            <a:spAutoFit/>
-          </a:bodyPr>
-          <a:lstStyle/>
-          <a:p>
-            <a:pPr algn="ctr"/>
-            <a:r>
-              <a:rPr lang="en-US" sz="500" b="1">
-                <a:solidFill>
-                  <a:schemeClr val="bg1"/>
-                </a:solidFill>
-              </a:rPr>
-              <a:t>Opto-isolators</a:t>
-            </a:r>
-          </a:p>
-        </p:txBody>
-      </p:sp>
-      <p:sp>
-        <p:nvSpPr>
-          <p:cNvPr id="28" name="TextBox 27">
-            <a:extLst>
-              <a:ext uri="{FF2B5EF4-FFF2-40B4-BE49-F238E27FC236}">
-                <a16:creationId xmlns:a16="http://schemas.microsoft.com/office/drawing/2014/main" id="{224DD0B2-845F-C9A1-3FA2-BD874A6CAD6C}"/>
-              </a:ext>
-            </a:extLst>
-          </p:cNvPr>
-          <p:cNvSpPr txBox="1"/>
-          <p:nvPr/>
-        </p:nvSpPr>
-        <p:spPr>
-          <a:xfrm>
-            <a:off x="4302654" y="2803817"/>
-            <a:ext cx="671979" cy="307777"/>
-          </a:xfrm>
-          <a:prstGeom prst="rect">
-            <a:avLst/>
-          </a:prstGeom>
-          <a:noFill/>
-        </p:spPr>
-        <p:txBody>
-          <a:bodyPr wrap="none" rtlCol="0">
-            <a:spAutoFit/>
-          </a:bodyPr>
-          <a:lstStyle/>
-          <a:p>
-            <a:pPr algn="ctr"/>
-            <a:r>
-              <a:rPr lang="en-US" sz="700" b="1">
-                <a:solidFill>
-                  <a:schemeClr val="tx1">
-                    <a:lumMod val="85000"/>
-                    <a:lumOff val="15000"/>
-                  </a:schemeClr>
-                </a:solidFill>
-              </a:rPr>
-              <a:t>Display FFC</a:t>
-            </a:r>
-            <a:br>
-              <a:rPr lang="en-US" sz="700" b="1">
-                <a:solidFill>
-                  <a:schemeClr val="tx1">
-                    <a:lumMod val="85000"/>
-                    <a:lumOff val="15000"/>
-                  </a:schemeClr>
-                </a:solidFill>
-              </a:rPr>
-            </a:br>
-            <a:r>
-              <a:rPr lang="en-US" sz="700" b="1">
-                <a:solidFill>
-                  <a:schemeClr val="tx1">
-                    <a:lumMod val="85000"/>
-                    <a:lumOff val="15000"/>
-                  </a:schemeClr>
-                </a:solidFill>
-              </a:rPr>
-              <a:t>Cutout</a:t>
-            </a:r>
-          </a:p>
-        </p:txBody>
-      </p:sp>
-      <p:sp>
-        <p:nvSpPr>
-          <p:cNvPr id="3" name="Rectangle 2">
-            <a:extLst>
-              <a:ext uri="{FF2B5EF4-FFF2-40B4-BE49-F238E27FC236}">
-                <a16:creationId xmlns:a16="http://schemas.microsoft.com/office/drawing/2014/main" id="{24616145-BD9B-5A7E-5896-7EA21D594744}"/>
+          <p:cNvPr id="10" name="Rectangle 9">
+            <a:extLst>
+              <a:ext uri="{FF2B5EF4-FFF2-40B4-BE49-F238E27FC236}">
+                <a16:creationId xmlns:a16="http://schemas.microsoft.com/office/drawing/2014/main" id="{8C0084E9-EDFC-EAFE-DE90-139AA59DBE24}"/>
               </a:ext>
             </a:extLst>
           </p:cNvPr>
@@ -9332,16 +9395,88 @@
         </p:nvSpPr>
         <p:spPr>
           <a:xfrm>
-            <a:off x="1893632" y="3897052"/>
-            <a:ext cx="1656183" cy="1276896"/>
+            <a:off x="1893633" y="1684052"/>
+            <a:ext cx="1574076" cy="2212999"/>
           </a:xfrm>
           <a:prstGeom prst="rect">
             <a:avLst/>
           </a:prstGeom>
-          <a:noFill/>
+          <a:solidFill>
+            <a:srgbClr val="A20000">
+              <a:alpha val="40000"/>
+            </a:srgbClr>
+          </a:solidFill>
           <a:ln w="19050">
             <a:solidFill>
-              <a:srgbClr val="FFFF00"/>
+              <a:srgbClr val="A20000"/>
+            </a:solidFill>
+          </a:ln>
+        </p:spPr>
+        <p:style>
+          <a:lnRef idx="2">
+            <a:schemeClr val="accent1">
+              <a:shade val="15000"/>
+            </a:schemeClr>
+          </a:lnRef>
+          <a:fillRef idx="1">
+            <a:schemeClr val="accent1"/>
+          </a:fillRef>
+          <a:effectRef idx="0">
+            <a:schemeClr val="accent1"/>
+          </a:effectRef>
+          <a:fontRef idx="minor">
+            <a:schemeClr val="lt1"/>
+          </a:fontRef>
+        </p:style>
+        <p:txBody>
+          <a:bodyPr rtlCol="0" anchor="ctr"/>
+          <a:lstStyle/>
+          <a:p>
+            <a:pPr algn="ctr"/>
+            <a:endParaRPr lang="en-US">
+              <a:solidFill>
+                <a:schemeClr val="tx1">
+                  <a:lumMod val="75000"/>
+                  <a:lumOff val="25000"/>
+                </a:schemeClr>
+              </a:solidFill>
+              <a:highlight>
+                <a:srgbClr val="A20000"/>
+              </a:highlight>
+            </a:endParaRPr>
+          </a:p>
+        </p:txBody>
+      </p:sp>
+      <p:sp>
+        <p:nvSpPr>
+          <p:cNvPr id="12" name="Rectangle 11">
+            <a:extLst>
+              <a:ext uri="{FF2B5EF4-FFF2-40B4-BE49-F238E27FC236}">
+                <a16:creationId xmlns:a16="http://schemas.microsoft.com/office/drawing/2014/main" id="{D8AB07CB-46C9-4097-77A1-7726323E6ABA}"/>
+              </a:ext>
+            </a:extLst>
+          </p:cNvPr>
+          <p:cNvSpPr/>
+          <p:nvPr/>
+        </p:nvSpPr>
+        <p:spPr>
+          <a:xfrm>
+            <a:off x="1887389" y="619639"/>
+            <a:ext cx="1574076" cy="721128"/>
+          </a:xfrm>
+          <a:prstGeom prst="rect">
+            <a:avLst/>
+          </a:prstGeom>
+          <a:solidFill>
+            <a:srgbClr val="084F6A">
+              <a:alpha val="40000"/>
+            </a:srgbClr>
+          </a:solidFill>
+          <a:ln w="19050">
+            <a:solidFill>
+              <a:schemeClr val="accent4">
+                <a:lumMod val="50000"/>
+              </a:schemeClr>
             </a:solidFill>
           </a:ln>
         </p:spPr>
@@ -9379,10 +9514,10 @@
       </p:sp>
       <p:sp>
         <p:nvSpPr>
-          <p:cNvPr id="5" name="Speech Bubble: Rectangle with Corners Rounded 4">
-            <a:extLst>
-              <a:ext uri="{FF2B5EF4-FFF2-40B4-BE49-F238E27FC236}">
-                <a16:creationId xmlns:a16="http://schemas.microsoft.com/office/drawing/2014/main" id="{60D38A7C-783F-26D5-5EDF-F20641F8F94B}"/>
+          <p:cNvPr id="14" name="Rectangle 13">
+            <a:extLst>
+              <a:ext uri="{FF2B5EF4-FFF2-40B4-BE49-F238E27FC236}">
+                <a16:creationId xmlns:a16="http://schemas.microsoft.com/office/drawing/2014/main" id="{B846D954-C391-5DC3-3975-7854A23586B1}"/>
               </a:ext>
             </a:extLst>
           </p:cNvPr>
@@ -9391,84 +9526,22 @@
         </p:nvSpPr>
         <p:spPr>
           <a:xfrm>
-            <a:off x="5433317" y="1572911"/>
-            <a:ext cx="1044116" cy="432048"/>
-          </a:xfrm>
-          <a:prstGeom prst="wedgeRoundRectCallout">
-            <a:avLst>
-              <a:gd name="adj1" fmla="val -45058"/>
-              <a:gd name="adj2" fmla="val 147744"/>
-              <a:gd name="adj3" fmla="val 16667"/>
-            </a:avLst>
+            <a:off x="3898305" y="619639"/>
+            <a:ext cx="2521732" cy="1771874"/>
+          </a:xfrm>
+          <a:prstGeom prst="rect">
+            <a:avLst/>
           </a:prstGeom>
           <a:solidFill>
-            <a:srgbClr val="F5F4EF"/>
+            <a:schemeClr val="bg2">
+              <a:alpha val="40000"/>
+            </a:schemeClr>
           </a:solidFill>
           <a:ln w="19050">
             <a:solidFill>
-              <a:srgbClr val="840000"/>
-            </a:solidFill>
-          </a:ln>
-        </p:spPr>
-        <p:style>
-          <a:lnRef idx="2">
-            <a:schemeClr val="accent1">
-              <a:shade val="15000"/>
-            </a:schemeClr>
-          </a:lnRef>
-          <a:fillRef idx="1">
-            <a:schemeClr val="accent1"/>
-          </a:fillRef>
-          <a:effectRef idx="0">
-            <a:schemeClr val="accent1"/>
-          </a:effectRef>
-          <a:fontRef idx="minor">
-            <a:schemeClr val="lt1"/>
-          </a:fontRef>
-        </p:style>
-        <p:txBody>
-          <a:bodyPr rtlCol="0" anchor="ctr"/>
-          <a:lstStyle/>
-          <a:p>
-            <a:pPr algn="ctr"/>
-            <a:r>
-              <a:rPr lang="en-US" sz="800" b="1">
-                <a:solidFill>
-                  <a:schemeClr val="tx1">
-                    <a:lumMod val="75000"/>
-                    <a:lumOff val="25000"/>
-                  </a:schemeClr>
-                </a:solidFill>
-              </a:rPr>
-              <a:t>No components or traces in this area</a:t>
-            </a:r>
-          </a:p>
-        </p:txBody>
-      </p:sp>
-      <p:sp>
-        <p:nvSpPr>
-          <p:cNvPr id="11" name="Rectangle 10">
-            <a:extLst>
-              <a:ext uri="{FF2B5EF4-FFF2-40B4-BE49-F238E27FC236}">
-                <a16:creationId xmlns:a16="http://schemas.microsoft.com/office/drawing/2014/main" id="{F85345CF-C1CD-C635-DB5A-F748C20213F2}"/>
-              </a:ext>
-            </a:extLst>
-          </p:cNvPr>
-          <p:cNvSpPr/>
-          <p:nvPr/>
-        </p:nvSpPr>
-        <p:spPr>
-          <a:xfrm>
-            <a:off x="3810551" y="2472958"/>
-            <a:ext cx="1656183" cy="2772308"/>
-          </a:xfrm>
-          <a:prstGeom prst="rect">
-            <a:avLst/>
-          </a:prstGeom>
-          <a:noFill/>
-          <a:ln w="19050">
-            <a:solidFill>
-              <a:srgbClr val="FFFF00"/>
+              <a:schemeClr val="bg1">
+                <a:lumMod val="95000"/>
+              </a:schemeClr>
             </a:solidFill>
           </a:ln>
         </p:spPr>
@@ -9506,10 +9579,10 @@
       </p:sp>
       <p:sp>
         <p:nvSpPr>
-          <p:cNvPr id="13" name="Speech Bubble: Rectangle with Corners Rounded 12">
-            <a:extLst>
-              <a:ext uri="{FF2B5EF4-FFF2-40B4-BE49-F238E27FC236}">
-                <a16:creationId xmlns:a16="http://schemas.microsoft.com/office/drawing/2014/main" id="{89844778-551B-BB2B-445E-9CE52BA3AF72}"/>
+          <p:cNvPr id="15" name="Rectangle 14">
+            <a:extLst>
+              <a:ext uri="{FF2B5EF4-FFF2-40B4-BE49-F238E27FC236}">
+                <a16:creationId xmlns:a16="http://schemas.microsoft.com/office/drawing/2014/main" id="{3A7ED21A-2DBC-B28D-FDC5-62CDDC02F5AB}"/>
               </a:ext>
             </a:extLst>
           </p:cNvPr>
@@ -9518,22 +9591,20 @@
         </p:nvSpPr>
         <p:spPr>
           <a:xfrm>
-            <a:off x="2274334" y="2981467"/>
-            <a:ext cx="1044116" cy="432048"/>
-          </a:xfrm>
-          <a:prstGeom prst="wedgeRoundRectCallout">
-            <a:avLst>
-              <a:gd name="adj1" fmla="val -45058"/>
-              <a:gd name="adj2" fmla="val 147744"/>
-              <a:gd name="adj3" fmla="val 16667"/>
-            </a:avLst>
+            <a:off x="5452643" y="2628463"/>
+            <a:ext cx="1014024" cy="2096681"/>
+          </a:xfrm>
+          <a:prstGeom prst="rect">
+            <a:avLst/>
           </a:prstGeom>
           <a:solidFill>
-            <a:srgbClr val="F5F4EF"/>
+            <a:srgbClr val="11838F">
+              <a:alpha val="50196"/>
+            </a:srgbClr>
           </a:solidFill>
           <a:ln w="19050">
             <a:solidFill>
-              <a:srgbClr val="840000"/>
+              <a:srgbClr val="11838F"/>
             </a:solidFill>
           </a:ln>
         </p:spPr>
@@ -9558,17 +9629,227 @@
           <a:lstStyle/>
           <a:p>
             <a:pPr algn="ctr"/>
-            <a:r>
-              <a:rPr lang="en-US" sz="800" b="1">
+            <a:endParaRPr lang="en-US">
+              <a:solidFill>
+                <a:schemeClr val="tx1">
+                  <a:lumMod val="75000"/>
+                  <a:lumOff val="25000"/>
+                </a:schemeClr>
+              </a:solidFill>
+            </a:endParaRPr>
+          </a:p>
+        </p:txBody>
+      </p:sp>
+      <p:sp>
+        <p:nvSpPr>
+          <p:cNvPr id="21" name="TextBox 20">
+            <a:extLst>
+              <a:ext uri="{FF2B5EF4-FFF2-40B4-BE49-F238E27FC236}">
+                <a16:creationId xmlns:a16="http://schemas.microsoft.com/office/drawing/2014/main" id="{1D6A5E16-390E-11D2-44F8-0ED5AF71F5E6}"/>
+              </a:ext>
+            </a:extLst>
+          </p:cNvPr>
+          <p:cNvSpPr txBox="1"/>
+          <p:nvPr/>
+        </p:nvSpPr>
+        <p:spPr>
+          <a:xfrm>
+            <a:off x="1786945" y="842460"/>
+            <a:ext cx="1767860" cy="230832"/>
+          </a:xfrm>
+          <a:prstGeom prst="rect">
+            <a:avLst/>
+          </a:prstGeom>
+          <a:noFill/>
+        </p:spPr>
+        <p:txBody>
+          <a:bodyPr wrap="square" rtlCol="0">
+            <a:spAutoFit/>
+          </a:bodyPr>
+          <a:lstStyle/>
+          <a:p>
+            <a:pPr algn="ctr"/>
+            <a:r>
+              <a:rPr lang="en-US" sz="900" b="1" i="1">
+                <a:solidFill>
+                  <a:schemeClr val="bg1"/>
+                </a:solidFill>
+              </a:rPr>
+              <a:t>SMPS</a:t>
+            </a:r>
+            <a:r>
+              <a:rPr lang="en-US" sz="900" b="1">
+                <a:solidFill>
+                  <a:schemeClr val="bg1"/>
+                </a:solidFill>
+              </a:rPr>
+              <a:t> Domain</a:t>
+            </a:r>
+            <a:endParaRPr lang="en-US" sz="900">
+              <a:solidFill>
+                <a:schemeClr val="bg1"/>
+              </a:solidFill>
+            </a:endParaRPr>
+          </a:p>
+        </p:txBody>
+      </p:sp>
+      <p:sp>
+        <p:nvSpPr>
+          <p:cNvPr id="22" name="TextBox 21">
+            <a:extLst>
+              <a:ext uri="{FF2B5EF4-FFF2-40B4-BE49-F238E27FC236}">
+                <a16:creationId xmlns:a16="http://schemas.microsoft.com/office/drawing/2014/main" id="{B15923FB-8A5D-3D8A-4CF0-9B6F6411A519}"/>
+              </a:ext>
+            </a:extLst>
+          </p:cNvPr>
+          <p:cNvSpPr txBox="1"/>
+          <p:nvPr/>
+        </p:nvSpPr>
+        <p:spPr>
+          <a:xfrm>
+            <a:off x="2017504" y="2354831"/>
+            <a:ext cx="1296144" cy="230832"/>
+          </a:xfrm>
+          <a:prstGeom prst="rect">
+            <a:avLst/>
+          </a:prstGeom>
+          <a:noFill/>
+        </p:spPr>
+        <p:txBody>
+          <a:bodyPr wrap="square" rtlCol="0">
+            <a:spAutoFit/>
+          </a:bodyPr>
+          <a:lstStyle/>
+          <a:p>
+            <a:pPr algn="ctr"/>
+            <a:r>
+              <a:rPr lang="en-US" sz="900" b="1">
+                <a:solidFill>
+                  <a:schemeClr val="bg1"/>
+                </a:solidFill>
+              </a:rPr>
+              <a:t>CAN Domain</a:t>
+            </a:r>
+            <a:endParaRPr lang="en-US" sz="900">
+              <a:solidFill>
+                <a:schemeClr val="bg1"/>
+              </a:solidFill>
+            </a:endParaRPr>
+          </a:p>
+        </p:txBody>
+      </p:sp>
+      <p:sp>
+        <p:nvSpPr>
+          <p:cNvPr id="24" name="TextBox 23">
+            <a:extLst>
+              <a:ext uri="{FF2B5EF4-FFF2-40B4-BE49-F238E27FC236}">
+                <a16:creationId xmlns:a16="http://schemas.microsoft.com/office/drawing/2014/main" id="{351CCCD8-904E-77D0-57E3-2308BBEBE4A1}"/>
+              </a:ext>
+            </a:extLst>
+          </p:cNvPr>
+          <p:cNvSpPr txBox="1"/>
+          <p:nvPr/>
+        </p:nvSpPr>
+        <p:spPr>
+          <a:xfrm>
+            <a:off x="4217095" y="1282242"/>
+            <a:ext cx="1980612" cy="230832"/>
+          </a:xfrm>
+          <a:prstGeom prst="rect">
+            <a:avLst/>
+          </a:prstGeom>
+          <a:noFill/>
+        </p:spPr>
+        <p:txBody>
+          <a:bodyPr wrap="square" rtlCol="0">
+            <a:spAutoFit/>
+          </a:bodyPr>
+          <a:lstStyle/>
+          <a:p>
+            <a:pPr algn="ctr"/>
+            <a:r>
+              <a:rPr lang="en-US" sz="900" b="1" i="1">
                 <a:solidFill>
                   <a:schemeClr val="tx1">
-                    <a:lumMod val="75000"/>
-                    <a:lumOff val="25000"/>
+                    <a:lumMod val="85000"/>
+                    <a:lumOff val="15000"/>
                   </a:schemeClr>
                 </a:solidFill>
               </a:rPr>
-              <a:t>No components or traces in this area</a:t>
-            </a:r>
+              <a:t>DIGITAL</a:t>
+            </a:r>
+            <a:r>
+              <a:rPr lang="en-US" sz="900" b="1">
+                <a:solidFill>
+                  <a:schemeClr val="tx1">
+                    <a:lumMod val="85000"/>
+                    <a:lumOff val="15000"/>
+                  </a:schemeClr>
+                </a:solidFill>
+              </a:rPr>
+              <a:t> Domain</a:t>
+            </a:r>
+            <a:endParaRPr lang="en-US" sz="900">
+              <a:solidFill>
+                <a:schemeClr val="tx1">
+                  <a:lumMod val="85000"/>
+                  <a:lumOff val="15000"/>
+                </a:schemeClr>
+              </a:solidFill>
+            </a:endParaRPr>
+          </a:p>
+        </p:txBody>
+      </p:sp>
+      <p:sp>
+        <p:nvSpPr>
+          <p:cNvPr id="25" name="TextBox 24">
+            <a:extLst>
+              <a:ext uri="{FF2B5EF4-FFF2-40B4-BE49-F238E27FC236}">
+                <a16:creationId xmlns:a16="http://schemas.microsoft.com/office/drawing/2014/main" id="{70ECF8EC-4BEB-A1A2-9D17-9F7F0C5FE3C0}"/>
+              </a:ext>
+            </a:extLst>
+          </p:cNvPr>
+          <p:cNvSpPr txBox="1"/>
+          <p:nvPr/>
+        </p:nvSpPr>
+        <p:spPr>
+          <a:xfrm>
+            <a:off x="5452643" y="3489324"/>
+            <a:ext cx="1054093" cy="369332"/>
+          </a:xfrm>
+          <a:prstGeom prst="rect">
+            <a:avLst/>
+          </a:prstGeom>
+          <a:noFill/>
+        </p:spPr>
+        <p:txBody>
+          <a:bodyPr wrap="square" rtlCol="0">
+            <a:spAutoFit/>
+          </a:bodyPr>
+          <a:lstStyle/>
+          <a:p>
+            <a:pPr algn="ctr"/>
+            <a:r>
+              <a:rPr lang="en-US" sz="900" b="1" i="1">
+                <a:solidFill>
+                  <a:schemeClr val="bg1"/>
+                </a:solidFill>
+              </a:rPr>
+              <a:t>LEGACY IO</a:t>
+            </a:r>
+            <a:r>
+              <a:rPr lang="en-US" sz="900" b="1">
+                <a:solidFill>
+                  <a:schemeClr val="bg1"/>
+                </a:solidFill>
+              </a:rPr>
+              <a:t> Domain</a:t>
+            </a:r>
+            <a:endParaRPr lang="en-US" sz="900">
+              <a:solidFill>
+                <a:schemeClr val="bg1"/>
+              </a:solidFill>
+            </a:endParaRPr>
           </a:p>
         </p:txBody>
       </p:sp>

</xml_diff>

<commit_message>
v 0.1.11 Updated all docs after changes to MDD400_V2.6 schematics.
</commit_message>
<xml_diff>
--- a/.assets/diagrams.pptx
+++ b/.assets/diagrams.pptx
@@ -11,9 +11,9 @@
     <p:sldId id="256" r:id="rId2"/>
     <p:sldId id="263" r:id="rId3"/>
     <p:sldId id="260" r:id="rId4"/>
-    <p:sldId id="257" r:id="rId5"/>
-    <p:sldId id="258" r:id="rId6"/>
-    <p:sldId id="261" r:id="rId7"/>
+    <p:sldId id="261" r:id="rId5"/>
+    <p:sldId id="257" r:id="rId6"/>
+    <p:sldId id="258" r:id="rId7"/>
     <p:sldId id="259" r:id="rId8"/>
     <p:sldId id="262" r:id="rId9"/>
     <p:sldId id="264" r:id="rId10"/>
@@ -205,7 +205,7 @@
           <a:p>
             <a:fld id="{3709B85E-FD1D-4C87-B36A-F5C287A24482}" type="datetimeFigureOut">
               <a:rPr lang="en-US" smtClean="0"/>
-              <a:t>8/4/2025</a:t>
+              <a:t>8/8/2025</a:t>
             </a:fld>
             <a:endParaRPr lang="en-US"/>
           </a:p>
@@ -621,7 +621,7 @@
           <a:p>
             <a:fld id="{9CD017A1-7FA2-4FB5-A9B9-704691091C1D}" type="slidenum">
               <a:rPr lang="en-US" smtClean="0"/>
-              <a:t>6</a:t>
+              <a:t>4</a:t>
             </a:fld>
             <a:endParaRPr lang="en-US"/>
           </a:p>
@@ -955,7 +955,7 @@
           <a:p>
             <a:fld id="{67C30635-7F4C-458C-AB0B-9951B311FD29}" type="datetimeFigureOut">
               <a:rPr lang="en-US" smtClean="0"/>
-              <a:t>8/4/2025</a:t>
+              <a:t>8/8/2025</a:t>
             </a:fld>
             <a:endParaRPr lang="en-US"/>
           </a:p>
@@ -1153,7 +1153,7 @@
           <a:p>
             <a:fld id="{67C30635-7F4C-458C-AB0B-9951B311FD29}" type="datetimeFigureOut">
               <a:rPr lang="en-US" smtClean="0"/>
-              <a:t>8/4/2025</a:t>
+              <a:t>8/8/2025</a:t>
             </a:fld>
             <a:endParaRPr lang="en-US"/>
           </a:p>
@@ -1361,7 +1361,7 @@
           <a:p>
             <a:fld id="{67C30635-7F4C-458C-AB0B-9951B311FD29}" type="datetimeFigureOut">
               <a:rPr lang="en-US" smtClean="0"/>
-              <a:t>8/4/2025</a:t>
+              <a:t>8/8/2025</a:t>
             </a:fld>
             <a:endParaRPr lang="en-US"/>
           </a:p>
@@ -1559,7 +1559,7 @@
           <a:p>
             <a:fld id="{67C30635-7F4C-458C-AB0B-9951B311FD29}" type="datetimeFigureOut">
               <a:rPr lang="en-US" smtClean="0"/>
-              <a:t>8/4/2025</a:t>
+              <a:t>8/8/2025</a:t>
             </a:fld>
             <a:endParaRPr lang="en-US"/>
           </a:p>
@@ -1834,7 +1834,7 @@
           <a:p>
             <a:fld id="{67C30635-7F4C-458C-AB0B-9951B311FD29}" type="datetimeFigureOut">
               <a:rPr lang="en-US" smtClean="0"/>
-              <a:t>8/4/2025</a:t>
+              <a:t>8/8/2025</a:t>
             </a:fld>
             <a:endParaRPr lang="en-US"/>
           </a:p>
@@ -2099,7 +2099,7 @@
           <a:p>
             <a:fld id="{67C30635-7F4C-458C-AB0B-9951B311FD29}" type="datetimeFigureOut">
               <a:rPr lang="en-US" smtClean="0"/>
-              <a:t>8/4/2025</a:t>
+              <a:t>8/8/2025</a:t>
             </a:fld>
             <a:endParaRPr lang="en-US"/>
           </a:p>
@@ -2511,7 +2511,7 @@
           <a:p>
             <a:fld id="{67C30635-7F4C-458C-AB0B-9951B311FD29}" type="datetimeFigureOut">
               <a:rPr lang="en-US" smtClean="0"/>
-              <a:t>8/4/2025</a:t>
+              <a:t>8/8/2025</a:t>
             </a:fld>
             <a:endParaRPr lang="en-US"/>
           </a:p>
@@ -2652,7 +2652,7 @@
           <a:p>
             <a:fld id="{67C30635-7F4C-458C-AB0B-9951B311FD29}" type="datetimeFigureOut">
               <a:rPr lang="en-US" smtClean="0"/>
-              <a:t>8/4/2025</a:t>
+              <a:t>8/8/2025</a:t>
             </a:fld>
             <a:endParaRPr lang="en-US"/>
           </a:p>
@@ -2765,7 +2765,7 @@
           <a:p>
             <a:fld id="{67C30635-7F4C-458C-AB0B-9951B311FD29}" type="datetimeFigureOut">
               <a:rPr lang="en-US" smtClean="0"/>
-              <a:t>8/4/2025</a:t>
+              <a:t>8/8/2025</a:t>
             </a:fld>
             <a:endParaRPr lang="en-US"/>
           </a:p>
@@ -3076,7 +3076,7 @@
           <a:p>
             <a:fld id="{67C30635-7F4C-458C-AB0B-9951B311FD29}" type="datetimeFigureOut">
               <a:rPr lang="en-US" smtClean="0"/>
-              <a:t>8/4/2025</a:t>
+              <a:t>8/8/2025</a:t>
             </a:fld>
             <a:endParaRPr lang="en-US"/>
           </a:p>
@@ -3364,7 +3364,7 @@
           <a:p>
             <a:fld id="{67C30635-7F4C-458C-AB0B-9951B311FD29}" type="datetimeFigureOut">
               <a:rPr lang="en-US" smtClean="0"/>
-              <a:t>8/4/2025</a:t>
+              <a:t>8/8/2025</a:t>
             </a:fld>
             <a:endParaRPr lang="en-US"/>
           </a:p>
@@ -3608,7 +3608,7 @@
           <a:p>
             <a:fld id="{67C30635-7F4C-458C-AB0B-9951B311FD29}" type="datetimeFigureOut">
               <a:rPr lang="en-US" smtClean="0"/>
-              <a:t>8/4/2025</a:t>
+              <a:t>8/8/2025</a:t>
             </a:fld>
             <a:endParaRPr lang="en-US"/>
           </a:p>
@@ -6084,10 +6084,10 @@
       </p:sp>
       <p:pic>
         <p:nvPicPr>
-          <p:cNvPr id="7" name="Picture 6">
-            <a:extLst>
-              <a:ext uri="{FF2B5EF4-FFF2-40B4-BE49-F238E27FC236}">
-                <a16:creationId xmlns:a16="http://schemas.microsoft.com/office/drawing/2014/main" id="{475B0CCB-B588-E010-6D89-4405D1BB1C2A}"/>
+          <p:cNvPr id="5" name="Picture 4">
+            <a:extLst>
+              <a:ext uri="{FF2B5EF4-FFF2-40B4-BE49-F238E27FC236}">
+                <a16:creationId xmlns:a16="http://schemas.microsoft.com/office/drawing/2014/main" id="{7C7D831D-44D3-10E0-15A4-4E9678C7E84C}"/>
               </a:ext>
             </a:extLst>
           </p:cNvPr>
@@ -6104,57 +6104,14 @@
         </p:blipFill>
         <p:spPr>
           <a:xfrm>
-            <a:off x="1706960" y="404664"/>
-            <a:ext cx="4965104" cy="4929611"/>
+            <a:off x="1706960" y="404663"/>
+            <a:ext cx="4933430" cy="4929611"/>
           </a:xfrm>
           <a:prstGeom prst="rect">
             <a:avLst/>
           </a:prstGeom>
         </p:spPr>
       </p:pic>
-      <p:sp>
-        <p:nvSpPr>
-          <p:cNvPr id="2" name="Title 1">
-            <a:extLst>
-              <a:ext uri="{FF2B5EF4-FFF2-40B4-BE49-F238E27FC236}">
-                <a16:creationId xmlns:a16="http://schemas.microsoft.com/office/drawing/2014/main" id="{F701D1CF-C2FF-ABD6-13F6-ACBD672DD0E7}"/>
-              </a:ext>
-            </a:extLst>
-          </p:cNvPr>
-          <p:cNvSpPr>
-            <a:spLocks noGrp="1"/>
-          </p:cNvSpPr>
-          <p:nvPr>
-            <p:ph type="title"/>
-          </p:nvPr>
-        </p:nvSpPr>
-        <p:spPr>
-          <a:xfrm>
-            <a:off x="1343471" y="5239356"/>
-            <a:ext cx="9532957" cy="1325563"/>
-          </a:xfrm>
-        </p:spPr>
-        <p:txBody>
-          <a:bodyPr>
-            <a:normAutofit/>
-          </a:bodyPr>
-          <a:lstStyle/>
-          <a:p>
-            <a:r>
-              <a:rPr lang="en-US" sz="1800" i="1">
-                <a:solidFill>
-                  <a:schemeClr val="tx1">
-                    <a:lumMod val="65000"/>
-                    <a:lumOff val="35000"/>
-                  </a:schemeClr>
-                </a:solidFill>
-                <a:latin typeface="Eras Demi ITC" panose="020B0805030504020804" pitchFamily="34" charset="0"/>
-              </a:rPr>
-              <a:t>MDD400 Isolation Domains</a:t>
-            </a:r>
-          </a:p>
-        </p:txBody>
-      </p:sp>
       <p:sp>
         <p:nvSpPr>
           <p:cNvPr id="15" name="Rectangle 14">
@@ -6169,8 +6126,8 @@
         </p:nvSpPr>
         <p:spPr>
           <a:xfrm>
-            <a:off x="1811524" y="1628800"/>
-            <a:ext cx="1692188" cy="3564396"/>
+            <a:off x="1913899" y="584684"/>
+            <a:ext cx="1692188" cy="2900106"/>
           </a:xfrm>
           <a:prstGeom prst="rect">
             <a:avLst/>
@@ -6235,8 +6192,8 @@
         </p:nvSpPr>
         <p:spPr>
           <a:xfrm>
-            <a:off x="2236847" y="3180166"/>
-            <a:ext cx="1012505" cy="230832"/>
+            <a:off x="2253740" y="1367108"/>
+            <a:ext cx="1012505" cy="369332"/>
           </a:xfrm>
           <a:prstGeom prst="rect">
             <a:avLst/>
@@ -6256,7 +6213,18 @@
                   <a:schemeClr val="bg1"/>
                 </a:solidFill>
               </a:rPr>
-              <a:t>CAN Domain</a:t>
+              <a:t>CAN </a:t>
+            </a:r>
+          </a:p>
+          <a:p>
+            <a:pPr algn="ctr"/>
+            <a:r>
+              <a:rPr lang="en-US" sz="900" b="1">
+                <a:solidFill>
+                  <a:schemeClr val="bg1"/>
+                </a:solidFill>
+              </a:rPr>
+              <a:t>Domain</a:t>
             </a:r>
             <a:endParaRPr lang="en-US" sz="900">
               <a:solidFill>
@@ -6280,8 +6248,8 @@
         </p:nvSpPr>
         <p:spPr>
           <a:xfrm>
-            <a:off x="5447927" y="2708920"/>
-            <a:ext cx="1008113" cy="2412267"/>
+            <a:off x="5447927" y="2564904"/>
+            <a:ext cx="1008113" cy="2556283"/>
           </a:xfrm>
           <a:prstGeom prst="rect">
             <a:avLst/>
@@ -6343,8 +6311,8 @@
         </p:nvSpPr>
         <p:spPr>
           <a:xfrm>
-            <a:off x="3935760" y="584684"/>
-            <a:ext cx="2520280" cy="1656184"/>
+            <a:off x="3813026" y="584684"/>
+            <a:ext cx="2643014" cy="1806404"/>
           </a:xfrm>
           <a:prstGeom prst="rect">
             <a:avLst/>
@@ -6410,7 +6378,7 @@
         <p:spPr>
           <a:xfrm>
             <a:off x="4537197" y="1367108"/>
-            <a:ext cx="1404156" cy="230832"/>
+            <a:ext cx="1404156" cy="369332"/>
           </a:xfrm>
           <a:prstGeom prst="rect">
             <a:avLst/>
@@ -6432,7 +6400,20 @@
                   </a:schemeClr>
                 </a:solidFill>
               </a:rPr>
-              <a:t>DIGITAL Domain</a:t>
+              <a:t>DIGITAL </a:t>
+            </a:r>
+          </a:p>
+          <a:p>
+            <a:pPr algn="ctr"/>
+            <a:r>
+              <a:rPr lang="en-US" sz="900" b="1">
+                <a:solidFill>
+                  <a:schemeClr val="bg2">
+                    <a:lumMod val="25000"/>
+                  </a:schemeClr>
+                </a:solidFill>
+              </a:rPr>
+              <a:t>Domain (3.3V)</a:t>
             </a:r>
             <a:endParaRPr lang="en-US" sz="900">
               <a:solidFill>
@@ -6498,8 +6479,8 @@
         </p:nvSpPr>
         <p:spPr>
           <a:xfrm>
-            <a:off x="1811524" y="548680"/>
-            <a:ext cx="1692188" cy="900100"/>
+            <a:off x="1882617" y="3719013"/>
+            <a:ext cx="1723470" cy="1408939"/>
           </a:xfrm>
           <a:prstGeom prst="rect">
             <a:avLst/>
@@ -6564,8 +6545,8 @@
         </p:nvSpPr>
         <p:spPr>
           <a:xfrm>
-            <a:off x="2169367" y="883314"/>
-            <a:ext cx="1012505" cy="230832"/>
+            <a:off x="2243099" y="4046882"/>
+            <a:ext cx="1012505" cy="369332"/>
           </a:xfrm>
           <a:prstGeom prst="rect">
             <a:avLst/>
@@ -6585,13 +6566,201 @@
                   <a:schemeClr val="bg1"/>
                 </a:solidFill>
               </a:rPr>
-              <a:t>SMPS Domain</a:t>
+              <a:t>SMPS </a:t>
+            </a:r>
+          </a:p>
+          <a:p>
+            <a:pPr algn="ctr"/>
+            <a:r>
+              <a:rPr lang="en-US" sz="900" b="1">
+                <a:solidFill>
+                  <a:schemeClr val="bg1"/>
+                </a:solidFill>
+              </a:rPr>
+              <a:t>Domain</a:t>
             </a:r>
             <a:endParaRPr lang="en-US" sz="900">
               <a:solidFill>
                 <a:schemeClr val="bg1"/>
               </a:solidFill>
             </a:endParaRPr>
+          </a:p>
+        </p:txBody>
+      </p:sp>
+      <p:sp>
+        <p:nvSpPr>
+          <p:cNvPr id="9" name="Rectangle 8">
+            <a:extLst>
+              <a:ext uri="{FF2B5EF4-FFF2-40B4-BE49-F238E27FC236}">
+                <a16:creationId xmlns:a16="http://schemas.microsoft.com/office/drawing/2014/main" id="{95D30BEF-2CB3-A893-2A5D-428D4AA7AE11}"/>
+              </a:ext>
+            </a:extLst>
+          </p:cNvPr>
+          <p:cNvSpPr/>
+          <p:nvPr/>
+        </p:nvSpPr>
+        <p:spPr>
+          <a:xfrm>
+            <a:off x="3813026" y="2564904"/>
+            <a:ext cx="1522559" cy="2592288"/>
+          </a:xfrm>
+          <a:prstGeom prst="rect">
+            <a:avLst/>
+          </a:prstGeom>
+          <a:solidFill>
+            <a:srgbClr val="D1D1D1">
+              <a:alpha val="89804"/>
+            </a:srgbClr>
+          </a:solidFill>
+          <a:ln w="19050">
+            <a:solidFill>
+              <a:schemeClr val="tx1">
+                <a:lumMod val="65000"/>
+                <a:lumOff val="35000"/>
+              </a:schemeClr>
+            </a:solidFill>
+          </a:ln>
+        </p:spPr>
+        <p:style>
+          <a:lnRef idx="2">
+            <a:schemeClr val="accent1">
+              <a:shade val="15000"/>
+            </a:schemeClr>
+          </a:lnRef>
+          <a:fillRef idx="1">
+            <a:schemeClr val="accent1"/>
+          </a:fillRef>
+          <a:effectRef idx="0">
+            <a:schemeClr val="accent1"/>
+          </a:effectRef>
+          <a:fontRef idx="minor">
+            <a:schemeClr val="lt1"/>
+          </a:fontRef>
+        </p:style>
+        <p:txBody>
+          <a:bodyPr rtlCol="0" anchor="ctr"/>
+          <a:lstStyle/>
+          <a:p>
+            <a:pPr algn="ctr"/>
+            <a:endParaRPr lang="en-US">
+              <a:solidFill>
+                <a:schemeClr val="tx1">
+                  <a:lumMod val="75000"/>
+                  <a:lumOff val="25000"/>
+                </a:schemeClr>
+              </a:solidFill>
+            </a:endParaRPr>
+          </a:p>
+        </p:txBody>
+      </p:sp>
+      <p:sp>
+        <p:nvSpPr>
+          <p:cNvPr id="11" name="TextBox 10">
+            <a:extLst>
+              <a:ext uri="{FF2B5EF4-FFF2-40B4-BE49-F238E27FC236}">
+                <a16:creationId xmlns:a16="http://schemas.microsoft.com/office/drawing/2014/main" id="{F5A864FC-4667-3722-4E9C-EDBF97285D7A}"/>
+              </a:ext>
+            </a:extLst>
+          </p:cNvPr>
+          <p:cNvSpPr txBox="1"/>
+          <p:nvPr/>
+        </p:nvSpPr>
+        <p:spPr>
+          <a:xfrm>
+            <a:off x="3872227" y="4004387"/>
+            <a:ext cx="1404156" cy="230832"/>
+          </a:xfrm>
+          <a:prstGeom prst="rect">
+            <a:avLst/>
+          </a:prstGeom>
+          <a:noFill/>
+        </p:spPr>
+        <p:txBody>
+          <a:bodyPr wrap="square" rtlCol="0">
+            <a:spAutoFit/>
+          </a:bodyPr>
+          <a:lstStyle/>
+          <a:p>
+            <a:pPr algn="ctr"/>
+            <a:r>
+              <a:rPr lang="en-US" sz="900" b="1">
+                <a:solidFill>
+                  <a:schemeClr val="bg2">
+                    <a:lumMod val="25000"/>
+                  </a:schemeClr>
+                </a:solidFill>
+              </a:rPr>
+              <a:t>DIGITAL Domain (5V)</a:t>
+            </a:r>
+            <a:endParaRPr lang="en-US" sz="900">
+              <a:solidFill>
+                <a:schemeClr val="bg2">
+                  <a:lumMod val="25000"/>
+                </a:schemeClr>
+              </a:solidFill>
+            </a:endParaRPr>
+          </a:p>
+        </p:txBody>
+      </p:sp>
+      <p:sp>
+        <p:nvSpPr>
+          <p:cNvPr id="14" name="Title 1">
+            <a:extLst>
+              <a:ext uri="{FF2B5EF4-FFF2-40B4-BE49-F238E27FC236}">
+                <a16:creationId xmlns:a16="http://schemas.microsoft.com/office/drawing/2014/main" id="{CC986114-28E7-3825-1BF4-D6F19E671305}"/>
+              </a:ext>
+            </a:extLst>
+          </p:cNvPr>
+          <p:cNvSpPr txBox="1">
+            <a:spLocks/>
+          </p:cNvSpPr>
+          <p:nvPr/>
+        </p:nvSpPr>
+        <p:spPr>
+          <a:xfrm>
+            <a:off x="1307468" y="5648551"/>
+            <a:ext cx="3384376" cy="720080"/>
+          </a:xfrm>
+          <a:prstGeom prst="rect">
+            <a:avLst/>
+          </a:prstGeom>
+        </p:spPr>
+        <p:txBody>
+          <a:bodyPr vert="horz" lIns="91440" tIns="45720" rIns="91440" bIns="45720" rtlCol="0" anchor="ctr">
+            <a:normAutofit/>
+          </a:bodyPr>
+          <a:lstStyle>
+            <a:lvl1pPr algn="l" defTabSz="914400" rtl="0" eaLnBrk="1" latinLnBrk="0" hangingPunct="1">
+              <a:lnSpc>
+                <a:spcPct val="90000"/>
+              </a:lnSpc>
+              <a:spcBef>
+                <a:spcPct val="0"/>
+              </a:spcBef>
+              <a:buNone/>
+              <a:defRPr sz="4400" kern="1200">
+                <a:solidFill>
+                  <a:schemeClr val="tx1"/>
+                </a:solidFill>
+                <a:latin typeface="+mj-lt"/>
+                <a:ea typeface="+mj-ea"/>
+                <a:cs typeface="+mj-cs"/>
+              </a:defRPr>
+            </a:lvl1pPr>
+          </a:lstStyle>
+          <a:p>
+            <a:r>
+              <a:rPr lang="en-US" sz="1600" i="1">
+                <a:solidFill>
+                  <a:schemeClr val="tx1">
+                    <a:lumMod val="65000"/>
+                    <a:lumOff val="35000"/>
+                  </a:schemeClr>
+                </a:solidFill>
+                <a:latin typeface="Eras Demi ITC" panose="020B0805030504020804" pitchFamily="34" charset="0"/>
+              </a:rPr>
+              <a:t>MDD400 Functional Domains</a:t>
+            </a:r>
           </a:p>
         </p:txBody>
       </p:sp>
@@ -6609,6 +6778,894 @@
 </file>
 
 <file path=ppt/slides/slide4.xml><?xml version="1.0" encoding="utf-8"?>
+<p:sld xmlns:a="http://schemas.openxmlformats.org/drawingml/2006/main" xmlns:r="http://schemas.openxmlformats.org/officeDocument/2006/relationships" xmlns:p="http://schemas.openxmlformats.org/presentationml/2006/main">
+  <p:cSld>
+    <p:bg>
+      <p:bgPr>
+        <a:solidFill>
+          <a:srgbClr val="F5F4EF"/>
+        </a:solidFill>
+        <a:effectLst/>
+      </p:bgPr>
+    </p:bg>
+    <p:spTree>
+      <p:nvGrpSpPr>
+        <p:cNvPr id="1" name="">
+          <a:extLst>
+            <a:ext uri="{FF2B5EF4-FFF2-40B4-BE49-F238E27FC236}">
+              <a16:creationId xmlns:a16="http://schemas.microsoft.com/office/drawing/2014/main" id="{04776D50-D360-937A-95AE-07D20605AE6A}"/>
+            </a:ext>
+          </a:extLst>
+        </p:cNvPr>
+        <p:cNvGrpSpPr/>
+        <p:nvPr/>
+      </p:nvGrpSpPr>
+      <p:grpSpPr>
+        <a:xfrm>
+          <a:off x="0" y="0"/>
+          <a:ext cx="0" cy="0"/>
+          <a:chOff x="0" y="0"/>
+          <a:chExt cx="0" cy="0"/>
+        </a:xfrm>
+      </p:grpSpPr>
+      <p:sp>
+        <p:nvSpPr>
+          <p:cNvPr id="4" name="Rectangle 3">
+            <a:extLst>
+              <a:ext uri="{FF2B5EF4-FFF2-40B4-BE49-F238E27FC236}">
+                <a16:creationId xmlns:a16="http://schemas.microsoft.com/office/drawing/2014/main" id="{BC536EF5-13FA-B8AB-D6E8-EB2FAAE79285}"/>
+              </a:ext>
+            </a:extLst>
+          </p:cNvPr>
+          <p:cNvSpPr/>
+          <p:nvPr/>
+        </p:nvSpPr>
+        <p:spPr>
+          <a:xfrm>
+            <a:off x="1235460" y="152636"/>
+            <a:ext cx="5868652" cy="6120680"/>
+          </a:xfrm>
+          <a:prstGeom prst="rect">
+            <a:avLst/>
+          </a:prstGeom>
+          <a:solidFill>
+            <a:srgbClr val="F5F4EF"/>
+          </a:solidFill>
+          <a:ln w="19050">
+            <a:solidFill>
+              <a:srgbClr val="840000"/>
+            </a:solidFill>
+          </a:ln>
+        </p:spPr>
+        <p:style>
+          <a:lnRef idx="2">
+            <a:schemeClr val="accent1">
+              <a:shade val="15000"/>
+            </a:schemeClr>
+          </a:lnRef>
+          <a:fillRef idx="1">
+            <a:schemeClr val="accent1"/>
+          </a:fillRef>
+          <a:effectRef idx="0">
+            <a:schemeClr val="accent1"/>
+          </a:effectRef>
+          <a:fontRef idx="minor">
+            <a:schemeClr val="lt1"/>
+          </a:fontRef>
+        </p:style>
+        <p:txBody>
+          <a:bodyPr rtlCol="0" anchor="ctr"/>
+          <a:lstStyle/>
+          <a:p>
+            <a:pPr algn="ctr"/>
+            <a:endParaRPr lang="en-US">
+              <a:solidFill>
+                <a:schemeClr val="tx1">
+                  <a:lumMod val="75000"/>
+                  <a:lumOff val="25000"/>
+                </a:schemeClr>
+              </a:solidFill>
+            </a:endParaRPr>
+          </a:p>
+        </p:txBody>
+      </p:sp>
+      <p:pic>
+        <p:nvPicPr>
+          <p:cNvPr id="5" name="Picture 4">
+            <a:extLst>
+              <a:ext uri="{FF2B5EF4-FFF2-40B4-BE49-F238E27FC236}">
+                <a16:creationId xmlns:a16="http://schemas.microsoft.com/office/drawing/2014/main" id="{17115EDD-107D-7E91-12FA-12E6EC8DC2C6}"/>
+              </a:ext>
+            </a:extLst>
+          </p:cNvPr>
+          <p:cNvPicPr>
+            <a:picLocks noChangeAspect="1"/>
+          </p:cNvPicPr>
+          <p:nvPr/>
+        </p:nvPicPr>
+        <p:blipFill>
+          <a:blip r:embed="rId3"/>
+          <a:stretch>
+            <a:fillRect/>
+          </a:stretch>
+        </p:blipFill>
+        <p:spPr>
+          <a:xfrm>
+            <a:off x="1685793" y="416067"/>
+            <a:ext cx="4942717" cy="4946537"/>
+          </a:xfrm>
+          <a:prstGeom prst="rect">
+            <a:avLst/>
+          </a:prstGeom>
+        </p:spPr>
+      </p:pic>
+      <p:sp>
+        <p:nvSpPr>
+          <p:cNvPr id="2" name="Title 1">
+            <a:extLst>
+              <a:ext uri="{FF2B5EF4-FFF2-40B4-BE49-F238E27FC236}">
+                <a16:creationId xmlns:a16="http://schemas.microsoft.com/office/drawing/2014/main" id="{E7217E81-ED03-849E-C61D-F5A86E7B15BA}"/>
+              </a:ext>
+            </a:extLst>
+          </p:cNvPr>
+          <p:cNvSpPr>
+            <a:spLocks noGrp="1"/>
+          </p:cNvSpPr>
+          <p:nvPr>
+            <p:ph type="title"/>
+          </p:nvPr>
+        </p:nvSpPr>
+        <p:spPr>
+          <a:xfrm>
+            <a:off x="1307468" y="5648551"/>
+            <a:ext cx="3384376" cy="720080"/>
+          </a:xfrm>
+        </p:spPr>
+        <p:txBody>
+          <a:bodyPr vert="horz" lIns="91440" tIns="45720" rIns="91440" bIns="45720" rtlCol="0" anchor="ctr">
+            <a:normAutofit/>
+          </a:bodyPr>
+          <a:lstStyle/>
+          <a:p>
+            <a:r>
+              <a:rPr lang="en-US" sz="1600" i="1">
+                <a:solidFill>
+                  <a:schemeClr val="tx1">
+                    <a:lumMod val="65000"/>
+                    <a:lumOff val="35000"/>
+                  </a:schemeClr>
+                </a:solidFill>
+                <a:latin typeface="Eras Demi ITC" panose="020B0805030504020804" pitchFamily="34" charset="0"/>
+              </a:rPr>
+              <a:t>MDD400 Isolation Domains</a:t>
+            </a:r>
+          </a:p>
+        </p:txBody>
+      </p:sp>
+      <p:sp>
+        <p:nvSpPr>
+          <p:cNvPr id="26" name="TextBox 25">
+            <a:extLst>
+              <a:ext uri="{FF2B5EF4-FFF2-40B4-BE49-F238E27FC236}">
+                <a16:creationId xmlns:a16="http://schemas.microsoft.com/office/drawing/2014/main" id="{750EA29D-C1F2-C859-0EAF-A0A57E36C3C1}"/>
+              </a:ext>
+            </a:extLst>
+          </p:cNvPr>
+          <p:cNvSpPr txBox="1"/>
+          <p:nvPr/>
+        </p:nvSpPr>
+        <p:spPr>
+          <a:xfrm rot="16200000">
+            <a:off x="3386777" y="3889193"/>
+            <a:ext cx="593432" cy="230832"/>
+          </a:xfrm>
+          <a:prstGeom prst="rect">
+            <a:avLst/>
+          </a:prstGeom>
+          <a:noFill/>
+        </p:spPr>
+        <p:txBody>
+          <a:bodyPr wrap="none" rtlCol="0">
+            <a:spAutoFit/>
+          </a:bodyPr>
+          <a:lstStyle/>
+          <a:p>
+            <a:pPr algn="ctr"/>
+            <a:r>
+              <a:rPr lang="en-US" sz="900" b="1">
+                <a:solidFill>
+                  <a:srgbClr val="FFFF00"/>
+                </a:solidFill>
+              </a:rPr>
+              <a:t>Ferrites</a:t>
+            </a:r>
+          </a:p>
+        </p:txBody>
+      </p:sp>
+      <p:sp>
+        <p:nvSpPr>
+          <p:cNvPr id="27" name="TextBox 26">
+            <a:extLst>
+              <a:ext uri="{FF2B5EF4-FFF2-40B4-BE49-F238E27FC236}">
+                <a16:creationId xmlns:a16="http://schemas.microsoft.com/office/drawing/2014/main" id="{C7775AF3-E1FC-B231-255F-995DFE9BED29}"/>
+              </a:ext>
+            </a:extLst>
+          </p:cNvPr>
+          <p:cNvSpPr txBox="1"/>
+          <p:nvPr/>
+        </p:nvSpPr>
+        <p:spPr>
+          <a:xfrm>
+            <a:off x="5518971" y="2393008"/>
+            <a:ext cx="947696" cy="230832"/>
+          </a:xfrm>
+          <a:prstGeom prst="rect">
+            <a:avLst/>
+          </a:prstGeom>
+          <a:noFill/>
+        </p:spPr>
+        <p:txBody>
+          <a:bodyPr wrap="none" rtlCol="0">
+            <a:spAutoFit/>
+          </a:bodyPr>
+          <a:lstStyle/>
+          <a:p>
+            <a:pPr algn="ctr"/>
+            <a:r>
+              <a:rPr lang="en-US" sz="900" b="1">
+                <a:solidFill>
+                  <a:srgbClr val="FFFF00"/>
+                </a:solidFill>
+              </a:rPr>
+              <a:t>Opto-isolators</a:t>
+            </a:r>
+          </a:p>
+        </p:txBody>
+      </p:sp>
+      <p:sp>
+        <p:nvSpPr>
+          <p:cNvPr id="9" name="TextBox 8">
+            <a:extLst>
+              <a:ext uri="{FF2B5EF4-FFF2-40B4-BE49-F238E27FC236}">
+                <a16:creationId xmlns:a16="http://schemas.microsoft.com/office/drawing/2014/main" id="{227ED8AB-371F-F6EF-D4B5-197FA235DD09}"/>
+              </a:ext>
+            </a:extLst>
+          </p:cNvPr>
+          <p:cNvSpPr txBox="1"/>
+          <p:nvPr/>
+        </p:nvSpPr>
+        <p:spPr>
+          <a:xfrm>
+            <a:off x="2303179" y="3505632"/>
+            <a:ext cx="1050288" cy="230832"/>
+          </a:xfrm>
+          <a:prstGeom prst="rect">
+            <a:avLst/>
+          </a:prstGeom>
+          <a:noFill/>
+        </p:spPr>
+        <p:txBody>
+          <a:bodyPr wrap="none" rtlCol="0">
+            <a:spAutoFit/>
+          </a:bodyPr>
+          <a:lstStyle/>
+          <a:p>
+            <a:pPr algn="ctr"/>
+            <a:r>
+              <a:rPr lang="en-US" sz="900" b="1">
+                <a:solidFill>
+                  <a:srgbClr val="FFFF00"/>
+                </a:solidFill>
+              </a:rPr>
+              <a:t>12V Transformer</a:t>
+            </a:r>
+          </a:p>
+        </p:txBody>
+      </p:sp>
+      <p:sp>
+        <p:nvSpPr>
+          <p:cNvPr id="6" name="Rectangle 5">
+            <a:extLst>
+              <a:ext uri="{FF2B5EF4-FFF2-40B4-BE49-F238E27FC236}">
+                <a16:creationId xmlns:a16="http://schemas.microsoft.com/office/drawing/2014/main" id="{5205AB9E-C476-A133-7293-476DB2C71112}"/>
+              </a:ext>
+            </a:extLst>
+          </p:cNvPr>
+          <p:cNvSpPr/>
+          <p:nvPr/>
+        </p:nvSpPr>
+        <p:spPr>
+          <a:xfrm>
+            <a:off x="1875888" y="605526"/>
+            <a:ext cx="1692188" cy="2900106"/>
+          </a:xfrm>
+          <a:prstGeom prst="rect">
+            <a:avLst/>
+          </a:prstGeom>
+          <a:solidFill>
+            <a:srgbClr val="A20000">
+              <a:alpha val="89804"/>
+            </a:srgbClr>
+          </a:solidFill>
+          <a:ln w="19050">
+            <a:solidFill>
+              <a:schemeClr val="tx2">
+                <a:lumMod val="90000"/>
+                <a:lumOff val="10000"/>
+              </a:schemeClr>
+            </a:solidFill>
+          </a:ln>
+        </p:spPr>
+        <p:style>
+          <a:lnRef idx="2">
+            <a:schemeClr val="accent1">
+              <a:shade val="15000"/>
+            </a:schemeClr>
+          </a:lnRef>
+          <a:fillRef idx="1">
+            <a:schemeClr val="accent1"/>
+          </a:fillRef>
+          <a:effectRef idx="0">
+            <a:schemeClr val="accent1"/>
+          </a:effectRef>
+          <a:fontRef idx="minor">
+            <a:schemeClr val="lt1"/>
+          </a:fontRef>
+        </p:style>
+        <p:txBody>
+          <a:bodyPr rtlCol="0" anchor="ctr"/>
+          <a:lstStyle/>
+          <a:p>
+            <a:pPr algn="ctr"/>
+            <a:endParaRPr lang="en-US">
+              <a:solidFill>
+                <a:schemeClr val="tx1">
+                  <a:lumMod val="75000"/>
+                  <a:lumOff val="25000"/>
+                </a:schemeClr>
+              </a:solidFill>
+            </a:endParaRPr>
+          </a:p>
+        </p:txBody>
+      </p:sp>
+      <p:sp>
+        <p:nvSpPr>
+          <p:cNvPr id="7" name="TextBox 6">
+            <a:extLst>
+              <a:ext uri="{FF2B5EF4-FFF2-40B4-BE49-F238E27FC236}">
+                <a16:creationId xmlns:a16="http://schemas.microsoft.com/office/drawing/2014/main" id="{7C4B6DF9-2BE4-53BD-781B-26AFBE0E3653}"/>
+              </a:ext>
+            </a:extLst>
+          </p:cNvPr>
+          <p:cNvSpPr txBox="1"/>
+          <p:nvPr/>
+        </p:nvSpPr>
+        <p:spPr>
+          <a:xfrm>
+            <a:off x="2215729" y="1387950"/>
+            <a:ext cx="1012505" cy="369332"/>
+          </a:xfrm>
+          <a:prstGeom prst="rect">
+            <a:avLst/>
+          </a:prstGeom>
+          <a:noFill/>
+        </p:spPr>
+        <p:txBody>
+          <a:bodyPr wrap="square" rtlCol="0">
+            <a:spAutoFit/>
+          </a:bodyPr>
+          <a:lstStyle/>
+          <a:p>
+            <a:pPr algn="ctr"/>
+            <a:r>
+              <a:rPr lang="en-US" sz="900" b="1">
+                <a:solidFill>
+                  <a:schemeClr val="bg1"/>
+                </a:solidFill>
+              </a:rPr>
+              <a:t>CAN </a:t>
+            </a:r>
+          </a:p>
+          <a:p>
+            <a:pPr algn="ctr"/>
+            <a:r>
+              <a:rPr lang="en-US" sz="900" b="1">
+                <a:solidFill>
+                  <a:schemeClr val="bg1"/>
+                </a:solidFill>
+              </a:rPr>
+              <a:t>Domain</a:t>
+            </a:r>
+            <a:endParaRPr lang="en-US" sz="900">
+              <a:solidFill>
+                <a:schemeClr val="bg1"/>
+              </a:solidFill>
+            </a:endParaRPr>
+          </a:p>
+        </p:txBody>
+      </p:sp>
+      <p:sp>
+        <p:nvSpPr>
+          <p:cNvPr id="11" name="Rectangle 10">
+            <a:extLst>
+              <a:ext uri="{FF2B5EF4-FFF2-40B4-BE49-F238E27FC236}">
+                <a16:creationId xmlns:a16="http://schemas.microsoft.com/office/drawing/2014/main" id="{1B420956-3FE7-4231-4EA4-2E40E90F5257}"/>
+              </a:ext>
+            </a:extLst>
+          </p:cNvPr>
+          <p:cNvSpPr/>
+          <p:nvPr/>
+        </p:nvSpPr>
+        <p:spPr>
+          <a:xfrm>
+            <a:off x="5450359" y="2585746"/>
+            <a:ext cx="967670" cy="2556283"/>
+          </a:xfrm>
+          <a:prstGeom prst="rect">
+            <a:avLst/>
+          </a:prstGeom>
+          <a:solidFill>
+            <a:srgbClr val="11838F">
+              <a:alpha val="89804"/>
+            </a:srgbClr>
+          </a:solidFill>
+          <a:ln w="19050">
+            <a:solidFill>
+              <a:srgbClr val="11838F"/>
+            </a:solidFill>
+          </a:ln>
+        </p:spPr>
+        <p:style>
+          <a:lnRef idx="2">
+            <a:schemeClr val="accent1">
+              <a:shade val="15000"/>
+            </a:schemeClr>
+          </a:lnRef>
+          <a:fillRef idx="1">
+            <a:schemeClr val="accent1"/>
+          </a:fillRef>
+          <a:effectRef idx="0">
+            <a:schemeClr val="accent1"/>
+          </a:effectRef>
+          <a:fontRef idx="minor">
+            <a:schemeClr val="lt1"/>
+          </a:fontRef>
+        </p:style>
+        <p:txBody>
+          <a:bodyPr rtlCol="0" anchor="ctr"/>
+          <a:lstStyle/>
+          <a:p>
+            <a:pPr algn="ctr"/>
+            <a:endParaRPr lang="en-US">
+              <a:solidFill>
+                <a:schemeClr val="tx1">
+                  <a:lumMod val="75000"/>
+                  <a:lumOff val="25000"/>
+                </a:schemeClr>
+              </a:solidFill>
+            </a:endParaRPr>
+          </a:p>
+        </p:txBody>
+      </p:sp>
+      <p:sp>
+        <p:nvSpPr>
+          <p:cNvPr id="13" name="Rectangle 12">
+            <a:extLst>
+              <a:ext uri="{FF2B5EF4-FFF2-40B4-BE49-F238E27FC236}">
+                <a16:creationId xmlns:a16="http://schemas.microsoft.com/office/drawing/2014/main" id="{A40B05FF-65D8-408C-616A-DE817C183157}"/>
+              </a:ext>
+            </a:extLst>
+          </p:cNvPr>
+          <p:cNvSpPr/>
+          <p:nvPr/>
+        </p:nvSpPr>
+        <p:spPr>
+          <a:xfrm>
+            <a:off x="3775015" y="605526"/>
+            <a:ext cx="2643014" cy="1806404"/>
+          </a:xfrm>
+          <a:prstGeom prst="rect">
+            <a:avLst/>
+          </a:prstGeom>
+          <a:solidFill>
+            <a:srgbClr val="D1D1D1">
+              <a:alpha val="89804"/>
+            </a:srgbClr>
+          </a:solidFill>
+          <a:ln w="19050">
+            <a:solidFill>
+              <a:schemeClr val="tx1">
+                <a:lumMod val="65000"/>
+                <a:lumOff val="35000"/>
+              </a:schemeClr>
+            </a:solidFill>
+          </a:ln>
+        </p:spPr>
+        <p:style>
+          <a:lnRef idx="2">
+            <a:schemeClr val="accent1">
+              <a:shade val="15000"/>
+            </a:schemeClr>
+          </a:lnRef>
+          <a:fillRef idx="1">
+            <a:schemeClr val="accent1"/>
+          </a:fillRef>
+          <a:effectRef idx="0">
+            <a:schemeClr val="accent1"/>
+          </a:effectRef>
+          <a:fontRef idx="minor">
+            <a:schemeClr val="lt1"/>
+          </a:fontRef>
+        </p:style>
+        <p:txBody>
+          <a:bodyPr rtlCol="0" anchor="ctr"/>
+          <a:lstStyle/>
+          <a:p>
+            <a:pPr algn="ctr"/>
+            <a:endParaRPr lang="en-US">
+              <a:solidFill>
+                <a:schemeClr val="tx1">
+                  <a:lumMod val="75000"/>
+                  <a:lumOff val="25000"/>
+                </a:schemeClr>
+              </a:solidFill>
+            </a:endParaRPr>
+          </a:p>
+        </p:txBody>
+      </p:sp>
+      <p:sp>
+        <p:nvSpPr>
+          <p:cNvPr id="16" name="TextBox 15">
+            <a:extLst>
+              <a:ext uri="{FF2B5EF4-FFF2-40B4-BE49-F238E27FC236}">
+                <a16:creationId xmlns:a16="http://schemas.microsoft.com/office/drawing/2014/main" id="{A126704B-50D8-2E04-D3E7-628E57A5AF66}"/>
+              </a:ext>
+            </a:extLst>
+          </p:cNvPr>
+          <p:cNvSpPr txBox="1"/>
+          <p:nvPr/>
+        </p:nvSpPr>
+        <p:spPr>
+          <a:xfrm>
+            <a:off x="4499186" y="1387950"/>
+            <a:ext cx="1404156" cy="369332"/>
+          </a:xfrm>
+          <a:prstGeom prst="rect">
+            <a:avLst/>
+          </a:prstGeom>
+          <a:noFill/>
+        </p:spPr>
+        <p:txBody>
+          <a:bodyPr wrap="square" rtlCol="0">
+            <a:spAutoFit/>
+          </a:bodyPr>
+          <a:lstStyle/>
+          <a:p>
+            <a:pPr algn="ctr"/>
+            <a:r>
+              <a:rPr lang="en-US" sz="900" b="1">
+                <a:solidFill>
+                  <a:schemeClr val="bg2">
+                    <a:lumMod val="25000"/>
+                  </a:schemeClr>
+                </a:solidFill>
+              </a:rPr>
+              <a:t>DIGITAL </a:t>
+            </a:r>
+          </a:p>
+          <a:p>
+            <a:pPr algn="ctr"/>
+            <a:r>
+              <a:rPr lang="en-US" sz="900" b="1">
+                <a:solidFill>
+                  <a:schemeClr val="bg2">
+                    <a:lumMod val="25000"/>
+                  </a:schemeClr>
+                </a:solidFill>
+              </a:rPr>
+              <a:t>Domain (3.3V)</a:t>
+            </a:r>
+            <a:endParaRPr lang="en-US" sz="900">
+              <a:solidFill>
+                <a:schemeClr val="bg2">
+                  <a:lumMod val="25000"/>
+                </a:schemeClr>
+              </a:solidFill>
+            </a:endParaRPr>
+          </a:p>
+        </p:txBody>
+      </p:sp>
+      <p:sp>
+        <p:nvSpPr>
+          <p:cNvPr id="17" name="TextBox 16">
+            <a:extLst>
+              <a:ext uri="{FF2B5EF4-FFF2-40B4-BE49-F238E27FC236}">
+                <a16:creationId xmlns:a16="http://schemas.microsoft.com/office/drawing/2014/main" id="{96B172C0-BFD5-449F-258D-A526376E6031}"/>
+              </a:ext>
+            </a:extLst>
+          </p:cNvPr>
+          <p:cNvSpPr txBox="1"/>
+          <p:nvPr/>
+        </p:nvSpPr>
+        <p:spPr>
+          <a:xfrm>
+            <a:off x="5409916" y="3350972"/>
+            <a:ext cx="1080121" cy="369332"/>
+          </a:xfrm>
+          <a:prstGeom prst="rect">
+            <a:avLst/>
+          </a:prstGeom>
+          <a:noFill/>
+        </p:spPr>
+        <p:txBody>
+          <a:bodyPr wrap="square" rtlCol="0">
+            <a:spAutoFit/>
+          </a:bodyPr>
+          <a:lstStyle/>
+          <a:p>
+            <a:pPr algn="ctr"/>
+            <a:r>
+              <a:rPr lang="en-US" sz="900" b="1">
+                <a:solidFill>
+                  <a:schemeClr val="bg1"/>
+                </a:solidFill>
+              </a:rPr>
+              <a:t>LEGACY IO Domain</a:t>
+            </a:r>
+          </a:p>
+        </p:txBody>
+      </p:sp>
+      <p:sp>
+        <p:nvSpPr>
+          <p:cNvPr id="18" name="Rectangle 17">
+            <a:extLst>
+              <a:ext uri="{FF2B5EF4-FFF2-40B4-BE49-F238E27FC236}">
+                <a16:creationId xmlns:a16="http://schemas.microsoft.com/office/drawing/2014/main" id="{5BD293A1-E0C5-5A1E-2CB8-02BC031B8D85}"/>
+              </a:ext>
+            </a:extLst>
+          </p:cNvPr>
+          <p:cNvSpPr/>
+          <p:nvPr/>
+        </p:nvSpPr>
+        <p:spPr>
+          <a:xfrm>
+            <a:off x="1875888" y="3739855"/>
+            <a:ext cx="1692188" cy="1408939"/>
+          </a:xfrm>
+          <a:prstGeom prst="rect">
+            <a:avLst/>
+          </a:prstGeom>
+          <a:solidFill>
+            <a:srgbClr val="215F9A">
+              <a:alpha val="89804"/>
+            </a:srgbClr>
+          </a:solidFill>
+          <a:ln w="19050">
+            <a:solidFill>
+              <a:schemeClr val="tx2">
+                <a:lumMod val="90000"/>
+                <a:lumOff val="10000"/>
+              </a:schemeClr>
+            </a:solidFill>
+          </a:ln>
+        </p:spPr>
+        <p:style>
+          <a:lnRef idx="2">
+            <a:schemeClr val="accent1">
+              <a:shade val="15000"/>
+            </a:schemeClr>
+          </a:lnRef>
+          <a:fillRef idx="1">
+            <a:schemeClr val="accent1"/>
+          </a:fillRef>
+          <a:effectRef idx="0">
+            <a:schemeClr val="accent1"/>
+          </a:effectRef>
+          <a:fontRef idx="minor">
+            <a:schemeClr val="lt1"/>
+          </a:fontRef>
+        </p:style>
+        <p:txBody>
+          <a:bodyPr rtlCol="0" anchor="ctr"/>
+          <a:lstStyle/>
+          <a:p>
+            <a:pPr algn="ctr"/>
+            <a:endParaRPr lang="en-US">
+              <a:solidFill>
+                <a:schemeClr val="tx1">
+                  <a:lumMod val="75000"/>
+                  <a:lumOff val="25000"/>
+                </a:schemeClr>
+              </a:solidFill>
+            </a:endParaRPr>
+          </a:p>
+        </p:txBody>
+      </p:sp>
+      <p:sp>
+        <p:nvSpPr>
+          <p:cNvPr id="19" name="TextBox 18">
+            <a:extLst>
+              <a:ext uri="{FF2B5EF4-FFF2-40B4-BE49-F238E27FC236}">
+                <a16:creationId xmlns:a16="http://schemas.microsoft.com/office/drawing/2014/main" id="{21B5DED5-DC3D-20FC-FC12-12DF18B7C969}"/>
+              </a:ext>
+            </a:extLst>
+          </p:cNvPr>
+          <p:cNvSpPr txBox="1"/>
+          <p:nvPr/>
+        </p:nvSpPr>
+        <p:spPr>
+          <a:xfrm>
+            <a:off x="2205088" y="4067724"/>
+            <a:ext cx="1012505" cy="369332"/>
+          </a:xfrm>
+          <a:prstGeom prst="rect">
+            <a:avLst/>
+          </a:prstGeom>
+          <a:noFill/>
+        </p:spPr>
+        <p:txBody>
+          <a:bodyPr wrap="square" rtlCol="0">
+            <a:spAutoFit/>
+          </a:bodyPr>
+          <a:lstStyle/>
+          <a:p>
+            <a:pPr algn="ctr"/>
+            <a:r>
+              <a:rPr lang="en-US" sz="900" b="1">
+                <a:solidFill>
+                  <a:schemeClr val="bg1"/>
+                </a:solidFill>
+              </a:rPr>
+              <a:t>SMPS </a:t>
+            </a:r>
+          </a:p>
+          <a:p>
+            <a:pPr algn="ctr"/>
+            <a:r>
+              <a:rPr lang="en-US" sz="900" b="1">
+                <a:solidFill>
+                  <a:schemeClr val="bg1"/>
+                </a:solidFill>
+              </a:rPr>
+              <a:t>Domain</a:t>
+            </a:r>
+            <a:endParaRPr lang="en-US" sz="900">
+              <a:solidFill>
+                <a:schemeClr val="bg1"/>
+              </a:solidFill>
+            </a:endParaRPr>
+          </a:p>
+        </p:txBody>
+      </p:sp>
+      <p:sp>
+        <p:nvSpPr>
+          <p:cNvPr id="20" name="Rectangle 19">
+            <a:extLst>
+              <a:ext uri="{FF2B5EF4-FFF2-40B4-BE49-F238E27FC236}">
+                <a16:creationId xmlns:a16="http://schemas.microsoft.com/office/drawing/2014/main" id="{1F31B150-9D32-769E-864A-DD9F9223A370}"/>
+              </a:ext>
+            </a:extLst>
+          </p:cNvPr>
+          <p:cNvSpPr/>
+          <p:nvPr/>
+        </p:nvSpPr>
+        <p:spPr>
+          <a:xfrm>
+            <a:off x="3775015" y="2585746"/>
+            <a:ext cx="1522559" cy="2592288"/>
+          </a:xfrm>
+          <a:prstGeom prst="rect">
+            <a:avLst/>
+          </a:prstGeom>
+          <a:solidFill>
+            <a:srgbClr val="D1D1D1">
+              <a:alpha val="89804"/>
+            </a:srgbClr>
+          </a:solidFill>
+          <a:ln w="19050">
+            <a:solidFill>
+              <a:schemeClr val="tx1">
+                <a:lumMod val="65000"/>
+                <a:lumOff val="35000"/>
+              </a:schemeClr>
+            </a:solidFill>
+          </a:ln>
+        </p:spPr>
+        <p:style>
+          <a:lnRef idx="2">
+            <a:schemeClr val="accent1">
+              <a:shade val="15000"/>
+            </a:schemeClr>
+          </a:lnRef>
+          <a:fillRef idx="1">
+            <a:schemeClr val="accent1"/>
+          </a:fillRef>
+          <a:effectRef idx="0">
+            <a:schemeClr val="accent1"/>
+          </a:effectRef>
+          <a:fontRef idx="minor">
+            <a:schemeClr val="lt1"/>
+          </a:fontRef>
+        </p:style>
+        <p:txBody>
+          <a:bodyPr rtlCol="0" anchor="ctr"/>
+          <a:lstStyle/>
+          <a:p>
+            <a:pPr algn="ctr"/>
+            <a:endParaRPr lang="en-US">
+              <a:solidFill>
+                <a:schemeClr val="tx1">
+                  <a:lumMod val="75000"/>
+                  <a:lumOff val="25000"/>
+                </a:schemeClr>
+              </a:solidFill>
+            </a:endParaRPr>
+          </a:p>
+        </p:txBody>
+      </p:sp>
+      <p:sp>
+        <p:nvSpPr>
+          <p:cNvPr id="23" name="TextBox 22">
+            <a:extLst>
+              <a:ext uri="{FF2B5EF4-FFF2-40B4-BE49-F238E27FC236}">
+                <a16:creationId xmlns:a16="http://schemas.microsoft.com/office/drawing/2014/main" id="{5044AADD-F29E-0C00-D583-075A232AF655}"/>
+              </a:ext>
+            </a:extLst>
+          </p:cNvPr>
+          <p:cNvSpPr txBox="1"/>
+          <p:nvPr/>
+        </p:nvSpPr>
+        <p:spPr>
+          <a:xfrm>
+            <a:off x="3834216" y="4025229"/>
+            <a:ext cx="1404156" cy="230832"/>
+          </a:xfrm>
+          <a:prstGeom prst="rect">
+            <a:avLst/>
+          </a:prstGeom>
+          <a:noFill/>
+        </p:spPr>
+        <p:txBody>
+          <a:bodyPr wrap="square" rtlCol="0">
+            <a:spAutoFit/>
+          </a:bodyPr>
+          <a:lstStyle/>
+          <a:p>
+            <a:pPr algn="ctr"/>
+            <a:r>
+              <a:rPr lang="en-US" sz="900" b="1">
+                <a:solidFill>
+                  <a:schemeClr val="bg2">
+                    <a:lumMod val="25000"/>
+                  </a:schemeClr>
+                </a:solidFill>
+              </a:rPr>
+              <a:t>DIGITAL Domain (5V)</a:t>
+            </a:r>
+            <a:endParaRPr lang="en-US" sz="900">
+              <a:solidFill>
+                <a:schemeClr val="bg2">
+                  <a:lumMod val="25000"/>
+                </a:schemeClr>
+              </a:solidFill>
+            </a:endParaRPr>
+          </a:p>
+        </p:txBody>
+      </p:sp>
+    </p:spTree>
+    <p:extLst>
+      <p:ext uri="{BB962C8B-B14F-4D97-AF65-F5344CB8AC3E}">
+        <p14:creationId xmlns:p14="http://schemas.microsoft.com/office/powerpoint/2010/main" val="1425979937"/>
+      </p:ext>
+    </p:extLst>
+  </p:cSld>
+  <p:clrMapOvr>
+    <a:masterClrMapping/>
+  </p:clrMapOvr>
+</p:sld>
+</file>
+
+<file path=ppt/slides/slide5.xml><?xml version="1.0" encoding="utf-8"?>
 <p:sld xmlns:a="http://schemas.openxmlformats.org/drawingml/2006/main" xmlns:r="http://schemas.openxmlformats.org/officeDocument/2006/relationships" xmlns:p="http://schemas.openxmlformats.org/presentationml/2006/main">
   <p:cSld>
     <p:spTree>
@@ -7777,7 +8834,7 @@
 </p:sld>
 </file>
 
-<file path=ppt/slides/slide5.xml><?xml version="1.0" encoding="utf-8"?>
+<file path=ppt/slides/slide6.xml><?xml version="1.0" encoding="utf-8"?>
 <p:sld xmlns:a="http://schemas.openxmlformats.org/drawingml/2006/main" xmlns:r="http://schemas.openxmlformats.org/officeDocument/2006/relationships" xmlns:p="http://schemas.openxmlformats.org/presentationml/2006/main">
   <p:cSld>
     <p:bg>
@@ -9084,779 +10141,6 @@
     <p:extLst>
       <p:ext uri="{BB962C8B-B14F-4D97-AF65-F5344CB8AC3E}">
         <p14:creationId xmlns:p14="http://schemas.microsoft.com/office/powerpoint/2010/main" val="4028541045"/>
-      </p:ext>
-    </p:extLst>
-  </p:cSld>
-  <p:clrMapOvr>
-    <a:masterClrMapping/>
-  </p:clrMapOvr>
-</p:sld>
-</file>
-
-<file path=ppt/slides/slide6.xml><?xml version="1.0" encoding="utf-8"?>
-<p:sld xmlns:a="http://schemas.openxmlformats.org/drawingml/2006/main" xmlns:r="http://schemas.openxmlformats.org/officeDocument/2006/relationships" xmlns:p="http://schemas.openxmlformats.org/presentationml/2006/main">
-  <p:cSld>
-    <p:bg>
-      <p:bgPr>
-        <a:solidFill>
-          <a:srgbClr val="F5F4EF"/>
-        </a:solidFill>
-        <a:effectLst/>
-      </p:bgPr>
-    </p:bg>
-    <p:spTree>
-      <p:nvGrpSpPr>
-        <p:cNvPr id="1" name="">
-          <a:extLst>
-            <a:ext uri="{FF2B5EF4-FFF2-40B4-BE49-F238E27FC236}">
-              <a16:creationId xmlns:a16="http://schemas.microsoft.com/office/drawing/2014/main" id="{04776D50-D360-937A-95AE-07D20605AE6A}"/>
-            </a:ext>
-          </a:extLst>
-        </p:cNvPr>
-        <p:cNvGrpSpPr/>
-        <p:nvPr/>
-      </p:nvGrpSpPr>
-      <p:grpSpPr>
-        <a:xfrm>
-          <a:off x="0" y="0"/>
-          <a:ext cx="0" cy="0"/>
-          <a:chOff x="0" y="0"/>
-          <a:chExt cx="0" cy="0"/>
-        </a:xfrm>
-      </p:grpSpPr>
-      <p:sp>
-        <p:nvSpPr>
-          <p:cNvPr id="4" name="Rectangle 3">
-            <a:extLst>
-              <a:ext uri="{FF2B5EF4-FFF2-40B4-BE49-F238E27FC236}">
-                <a16:creationId xmlns:a16="http://schemas.microsoft.com/office/drawing/2014/main" id="{BC536EF5-13FA-B8AB-D6E8-EB2FAAE79285}"/>
-              </a:ext>
-            </a:extLst>
-          </p:cNvPr>
-          <p:cNvSpPr/>
-          <p:nvPr/>
-        </p:nvSpPr>
-        <p:spPr>
-          <a:xfrm>
-            <a:off x="1235460" y="152636"/>
-            <a:ext cx="5868652" cy="6120680"/>
-          </a:xfrm>
-          <a:prstGeom prst="rect">
-            <a:avLst/>
-          </a:prstGeom>
-          <a:solidFill>
-            <a:srgbClr val="F5F4EF"/>
-          </a:solidFill>
-          <a:ln w="19050">
-            <a:solidFill>
-              <a:srgbClr val="840000"/>
-            </a:solidFill>
-          </a:ln>
-        </p:spPr>
-        <p:style>
-          <a:lnRef idx="2">
-            <a:schemeClr val="accent1">
-              <a:shade val="15000"/>
-            </a:schemeClr>
-          </a:lnRef>
-          <a:fillRef idx="1">
-            <a:schemeClr val="accent1"/>
-          </a:fillRef>
-          <a:effectRef idx="0">
-            <a:schemeClr val="accent1"/>
-          </a:effectRef>
-          <a:fontRef idx="minor">
-            <a:schemeClr val="lt1"/>
-          </a:fontRef>
-        </p:style>
-        <p:txBody>
-          <a:bodyPr rtlCol="0" anchor="ctr"/>
-          <a:lstStyle/>
-          <a:p>
-            <a:pPr algn="ctr"/>
-            <a:endParaRPr lang="en-US">
-              <a:solidFill>
-                <a:schemeClr val="tx1">
-                  <a:lumMod val="75000"/>
-                  <a:lumOff val="25000"/>
-                </a:schemeClr>
-              </a:solidFill>
-            </a:endParaRPr>
-          </a:p>
-        </p:txBody>
-      </p:sp>
-      <p:pic>
-        <p:nvPicPr>
-          <p:cNvPr id="8" name="Picture 7">
-            <a:extLst>
-              <a:ext uri="{FF2B5EF4-FFF2-40B4-BE49-F238E27FC236}">
-                <a16:creationId xmlns:a16="http://schemas.microsoft.com/office/drawing/2014/main" id="{30CC825A-3191-EE57-0FF2-E8F8AE02E227}"/>
-              </a:ext>
-            </a:extLst>
-          </p:cNvPr>
-          <p:cNvPicPr>
-            <a:picLocks noChangeAspect="1"/>
-          </p:cNvPicPr>
-          <p:nvPr/>
-        </p:nvPicPr>
-        <p:blipFill>
-          <a:blip r:embed="rId3"/>
-          <a:stretch>
-            <a:fillRect/>
-          </a:stretch>
-        </p:blipFill>
-        <p:spPr>
-          <a:xfrm>
-            <a:off x="1685794" y="415274"/>
-            <a:ext cx="4954983" cy="4947331"/>
-          </a:xfrm>
-          <a:prstGeom prst="rect">
-            <a:avLst/>
-          </a:prstGeom>
-          <a:solidFill>
-            <a:srgbClr val="A20000"/>
-          </a:solidFill>
-        </p:spPr>
-      </p:pic>
-      <p:sp>
-        <p:nvSpPr>
-          <p:cNvPr id="2" name="Title 1">
-            <a:extLst>
-              <a:ext uri="{FF2B5EF4-FFF2-40B4-BE49-F238E27FC236}">
-                <a16:creationId xmlns:a16="http://schemas.microsoft.com/office/drawing/2014/main" id="{E7217E81-ED03-849E-C61D-F5A86E7B15BA}"/>
-              </a:ext>
-            </a:extLst>
-          </p:cNvPr>
-          <p:cNvSpPr>
-            <a:spLocks noGrp="1"/>
-          </p:cNvSpPr>
-          <p:nvPr>
-            <p:ph type="title"/>
-          </p:nvPr>
-        </p:nvSpPr>
-        <p:spPr>
-          <a:xfrm>
-            <a:off x="1307468" y="5648551"/>
-            <a:ext cx="3384376" cy="720080"/>
-          </a:xfrm>
-        </p:spPr>
-        <p:txBody>
-          <a:bodyPr vert="horz" lIns="91440" tIns="45720" rIns="91440" bIns="45720" rtlCol="0" anchor="ctr">
-            <a:normAutofit/>
-          </a:bodyPr>
-          <a:lstStyle/>
-          <a:p>
-            <a:r>
-              <a:rPr lang="en-US" sz="1600" i="1">
-                <a:solidFill>
-                  <a:schemeClr val="tx1">
-                    <a:lumMod val="65000"/>
-                    <a:lumOff val="35000"/>
-                  </a:schemeClr>
-                </a:solidFill>
-                <a:latin typeface="Eras Demi ITC" panose="020B0805030504020804" pitchFamily="34" charset="0"/>
-              </a:rPr>
-              <a:t>MDD400 Functional Domains</a:t>
-            </a:r>
-          </a:p>
-        </p:txBody>
-      </p:sp>
-      <p:sp>
-        <p:nvSpPr>
-          <p:cNvPr id="26" name="TextBox 25">
-            <a:extLst>
-              <a:ext uri="{FF2B5EF4-FFF2-40B4-BE49-F238E27FC236}">
-                <a16:creationId xmlns:a16="http://schemas.microsoft.com/office/drawing/2014/main" id="{750EA29D-C1F2-C859-0EAF-A0A57E36C3C1}"/>
-              </a:ext>
-            </a:extLst>
-          </p:cNvPr>
-          <p:cNvSpPr txBox="1"/>
-          <p:nvPr/>
-        </p:nvSpPr>
-        <p:spPr>
-          <a:xfrm rot="16200000">
-            <a:off x="3263039" y="837992"/>
-            <a:ext cx="784189" cy="230832"/>
-          </a:xfrm>
-          <a:prstGeom prst="rect">
-            <a:avLst/>
-          </a:prstGeom>
-          <a:noFill/>
-        </p:spPr>
-        <p:txBody>
-          <a:bodyPr wrap="none" rtlCol="0">
-            <a:spAutoFit/>
-          </a:bodyPr>
-          <a:lstStyle/>
-          <a:p>
-            <a:pPr algn="ctr"/>
-            <a:r>
-              <a:rPr lang="en-US" sz="900" b="1">
-                <a:solidFill>
-                  <a:srgbClr val="FFFF00"/>
-                </a:solidFill>
-              </a:rPr>
-              <a:t>CM Chokes</a:t>
-            </a:r>
-          </a:p>
-        </p:txBody>
-      </p:sp>
-      <p:sp>
-        <p:nvSpPr>
-          <p:cNvPr id="27" name="TextBox 26">
-            <a:extLst>
-              <a:ext uri="{FF2B5EF4-FFF2-40B4-BE49-F238E27FC236}">
-                <a16:creationId xmlns:a16="http://schemas.microsoft.com/office/drawing/2014/main" id="{C7775AF3-E1FC-B231-255F-995DFE9BED29}"/>
-              </a:ext>
-            </a:extLst>
-          </p:cNvPr>
-          <p:cNvSpPr txBox="1"/>
-          <p:nvPr/>
-        </p:nvSpPr>
-        <p:spPr>
-          <a:xfrm>
-            <a:off x="5518971" y="2393008"/>
-            <a:ext cx="947696" cy="230832"/>
-          </a:xfrm>
-          <a:prstGeom prst="rect">
-            <a:avLst/>
-          </a:prstGeom>
-          <a:noFill/>
-        </p:spPr>
-        <p:txBody>
-          <a:bodyPr wrap="none" rtlCol="0">
-            <a:spAutoFit/>
-          </a:bodyPr>
-          <a:lstStyle/>
-          <a:p>
-            <a:pPr algn="ctr"/>
-            <a:r>
-              <a:rPr lang="en-US" sz="900" b="1">
-                <a:solidFill>
-                  <a:srgbClr val="FFFF00"/>
-                </a:solidFill>
-              </a:rPr>
-              <a:t>Opto-isolators</a:t>
-            </a:r>
-          </a:p>
-        </p:txBody>
-      </p:sp>
-      <p:sp>
-        <p:nvSpPr>
-          <p:cNvPr id="9" name="TextBox 8">
-            <a:extLst>
-              <a:ext uri="{FF2B5EF4-FFF2-40B4-BE49-F238E27FC236}">
-                <a16:creationId xmlns:a16="http://schemas.microsoft.com/office/drawing/2014/main" id="{227ED8AB-371F-F6EF-D4B5-197FA235DD09}"/>
-              </a:ext>
-            </a:extLst>
-          </p:cNvPr>
-          <p:cNvSpPr txBox="1"/>
-          <p:nvPr/>
-        </p:nvSpPr>
-        <p:spPr>
-          <a:xfrm>
-            <a:off x="2135560" y="1412776"/>
-            <a:ext cx="593432" cy="230832"/>
-          </a:xfrm>
-          <a:prstGeom prst="rect">
-            <a:avLst/>
-          </a:prstGeom>
-          <a:noFill/>
-        </p:spPr>
-        <p:txBody>
-          <a:bodyPr wrap="none" rtlCol="0">
-            <a:spAutoFit/>
-          </a:bodyPr>
-          <a:lstStyle/>
-          <a:p>
-            <a:pPr algn="ctr"/>
-            <a:r>
-              <a:rPr lang="en-US" sz="900" b="1">
-                <a:solidFill>
-                  <a:srgbClr val="FFFF00"/>
-                </a:solidFill>
-              </a:rPr>
-              <a:t>Ferrites</a:t>
-            </a:r>
-          </a:p>
-        </p:txBody>
-      </p:sp>
-      <p:sp>
-        <p:nvSpPr>
-          <p:cNvPr id="10" name="Rectangle 9">
-            <a:extLst>
-              <a:ext uri="{FF2B5EF4-FFF2-40B4-BE49-F238E27FC236}">
-                <a16:creationId xmlns:a16="http://schemas.microsoft.com/office/drawing/2014/main" id="{8C0084E9-EDFC-EAFE-DE90-139AA59DBE24}"/>
-              </a:ext>
-            </a:extLst>
-          </p:cNvPr>
-          <p:cNvSpPr/>
-          <p:nvPr/>
-        </p:nvSpPr>
-        <p:spPr>
-          <a:xfrm>
-            <a:off x="1893633" y="1684052"/>
-            <a:ext cx="1574076" cy="2212999"/>
-          </a:xfrm>
-          <a:prstGeom prst="rect">
-            <a:avLst/>
-          </a:prstGeom>
-          <a:solidFill>
-            <a:srgbClr val="A20000">
-              <a:alpha val="40000"/>
-            </a:srgbClr>
-          </a:solidFill>
-          <a:ln w="19050">
-            <a:solidFill>
-              <a:srgbClr val="A20000"/>
-            </a:solidFill>
-          </a:ln>
-        </p:spPr>
-        <p:style>
-          <a:lnRef idx="2">
-            <a:schemeClr val="accent1">
-              <a:shade val="15000"/>
-            </a:schemeClr>
-          </a:lnRef>
-          <a:fillRef idx="1">
-            <a:schemeClr val="accent1"/>
-          </a:fillRef>
-          <a:effectRef idx="0">
-            <a:schemeClr val="accent1"/>
-          </a:effectRef>
-          <a:fontRef idx="minor">
-            <a:schemeClr val="lt1"/>
-          </a:fontRef>
-        </p:style>
-        <p:txBody>
-          <a:bodyPr rtlCol="0" anchor="ctr"/>
-          <a:lstStyle/>
-          <a:p>
-            <a:pPr algn="ctr"/>
-            <a:endParaRPr lang="en-US">
-              <a:solidFill>
-                <a:schemeClr val="tx1">
-                  <a:lumMod val="75000"/>
-                  <a:lumOff val="25000"/>
-                </a:schemeClr>
-              </a:solidFill>
-              <a:highlight>
-                <a:srgbClr val="A20000"/>
-              </a:highlight>
-            </a:endParaRPr>
-          </a:p>
-        </p:txBody>
-      </p:sp>
-      <p:sp>
-        <p:nvSpPr>
-          <p:cNvPr id="12" name="Rectangle 11">
-            <a:extLst>
-              <a:ext uri="{FF2B5EF4-FFF2-40B4-BE49-F238E27FC236}">
-                <a16:creationId xmlns:a16="http://schemas.microsoft.com/office/drawing/2014/main" id="{D8AB07CB-46C9-4097-77A1-7726323E6ABA}"/>
-              </a:ext>
-            </a:extLst>
-          </p:cNvPr>
-          <p:cNvSpPr/>
-          <p:nvPr/>
-        </p:nvSpPr>
-        <p:spPr>
-          <a:xfrm>
-            <a:off x="1887389" y="619639"/>
-            <a:ext cx="1574076" cy="721128"/>
-          </a:xfrm>
-          <a:prstGeom prst="rect">
-            <a:avLst/>
-          </a:prstGeom>
-          <a:solidFill>
-            <a:srgbClr val="084F6A">
-              <a:alpha val="40000"/>
-            </a:srgbClr>
-          </a:solidFill>
-          <a:ln w="19050">
-            <a:solidFill>
-              <a:schemeClr val="accent4">
-                <a:lumMod val="50000"/>
-              </a:schemeClr>
-            </a:solidFill>
-          </a:ln>
-        </p:spPr>
-        <p:style>
-          <a:lnRef idx="2">
-            <a:schemeClr val="accent1">
-              <a:shade val="15000"/>
-            </a:schemeClr>
-          </a:lnRef>
-          <a:fillRef idx="1">
-            <a:schemeClr val="accent1"/>
-          </a:fillRef>
-          <a:effectRef idx="0">
-            <a:schemeClr val="accent1"/>
-          </a:effectRef>
-          <a:fontRef idx="minor">
-            <a:schemeClr val="lt1"/>
-          </a:fontRef>
-        </p:style>
-        <p:txBody>
-          <a:bodyPr rtlCol="0" anchor="ctr"/>
-          <a:lstStyle/>
-          <a:p>
-            <a:pPr algn="ctr"/>
-            <a:endParaRPr lang="en-US">
-              <a:solidFill>
-                <a:schemeClr val="tx1">
-                  <a:lumMod val="75000"/>
-                  <a:lumOff val="25000"/>
-                </a:schemeClr>
-              </a:solidFill>
-            </a:endParaRPr>
-          </a:p>
-        </p:txBody>
-      </p:sp>
-      <p:sp>
-        <p:nvSpPr>
-          <p:cNvPr id="14" name="Rectangle 13">
-            <a:extLst>
-              <a:ext uri="{FF2B5EF4-FFF2-40B4-BE49-F238E27FC236}">
-                <a16:creationId xmlns:a16="http://schemas.microsoft.com/office/drawing/2014/main" id="{B846D954-C391-5DC3-3975-7854A23586B1}"/>
-              </a:ext>
-            </a:extLst>
-          </p:cNvPr>
-          <p:cNvSpPr/>
-          <p:nvPr/>
-        </p:nvSpPr>
-        <p:spPr>
-          <a:xfrm>
-            <a:off x="3898305" y="619639"/>
-            <a:ext cx="2521732" cy="1771874"/>
-          </a:xfrm>
-          <a:prstGeom prst="rect">
-            <a:avLst/>
-          </a:prstGeom>
-          <a:solidFill>
-            <a:schemeClr val="bg2">
-              <a:alpha val="40000"/>
-            </a:schemeClr>
-          </a:solidFill>
-          <a:ln w="19050">
-            <a:solidFill>
-              <a:schemeClr val="bg1">
-                <a:lumMod val="95000"/>
-              </a:schemeClr>
-            </a:solidFill>
-          </a:ln>
-        </p:spPr>
-        <p:style>
-          <a:lnRef idx="2">
-            <a:schemeClr val="accent1">
-              <a:shade val="15000"/>
-            </a:schemeClr>
-          </a:lnRef>
-          <a:fillRef idx="1">
-            <a:schemeClr val="accent1"/>
-          </a:fillRef>
-          <a:effectRef idx="0">
-            <a:schemeClr val="accent1"/>
-          </a:effectRef>
-          <a:fontRef idx="minor">
-            <a:schemeClr val="lt1"/>
-          </a:fontRef>
-        </p:style>
-        <p:txBody>
-          <a:bodyPr rtlCol="0" anchor="ctr"/>
-          <a:lstStyle/>
-          <a:p>
-            <a:pPr algn="ctr"/>
-            <a:endParaRPr lang="en-US">
-              <a:solidFill>
-                <a:schemeClr val="tx1">
-                  <a:lumMod val="75000"/>
-                  <a:lumOff val="25000"/>
-                </a:schemeClr>
-              </a:solidFill>
-            </a:endParaRPr>
-          </a:p>
-        </p:txBody>
-      </p:sp>
-      <p:sp>
-        <p:nvSpPr>
-          <p:cNvPr id="15" name="Rectangle 14">
-            <a:extLst>
-              <a:ext uri="{FF2B5EF4-FFF2-40B4-BE49-F238E27FC236}">
-                <a16:creationId xmlns:a16="http://schemas.microsoft.com/office/drawing/2014/main" id="{3A7ED21A-2DBC-B28D-FDC5-62CDDC02F5AB}"/>
-              </a:ext>
-            </a:extLst>
-          </p:cNvPr>
-          <p:cNvSpPr/>
-          <p:nvPr/>
-        </p:nvSpPr>
-        <p:spPr>
-          <a:xfrm>
-            <a:off x="5452643" y="2628463"/>
-            <a:ext cx="1014024" cy="2096681"/>
-          </a:xfrm>
-          <a:prstGeom prst="rect">
-            <a:avLst/>
-          </a:prstGeom>
-          <a:solidFill>
-            <a:srgbClr val="11838F">
-              <a:alpha val="50196"/>
-            </a:srgbClr>
-          </a:solidFill>
-          <a:ln w="19050">
-            <a:solidFill>
-              <a:srgbClr val="11838F"/>
-            </a:solidFill>
-          </a:ln>
-        </p:spPr>
-        <p:style>
-          <a:lnRef idx="2">
-            <a:schemeClr val="accent1">
-              <a:shade val="15000"/>
-            </a:schemeClr>
-          </a:lnRef>
-          <a:fillRef idx="1">
-            <a:schemeClr val="accent1"/>
-          </a:fillRef>
-          <a:effectRef idx="0">
-            <a:schemeClr val="accent1"/>
-          </a:effectRef>
-          <a:fontRef idx="minor">
-            <a:schemeClr val="lt1"/>
-          </a:fontRef>
-        </p:style>
-        <p:txBody>
-          <a:bodyPr rtlCol="0" anchor="ctr"/>
-          <a:lstStyle/>
-          <a:p>
-            <a:pPr algn="ctr"/>
-            <a:endParaRPr lang="en-US">
-              <a:solidFill>
-                <a:schemeClr val="tx1">
-                  <a:lumMod val="75000"/>
-                  <a:lumOff val="25000"/>
-                </a:schemeClr>
-              </a:solidFill>
-            </a:endParaRPr>
-          </a:p>
-        </p:txBody>
-      </p:sp>
-      <p:sp>
-        <p:nvSpPr>
-          <p:cNvPr id="21" name="TextBox 20">
-            <a:extLst>
-              <a:ext uri="{FF2B5EF4-FFF2-40B4-BE49-F238E27FC236}">
-                <a16:creationId xmlns:a16="http://schemas.microsoft.com/office/drawing/2014/main" id="{1D6A5E16-390E-11D2-44F8-0ED5AF71F5E6}"/>
-              </a:ext>
-            </a:extLst>
-          </p:cNvPr>
-          <p:cNvSpPr txBox="1"/>
-          <p:nvPr/>
-        </p:nvSpPr>
-        <p:spPr>
-          <a:xfrm>
-            <a:off x="1786945" y="842460"/>
-            <a:ext cx="1767860" cy="230832"/>
-          </a:xfrm>
-          <a:prstGeom prst="rect">
-            <a:avLst/>
-          </a:prstGeom>
-          <a:noFill/>
-        </p:spPr>
-        <p:txBody>
-          <a:bodyPr wrap="square" rtlCol="0">
-            <a:spAutoFit/>
-          </a:bodyPr>
-          <a:lstStyle/>
-          <a:p>
-            <a:pPr algn="ctr"/>
-            <a:r>
-              <a:rPr lang="en-US" sz="900" b="1" i="1">
-                <a:solidFill>
-                  <a:schemeClr val="bg1"/>
-                </a:solidFill>
-              </a:rPr>
-              <a:t>SMPS</a:t>
-            </a:r>
-            <a:r>
-              <a:rPr lang="en-US" sz="900" b="1">
-                <a:solidFill>
-                  <a:schemeClr val="bg1"/>
-                </a:solidFill>
-              </a:rPr>
-              <a:t> Domain</a:t>
-            </a:r>
-            <a:endParaRPr lang="en-US" sz="900">
-              <a:solidFill>
-                <a:schemeClr val="bg1"/>
-              </a:solidFill>
-            </a:endParaRPr>
-          </a:p>
-        </p:txBody>
-      </p:sp>
-      <p:sp>
-        <p:nvSpPr>
-          <p:cNvPr id="22" name="TextBox 21">
-            <a:extLst>
-              <a:ext uri="{FF2B5EF4-FFF2-40B4-BE49-F238E27FC236}">
-                <a16:creationId xmlns:a16="http://schemas.microsoft.com/office/drawing/2014/main" id="{B15923FB-8A5D-3D8A-4CF0-9B6F6411A519}"/>
-              </a:ext>
-            </a:extLst>
-          </p:cNvPr>
-          <p:cNvSpPr txBox="1"/>
-          <p:nvPr/>
-        </p:nvSpPr>
-        <p:spPr>
-          <a:xfrm>
-            <a:off x="2017504" y="2354831"/>
-            <a:ext cx="1296144" cy="230832"/>
-          </a:xfrm>
-          <a:prstGeom prst="rect">
-            <a:avLst/>
-          </a:prstGeom>
-          <a:noFill/>
-        </p:spPr>
-        <p:txBody>
-          <a:bodyPr wrap="square" rtlCol="0">
-            <a:spAutoFit/>
-          </a:bodyPr>
-          <a:lstStyle/>
-          <a:p>
-            <a:pPr algn="ctr"/>
-            <a:r>
-              <a:rPr lang="en-US" sz="900" b="1">
-                <a:solidFill>
-                  <a:schemeClr val="bg1"/>
-                </a:solidFill>
-              </a:rPr>
-              <a:t>CAN Domain</a:t>
-            </a:r>
-            <a:endParaRPr lang="en-US" sz="900">
-              <a:solidFill>
-                <a:schemeClr val="bg1"/>
-              </a:solidFill>
-            </a:endParaRPr>
-          </a:p>
-        </p:txBody>
-      </p:sp>
-      <p:sp>
-        <p:nvSpPr>
-          <p:cNvPr id="24" name="TextBox 23">
-            <a:extLst>
-              <a:ext uri="{FF2B5EF4-FFF2-40B4-BE49-F238E27FC236}">
-                <a16:creationId xmlns:a16="http://schemas.microsoft.com/office/drawing/2014/main" id="{351CCCD8-904E-77D0-57E3-2308BBEBE4A1}"/>
-              </a:ext>
-            </a:extLst>
-          </p:cNvPr>
-          <p:cNvSpPr txBox="1"/>
-          <p:nvPr/>
-        </p:nvSpPr>
-        <p:spPr>
-          <a:xfrm>
-            <a:off x="4217095" y="1282242"/>
-            <a:ext cx="1980612" cy="230832"/>
-          </a:xfrm>
-          <a:prstGeom prst="rect">
-            <a:avLst/>
-          </a:prstGeom>
-          <a:noFill/>
-        </p:spPr>
-        <p:txBody>
-          <a:bodyPr wrap="square" rtlCol="0">
-            <a:spAutoFit/>
-          </a:bodyPr>
-          <a:lstStyle/>
-          <a:p>
-            <a:pPr algn="ctr"/>
-            <a:r>
-              <a:rPr lang="en-US" sz="900" b="1" i="1">
-                <a:solidFill>
-                  <a:schemeClr val="tx1">
-                    <a:lumMod val="85000"/>
-                    <a:lumOff val="15000"/>
-                  </a:schemeClr>
-                </a:solidFill>
-              </a:rPr>
-              <a:t>DIGITAL</a:t>
-            </a:r>
-            <a:r>
-              <a:rPr lang="en-US" sz="900" b="1">
-                <a:solidFill>
-                  <a:schemeClr val="tx1">
-                    <a:lumMod val="85000"/>
-                    <a:lumOff val="15000"/>
-                  </a:schemeClr>
-                </a:solidFill>
-              </a:rPr>
-              <a:t> Domain</a:t>
-            </a:r>
-            <a:endParaRPr lang="en-US" sz="900">
-              <a:solidFill>
-                <a:schemeClr val="tx1">
-                  <a:lumMod val="85000"/>
-                  <a:lumOff val="15000"/>
-                </a:schemeClr>
-              </a:solidFill>
-            </a:endParaRPr>
-          </a:p>
-        </p:txBody>
-      </p:sp>
-      <p:sp>
-        <p:nvSpPr>
-          <p:cNvPr id="25" name="TextBox 24">
-            <a:extLst>
-              <a:ext uri="{FF2B5EF4-FFF2-40B4-BE49-F238E27FC236}">
-                <a16:creationId xmlns:a16="http://schemas.microsoft.com/office/drawing/2014/main" id="{70ECF8EC-4BEB-A1A2-9D17-9F7F0C5FE3C0}"/>
-              </a:ext>
-            </a:extLst>
-          </p:cNvPr>
-          <p:cNvSpPr txBox="1"/>
-          <p:nvPr/>
-        </p:nvSpPr>
-        <p:spPr>
-          <a:xfrm>
-            <a:off x="5452643" y="3489324"/>
-            <a:ext cx="1054093" cy="369332"/>
-          </a:xfrm>
-          <a:prstGeom prst="rect">
-            <a:avLst/>
-          </a:prstGeom>
-          <a:noFill/>
-        </p:spPr>
-        <p:txBody>
-          <a:bodyPr wrap="square" rtlCol="0">
-            <a:spAutoFit/>
-          </a:bodyPr>
-          <a:lstStyle/>
-          <a:p>
-            <a:pPr algn="ctr"/>
-            <a:r>
-              <a:rPr lang="en-US" sz="900" b="1" i="1">
-                <a:solidFill>
-                  <a:schemeClr val="bg1"/>
-                </a:solidFill>
-              </a:rPr>
-              <a:t>LEGACY IO</a:t>
-            </a:r>
-            <a:r>
-              <a:rPr lang="en-US" sz="900" b="1">
-                <a:solidFill>
-                  <a:schemeClr val="bg1"/>
-                </a:solidFill>
-              </a:rPr>
-              <a:t> Domain</a:t>
-            </a:r>
-            <a:endParaRPr lang="en-US" sz="900">
-              <a:solidFill>
-                <a:schemeClr val="bg1"/>
-              </a:solidFill>
-            </a:endParaRPr>
-          </a:p>
-        </p:txBody>
-      </p:sp>
-    </p:spTree>
-    <p:extLst>
-      <p:ext uri="{BB962C8B-B14F-4D97-AF65-F5344CB8AC3E}">
-        <p14:creationId xmlns:p14="http://schemas.microsoft.com/office/powerpoint/2010/main" val="1425979937"/>
       </p:ext>
     </p:extLst>
   </p:cSld>

</xml_diff>